<commit_message>
Enrich work report: add 9 bullet points from git history, tighten card spacing
Co-Authored-By: Claude Opus 4.6 <noreply@anthropic.com>
Claude-Session: https://claude.ai/code/session_015nf3knxVoVVLYAWgtjzRg9
</commit_message>
<xml_diff>
--- a/2026年8-9月工作汇报.pptx
+++ b/2026年8-9月工作汇报.pptx
@@ -3887,11 +3887,11 @@
         <p:spPr>
           <a:xfrm>
             <a:off x="548640" y="2916936"/>
-            <a:ext cx="4221328" cy="512064"/>
+            <a:ext cx="4221328" cy="448056"/>
           </a:xfrm>
           <a:prstGeom prst="roundRect">
             <a:avLst>
-              <a:gd name="adj" fmla="val 8929"/>
+              <a:gd name="adj" fmla="val 10204"/>
             </a:avLst>
           </a:prstGeom>
           <a:solidFill>
@@ -3914,7 +3914,7 @@
         <p:spPr>
           <a:xfrm>
             <a:off x="566928" y="2962656"/>
-            <a:ext cx="32004" cy="420624"/>
+            <a:ext cx="32004" cy="356616"/>
           </a:xfrm>
           <a:prstGeom prst="rect">
             <a:avLst/>
@@ -3933,7 +3933,7 @@
         </p:nvSpPr>
         <p:spPr>
           <a:xfrm>
-            <a:off x="694944" y="3131820"/>
+            <a:off x="694944" y="3104388"/>
             <a:ext cx="54864" cy="54864"/>
           </a:xfrm>
           <a:prstGeom prst="ellipse">
@@ -3953,8 +3953,8 @@
         </p:nvSpPr>
         <p:spPr>
           <a:xfrm>
-            <a:off x="859536" y="3026664"/>
-            <a:ext cx="3800704" cy="292608"/>
+            <a:off x="859536" y="2999232"/>
+            <a:ext cx="3800704" cy="283464"/>
           </a:xfrm>
           <a:prstGeom prst="rect">
             <a:avLst/>
@@ -3968,12 +3968,12 @@
           <a:p>
             <a:pPr indent="0" marL="0">
               <a:lnSpc>
-                <a:spcPts val="1650"/>
+                <a:spcPts val="1600"/>
               </a:lnSpc>
               <a:buNone/>
             </a:pPr>
             <a:r>
-              <a:rPr lang="en-US" sz="1200" dirty="0">
+              <a:rPr lang="en-US" sz="1150" dirty="0">
                 <a:solidFill>
                   <a:srgbClr val="363636"/>
                 </a:solidFill>
@@ -3983,7 +3983,7 @@
               </a:rPr>
               <a:t>自动驾驶评估台新增【AI 法案高风险合规】模块</a:t>
             </a:r>
-            <a:endParaRPr lang="en-US" sz="1200" dirty="0"/>
+            <a:endParaRPr lang="en-US" sz="1150" dirty="0"/>
           </a:p>
         </p:txBody>
       </p:sp>
@@ -3995,12 +3995,12 @@
         </p:nvSpPr>
         <p:spPr>
           <a:xfrm>
-            <a:off x="548640" y="3557016"/>
-            <a:ext cx="4221328" cy="731520"/>
+            <a:off x="548640" y="3465576"/>
+            <a:ext cx="4221328" cy="658368"/>
           </a:xfrm>
           <a:prstGeom prst="roundRect">
             <a:avLst>
-              <a:gd name="adj" fmla="val 6250"/>
+              <a:gd name="adj" fmla="val 6944"/>
             </a:avLst>
           </a:prstGeom>
           <a:solidFill>
@@ -4022,8 +4022,8 @@
         </p:nvSpPr>
         <p:spPr>
           <a:xfrm>
-            <a:off x="566928" y="3602736"/>
-            <a:ext cx="32004" cy="640080"/>
+            <a:off x="566928" y="3511296"/>
+            <a:ext cx="32004" cy="566928"/>
           </a:xfrm>
           <a:prstGeom prst="rect">
             <a:avLst/>
@@ -4042,7 +4042,7 @@
         </p:nvSpPr>
         <p:spPr>
           <a:xfrm>
-            <a:off x="694944" y="3771900"/>
+            <a:off x="694944" y="3653028"/>
             <a:ext cx="54864" cy="54864"/>
           </a:xfrm>
           <a:prstGeom prst="ellipse">
@@ -4062,8 +4062,8 @@
         </p:nvSpPr>
         <p:spPr>
           <a:xfrm>
-            <a:off x="859536" y="3666744"/>
-            <a:ext cx="3800704" cy="512064"/>
+            <a:off x="859536" y="3547872"/>
+            <a:ext cx="3800704" cy="493776"/>
           </a:xfrm>
           <a:prstGeom prst="rect">
             <a:avLst/>
@@ -4077,12 +4077,12 @@
           <a:p>
             <a:pPr indent="0" marL="0">
               <a:lnSpc>
-                <a:spcPts val="1650"/>
+                <a:spcPts val="1600"/>
               </a:lnSpc>
               <a:buNone/>
             </a:pPr>
             <a:r>
-              <a:rPr lang="en-US" sz="1200" dirty="0">
+              <a:rPr lang="en-US" sz="1150" dirty="0">
                 <a:solidFill>
                   <a:srgbClr val="363636"/>
                 </a:solidFill>
@@ -4092,7 +4092,7 @@
               </a:rPr>
               <a:t>电气与电动化评估台新增【电池法规 (EU) 2026/1738 循环设计与报废车管理】模块</a:t>
             </a:r>
-            <a:endParaRPr lang="en-US" sz="1200" dirty="0"/>
+            <a:endParaRPr lang="en-US" sz="1150" dirty="0"/>
           </a:p>
         </p:txBody>
       </p:sp>
@@ -4104,12 +4104,12 @@
         </p:nvSpPr>
         <p:spPr>
           <a:xfrm>
-            <a:off x="548640" y="4416552"/>
-            <a:ext cx="4221328" cy="731520"/>
+            <a:off x="548640" y="4224528"/>
+            <a:ext cx="4221328" cy="448056"/>
           </a:xfrm>
           <a:prstGeom prst="roundRect">
             <a:avLst>
-              <a:gd name="adj" fmla="val 6250"/>
+              <a:gd name="adj" fmla="val 10204"/>
             </a:avLst>
           </a:prstGeom>
           <a:solidFill>
@@ -4131,8 +4131,8 @@
         </p:nvSpPr>
         <p:spPr>
           <a:xfrm>
-            <a:off x="566928" y="4462272"/>
-            <a:ext cx="32004" cy="640080"/>
+            <a:off x="566928" y="4270248"/>
+            <a:ext cx="32004" cy="356616"/>
           </a:xfrm>
           <a:prstGeom prst="rect">
             <a:avLst/>
@@ -4151,7 +4151,7 @@
         </p:nvSpPr>
         <p:spPr>
           <a:xfrm>
-            <a:off x="694944" y="4631436"/>
+            <a:off x="694944" y="4411980"/>
             <a:ext cx="54864" cy="54864"/>
           </a:xfrm>
           <a:prstGeom prst="ellipse">
@@ -4171,8 +4171,8 @@
         </p:nvSpPr>
         <p:spPr>
           <a:xfrm>
-            <a:off x="859536" y="4526280"/>
-            <a:ext cx="3800704" cy="512064"/>
+            <a:off x="859536" y="4306824"/>
+            <a:ext cx="3800704" cy="283464"/>
           </a:xfrm>
           <a:prstGeom prst="rect">
             <a:avLst/>
@@ -4186,12 +4186,12 @@
           <a:p>
             <a:pPr indent="0" marL="0">
               <a:lnSpc>
-                <a:spcPts val="1650"/>
+                <a:spcPts val="1600"/>
               </a:lnSpc>
               <a:buNone/>
             </a:pPr>
             <a:r>
-              <a:rPr lang="en-US" sz="1200" dirty="0">
+              <a:rPr lang="en-US" sz="1150" dirty="0">
                 <a:solidFill>
                   <a:srgbClr val="363636"/>
                 </a:solidFill>
@@ -4201,7 +4201,7 @@
               </a:rPr>
               <a:t>E-mark 工具两轮全面排查:一轮改写生硬措辞,二轮排查交互逻辑与数据准确性问题</a:t>
             </a:r>
-            <a:endParaRPr lang="en-US" sz="1200" dirty="0"/>
+            <a:endParaRPr lang="en-US" sz="1150" dirty="0"/>
           </a:p>
         </p:txBody>
       </p:sp>
@@ -4213,12 +4213,12 @@
         </p:nvSpPr>
         <p:spPr>
           <a:xfrm>
-            <a:off x="548640" y="5276088"/>
-            <a:ext cx="4221328" cy="512064"/>
+            <a:off x="548640" y="4773168"/>
+            <a:ext cx="4221328" cy="448056"/>
           </a:xfrm>
           <a:prstGeom prst="roundRect">
             <a:avLst>
-              <a:gd name="adj" fmla="val 8929"/>
+              <a:gd name="adj" fmla="val 10204"/>
             </a:avLst>
           </a:prstGeom>
           <a:solidFill>
@@ -4240,8 +4240,8 @@
         </p:nvSpPr>
         <p:spPr>
           <a:xfrm>
-            <a:off x="566928" y="5321808"/>
-            <a:ext cx="32004" cy="420624"/>
+            <a:off x="566928" y="4818888"/>
+            <a:ext cx="32004" cy="356616"/>
           </a:xfrm>
           <a:prstGeom prst="rect">
             <a:avLst/>
@@ -4260,7 +4260,7 @@
         </p:nvSpPr>
         <p:spPr>
           <a:xfrm>
-            <a:off x="694944" y="5490972"/>
+            <a:off x="694944" y="4960620"/>
             <a:ext cx="54864" cy="54864"/>
           </a:xfrm>
           <a:prstGeom prst="ellipse">
@@ -4280,8 +4280,8 @@
         </p:nvSpPr>
         <p:spPr>
           <a:xfrm>
-            <a:off x="859536" y="5385816"/>
-            <a:ext cx="3800704" cy="292608"/>
+            <a:off x="859536" y="4855464"/>
+            <a:ext cx="3800704" cy="283464"/>
           </a:xfrm>
           <a:prstGeom prst="rect">
             <a:avLst/>
@@ -4295,12 +4295,12 @@
           <a:p>
             <a:pPr indent="0" marL="0">
               <a:lnSpc>
-                <a:spcPts val="1650"/>
+                <a:spcPts val="1600"/>
               </a:lnSpc>
               <a:buNone/>
             </a:pPr>
             <a:r>
-              <a:rPr lang="en-US" sz="1200" dirty="0">
+              <a:rPr lang="en-US" sz="1150" dirty="0">
                 <a:solidFill>
                   <a:srgbClr val="363636"/>
                 </a:solidFill>
@@ -4310,7 +4310,7 @@
               </a:rPr>
               <a:t>认证金字塔 B/C 档 16 国数据系统性复核与纠错(拉美/北非/东非/独联体)</a:t>
             </a:r>
-            <a:endParaRPr lang="en-US" sz="1200" dirty="0"/>
+            <a:endParaRPr lang="en-US" sz="1150" dirty="0"/>
           </a:p>
         </p:txBody>
       </p:sp>
@@ -4322,12 +4322,12 @@
         </p:nvSpPr>
         <p:spPr>
           <a:xfrm>
-            <a:off x="548640" y="5916168"/>
-            <a:ext cx="4221328" cy="512064"/>
+            <a:off x="548640" y="5321808"/>
+            <a:ext cx="4221328" cy="448056"/>
           </a:xfrm>
           <a:prstGeom prst="roundRect">
             <a:avLst>
-              <a:gd name="adj" fmla="val 8929"/>
+              <a:gd name="adj" fmla="val 10204"/>
             </a:avLst>
           </a:prstGeom>
           <a:solidFill>
@@ -4349,8 +4349,8 @@
         </p:nvSpPr>
         <p:spPr>
           <a:xfrm>
-            <a:off x="566928" y="5961888"/>
-            <a:ext cx="32004" cy="420624"/>
+            <a:off x="566928" y="5367528"/>
+            <a:ext cx="32004" cy="356616"/>
           </a:xfrm>
           <a:prstGeom prst="rect">
             <a:avLst/>
@@ -4369,7 +4369,7 @@
         </p:nvSpPr>
         <p:spPr>
           <a:xfrm>
-            <a:off x="694944" y="6131052"/>
+            <a:off x="694944" y="5509260"/>
             <a:ext cx="54864" cy="54864"/>
           </a:xfrm>
           <a:prstGeom prst="ellipse">
@@ -4389,8 +4389,8 @@
         </p:nvSpPr>
         <p:spPr>
           <a:xfrm>
-            <a:off x="859536" y="6025896"/>
-            <a:ext cx="3800704" cy="292608"/>
+            <a:off x="859536" y="5404104"/>
+            <a:ext cx="3800704" cy="283464"/>
           </a:xfrm>
           <a:prstGeom prst="rect">
             <a:avLst/>
@@ -4404,12 +4404,12 @@
           <a:p>
             <a:pPr indent="0" marL="0">
               <a:lnSpc>
-                <a:spcPts val="1650"/>
+                <a:spcPts val="1600"/>
               </a:lnSpc>
               <a:buNone/>
             </a:pPr>
             <a:r>
-              <a:rPr lang="en-US" sz="1200" dirty="0">
+              <a:rPr lang="en-US" sz="1150" dirty="0">
                 <a:solidFill>
                   <a:srgbClr val="363636"/>
                 </a:solidFill>
@@ -4419,13 +4419,122 @@
               </a:rPr>
               <a:t>五个评估工具全部接入「一点通」平台法规链接</a:t>
             </a:r>
-            <a:endParaRPr lang="en-US" sz="1200" dirty="0"/>
+            <a:endParaRPr lang="en-US" sz="1150" dirty="0"/>
+          </a:p>
+        </p:txBody>
+      </p:sp>
+      <p:sp>
+        <p:nvSpPr>
+          <p:cNvPr id="28" name="Shape 25"/>
+          <p:cNvSpPr/>
+          <p:nvPr/>
+        </p:nvSpPr>
+        <p:spPr>
+          <a:xfrm>
+            <a:off x="548640" y="5870448"/>
+            <a:ext cx="4221328" cy="448056"/>
+          </a:xfrm>
+          <a:prstGeom prst="roundRect">
+            <a:avLst>
+              <a:gd name="adj" fmla="val 10204"/>
+            </a:avLst>
+          </a:prstGeom>
+          <a:solidFill>
+            <a:srgbClr val="FFFFFF"/>
+          </a:solidFill>
+          <a:ln w="9525">
+            <a:solidFill>
+              <a:srgbClr val="E8E8E8"/>
+            </a:solidFill>
+            <a:prstDash val="solid"/>
+          </a:ln>
+        </p:spPr>
+      </p:sp>
+      <p:sp>
+        <p:nvSpPr>
+          <p:cNvPr id="29" name="Shape 26"/>
+          <p:cNvSpPr/>
+          <p:nvPr/>
+        </p:nvSpPr>
+        <p:spPr>
+          <a:xfrm>
+            <a:off x="566928" y="5916168"/>
+            <a:ext cx="32004" cy="356616"/>
+          </a:xfrm>
+          <a:prstGeom prst="rect">
+            <a:avLst/>
+          </a:prstGeom>
+          <a:solidFill>
+            <a:srgbClr val="FF6600"/>
+          </a:solidFill>
+          <a:ln/>
+        </p:spPr>
+      </p:sp>
+      <p:sp>
+        <p:nvSpPr>
+          <p:cNvPr id="30" name="Shape 27"/>
+          <p:cNvSpPr/>
+          <p:nvPr/>
+        </p:nvSpPr>
+        <p:spPr>
+          <a:xfrm>
+            <a:off x="694944" y="6057900"/>
+            <a:ext cx="54864" cy="54864"/>
+          </a:xfrm>
+          <a:prstGeom prst="ellipse">
+            <a:avLst/>
+          </a:prstGeom>
+          <a:solidFill>
+            <a:srgbClr val="FF6600"/>
+          </a:solidFill>
+          <a:ln/>
+        </p:spPr>
+      </p:sp>
+      <p:sp>
+        <p:nvSpPr>
+          <p:cNvPr id="31" name="Text 28"/>
+          <p:cNvSpPr txBox="1"/>
+          <p:nvPr/>
+        </p:nvSpPr>
+        <p:spPr>
+          <a:xfrm>
+            <a:off x="859536" y="5952744"/>
+            <a:ext cx="3800704" cy="283464"/>
+          </a:xfrm>
+          <a:prstGeom prst="rect">
+            <a:avLst/>
+          </a:prstGeom>
+          <a:noFill/>
+          <a:ln/>
+        </p:spPr>
+        <p:txBody>
+          <a:bodyPr wrap="square" lIns="0" tIns="0" rIns="0" bIns="0" rtlCol="0" anchor="t"/>
+          <a:lstStyle/>
+          <a:p>
+            <a:pPr indent="0" marL="0">
+              <a:lnSpc>
+                <a:spcPts val="1600"/>
+              </a:lnSpc>
+              <a:buNone/>
+            </a:pPr>
+            <a:r>
+              <a:rPr lang="en-US" sz="1150" dirty="0">
+                <a:solidFill>
+                  <a:srgbClr val="363636"/>
+                </a:solidFill>
+                <a:latin typeface="Arial" pitchFamily="34" charset="0"/>
+                <a:ea typeface="Arial" pitchFamily="34" charset="-122"/>
+                <a:cs typeface="Arial" pitchFamily="34" charset="-120"/>
+              </a:rPr>
+              <a:t>电池护照合规自查组据欧盟官方指引扩充完善</a:t>
+            </a:r>
+            <a:endParaRPr lang="en-US" sz="1150" dirty="0"/>
           </a:p>
         </p:txBody>
       </p:sp>
       <p:pic>
         <p:nvPicPr>
-          <p:cNvPr id="28" name="Image 1" descr="/tmp/pptx_work/icons/calendar.png">    </p:cNvPr>
+          <p:cNvPr id="32" name="Image 1" descr="/tmp/pptx_work/icons/calendar.png">    </p:cNvPr>
           <p:cNvPicPr>
             <a:picLocks noChangeAspect="1"/>
           </p:cNvPicPr>
@@ -4449,7 +4558,7 @@
       </p:pic>
       <p:sp>
         <p:nvSpPr>
-          <p:cNvPr id="29" name="Text 25"/>
+          <p:cNvPr id="33" name="Text 29"/>
           <p:cNvSpPr txBox="1"/>
           <p:nvPr/>
         </p:nvSpPr>
@@ -4491,7 +4600,7 @@
       </p:sp>
       <p:sp>
         <p:nvSpPr>
-          <p:cNvPr id="30" name="Shape 26"/>
+          <p:cNvPr id="34" name="Shape 30"/>
           <p:cNvSpPr/>
           <p:nvPr/>
         </p:nvSpPr>
@@ -4514,18 +4623,18 @@
       </p:sp>
       <p:sp>
         <p:nvSpPr>
-          <p:cNvPr id="31" name="Shape 27"/>
+          <p:cNvPr id="35" name="Shape 31"/>
           <p:cNvSpPr/>
           <p:nvPr/>
         </p:nvSpPr>
         <p:spPr>
           <a:xfrm>
             <a:off x="5135728" y="2916936"/>
-            <a:ext cx="4221328" cy="512064"/>
+            <a:ext cx="4221328" cy="448056"/>
           </a:xfrm>
           <a:prstGeom prst="roundRect">
             <a:avLst>
-              <a:gd name="adj" fmla="val 8929"/>
+              <a:gd name="adj" fmla="val 10204"/>
             </a:avLst>
           </a:prstGeom>
           <a:solidFill>
@@ -4541,14 +4650,14 @@
       </p:sp>
       <p:sp>
         <p:nvSpPr>
-          <p:cNvPr id="32" name="Shape 28"/>
+          <p:cNvPr id="36" name="Shape 32"/>
           <p:cNvSpPr/>
           <p:nvPr/>
         </p:nvSpPr>
         <p:spPr>
           <a:xfrm>
             <a:off x="5154016" y="2962656"/>
-            <a:ext cx="32004" cy="420624"/>
+            <a:ext cx="32004" cy="356616"/>
           </a:xfrm>
           <a:prstGeom prst="rect">
             <a:avLst/>
@@ -4561,13 +4670,13 @@
       </p:sp>
       <p:sp>
         <p:nvSpPr>
-          <p:cNvPr id="33" name="Shape 29"/>
-          <p:cNvSpPr/>
-          <p:nvPr/>
-        </p:nvSpPr>
-        <p:spPr>
-          <a:xfrm>
-            <a:off x="5282032" y="3131820"/>
+          <p:cNvPr id="37" name="Shape 33"/>
+          <p:cNvSpPr/>
+          <p:nvPr/>
+        </p:nvSpPr>
+        <p:spPr>
+          <a:xfrm>
+            <a:off x="5282032" y="3104388"/>
             <a:ext cx="54864" cy="54864"/>
           </a:xfrm>
           <a:prstGeom prst="ellipse">
@@ -4581,14 +4690,14 @@
       </p:sp>
       <p:sp>
         <p:nvSpPr>
-          <p:cNvPr id="34" name="Text 30"/>
+          <p:cNvPr id="38" name="Text 34"/>
           <p:cNvSpPr txBox="1"/>
           <p:nvPr/>
         </p:nvSpPr>
         <p:spPr>
           <a:xfrm>
-            <a:off x="5446624" y="3026664"/>
-            <a:ext cx="3800704" cy="292608"/>
+            <a:off x="5446624" y="2999232"/>
+            <a:ext cx="3800704" cy="283464"/>
           </a:xfrm>
           <a:prstGeom prst="rect">
             <a:avLst/>
@@ -4602,12 +4711,12 @@
           <a:p>
             <a:pPr indent="0" marL="0">
               <a:lnSpc>
-                <a:spcPts val="1650"/>
+                <a:spcPts val="1600"/>
               </a:lnSpc>
               <a:buNone/>
             </a:pPr>
             <a:r>
-              <a:rPr lang="en-US" sz="1200" dirty="0">
+              <a:rPr lang="en-US" sz="1150" dirty="0">
                 <a:solidFill>
                   <a:srgbClr val="363636"/>
                 </a:solidFill>
@@ -4617,24 +4726,24 @@
               </a:rPr>
               <a:t>《全球及中国汽车法规标准月报》编制(7月刊)</a:t>
             </a:r>
-            <a:endParaRPr lang="en-US" sz="1200" dirty="0"/>
-          </a:p>
-        </p:txBody>
-      </p:sp>
-      <p:sp>
-        <p:nvSpPr>
-          <p:cNvPr id="35" name="Shape 31"/>
-          <p:cNvSpPr/>
-          <p:nvPr/>
-        </p:nvSpPr>
-        <p:spPr>
-          <a:xfrm>
-            <a:off x="5135728" y="3557016"/>
-            <a:ext cx="4221328" cy="731520"/>
+            <a:endParaRPr lang="en-US" sz="1150" dirty="0"/>
+          </a:p>
+        </p:txBody>
+      </p:sp>
+      <p:sp>
+        <p:nvSpPr>
+          <p:cNvPr id="39" name="Shape 35"/>
+          <p:cNvSpPr/>
+          <p:nvPr/>
+        </p:nvSpPr>
+        <p:spPr>
+          <a:xfrm>
+            <a:off x="5135728" y="3465576"/>
+            <a:ext cx="4221328" cy="448056"/>
           </a:xfrm>
           <a:prstGeom prst="roundRect">
             <a:avLst>
-              <a:gd name="adj" fmla="val 6250"/>
+              <a:gd name="adj" fmla="val 10204"/>
             </a:avLst>
           </a:prstGeom>
           <a:solidFill>
@@ -4650,14 +4759,14 @@
       </p:sp>
       <p:sp>
         <p:nvSpPr>
-          <p:cNvPr id="36" name="Shape 32"/>
-          <p:cNvSpPr/>
-          <p:nvPr/>
-        </p:nvSpPr>
-        <p:spPr>
-          <a:xfrm>
-            <a:off x="5154016" y="3602736"/>
-            <a:ext cx="32004" cy="640080"/>
+          <p:cNvPr id="40" name="Shape 36"/>
+          <p:cNvSpPr/>
+          <p:nvPr/>
+        </p:nvSpPr>
+        <p:spPr>
+          <a:xfrm>
+            <a:off x="5154016" y="3511296"/>
+            <a:ext cx="32004" cy="356616"/>
           </a:xfrm>
           <a:prstGeom prst="rect">
             <a:avLst/>
@@ -4670,13 +4779,13 @@
       </p:sp>
       <p:sp>
         <p:nvSpPr>
-          <p:cNvPr id="37" name="Shape 33"/>
-          <p:cNvSpPr/>
-          <p:nvPr/>
-        </p:nvSpPr>
-        <p:spPr>
-          <a:xfrm>
-            <a:off x="5282032" y="3771900"/>
+          <p:cNvPr id="41" name="Shape 37"/>
+          <p:cNvSpPr/>
+          <p:nvPr/>
+        </p:nvSpPr>
+        <p:spPr>
+          <a:xfrm>
+            <a:off x="5282032" y="3653028"/>
             <a:ext cx="54864" cy="54864"/>
           </a:xfrm>
           <a:prstGeom prst="ellipse">
@@ -4690,14 +4799,14 @@
       </p:sp>
       <p:sp>
         <p:nvSpPr>
-          <p:cNvPr id="38" name="Text 34"/>
+          <p:cNvPr id="42" name="Text 38"/>
           <p:cNvSpPr txBox="1"/>
           <p:nvPr/>
         </p:nvSpPr>
         <p:spPr>
           <a:xfrm>
-            <a:off x="5446624" y="3666744"/>
-            <a:ext cx="3800704" cy="512064"/>
+            <a:off x="5446624" y="3547872"/>
+            <a:ext cx="3800704" cy="283464"/>
           </a:xfrm>
           <a:prstGeom prst="rect">
             <a:avLst/>
@@ -4711,12 +4820,12 @@
           <a:p>
             <a:pPr indent="0" marL="0">
               <a:lnSpc>
-                <a:spcPts val="1650"/>
+                <a:spcPts val="1600"/>
               </a:lnSpc>
               <a:buNone/>
             </a:pPr>
             <a:r>
-              <a:rPr lang="en-US" sz="1200" dirty="0">
+              <a:rPr lang="en-US" sz="1150" dirty="0">
                 <a:solidFill>
                   <a:srgbClr val="363636"/>
                 </a:solidFill>
@@ -4724,26 +4833,26 @@
                 <a:ea typeface="Arial" pitchFamily="34" charset="-122"/>
                 <a:cs typeface="Arial" pitchFamily="34" charset="-120"/>
               </a:rPr>
-              <a:t>配合 IT 质检「事件录入模板」大模型读取内容质量,固化默认模板并修复下拉不匹配问题</a:t>
-            </a:r>
-            <a:endParaRPr lang="en-US" sz="1200" dirty="0"/>
-          </a:p>
-        </p:txBody>
-      </p:sp>
-      <p:sp>
-        <p:nvSpPr>
-          <p:cNvPr id="39" name="Shape 35"/>
-          <p:cNvSpPr/>
-          <p:nvPr/>
-        </p:nvSpPr>
-        <p:spPr>
-          <a:xfrm>
-            <a:off x="5135728" y="4416552"/>
-            <a:ext cx="4221328" cy="512064"/>
+              <a:t>配合 IT 质检「事件录入模板」优化,固化默认模板</a:t>
+            </a:r>
+            <a:endParaRPr lang="en-US" sz="1150" dirty="0"/>
+          </a:p>
+        </p:txBody>
+      </p:sp>
+      <p:sp>
+        <p:nvSpPr>
+          <p:cNvPr id="43" name="Shape 39"/>
+          <p:cNvSpPr/>
+          <p:nvPr/>
+        </p:nvSpPr>
+        <p:spPr>
+          <a:xfrm>
+            <a:off x="5135728" y="4014216"/>
+            <a:ext cx="4221328" cy="448056"/>
           </a:xfrm>
           <a:prstGeom prst="roundRect">
             <a:avLst>
-              <a:gd name="adj" fmla="val 8929"/>
+              <a:gd name="adj" fmla="val 10204"/>
             </a:avLst>
           </a:prstGeom>
           <a:solidFill>
@@ -4759,14 +4868,14 @@
       </p:sp>
       <p:sp>
         <p:nvSpPr>
-          <p:cNvPr id="40" name="Shape 36"/>
-          <p:cNvSpPr/>
-          <p:nvPr/>
-        </p:nvSpPr>
-        <p:spPr>
-          <a:xfrm>
-            <a:off x="5154016" y="4462272"/>
-            <a:ext cx="32004" cy="420624"/>
+          <p:cNvPr id="44" name="Shape 40"/>
+          <p:cNvSpPr/>
+          <p:nvPr/>
+        </p:nvSpPr>
+        <p:spPr>
+          <a:xfrm>
+            <a:off x="5154016" y="4059936"/>
+            <a:ext cx="32004" cy="356616"/>
           </a:xfrm>
           <a:prstGeom prst="rect">
             <a:avLst/>
@@ -4779,13 +4888,13 @@
       </p:sp>
       <p:sp>
         <p:nvSpPr>
-          <p:cNvPr id="41" name="Shape 37"/>
-          <p:cNvSpPr/>
-          <p:nvPr/>
-        </p:nvSpPr>
-        <p:spPr>
-          <a:xfrm>
-            <a:off x="5282032" y="4631436"/>
+          <p:cNvPr id="45" name="Shape 41"/>
+          <p:cNvSpPr/>
+          <p:nvPr/>
+        </p:nvSpPr>
+        <p:spPr>
+          <a:xfrm>
+            <a:off x="5282032" y="4201668"/>
             <a:ext cx="54864" cy="54864"/>
           </a:xfrm>
           <a:prstGeom prst="ellipse">
@@ -4799,14 +4908,14 @@
       </p:sp>
       <p:sp>
         <p:nvSpPr>
-          <p:cNvPr id="42" name="Text 38"/>
+          <p:cNvPr id="46" name="Text 42"/>
           <p:cNvSpPr txBox="1"/>
           <p:nvPr/>
         </p:nvSpPr>
         <p:spPr>
           <a:xfrm>
-            <a:off x="5446624" y="4526280"/>
-            <a:ext cx="3800704" cy="292608"/>
+            <a:off x="5446624" y="4096512"/>
+            <a:ext cx="3800704" cy="283464"/>
           </a:xfrm>
           <a:prstGeom prst="rect">
             <a:avLst/>
@@ -4820,12 +4929,12 @@
           <a:p>
             <a:pPr indent="0" marL="0">
               <a:lnSpc>
-                <a:spcPts val="1650"/>
+                <a:spcPts val="1600"/>
               </a:lnSpc>
               <a:buNone/>
             </a:pPr>
             <a:r>
-              <a:rPr lang="en-US" sz="1200" dirty="0">
+              <a:rPr lang="en-US" sz="1150" dirty="0">
                 <a:solidFill>
                   <a:srgbClr val="363636"/>
                 </a:solidFill>
@@ -4835,24 +4944,24 @@
               </a:rPr>
               <a:t>7月月报定稿:补入中国国内标准动态后归档</a:t>
             </a:r>
-            <a:endParaRPr lang="en-US" sz="1200" dirty="0"/>
-          </a:p>
-        </p:txBody>
-      </p:sp>
-      <p:sp>
-        <p:nvSpPr>
-          <p:cNvPr id="43" name="Shape 39"/>
-          <p:cNvSpPr/>
-          <p:nvPr/>
-        </p:nvSpPr>
-        <p:spPr>
-          <a:xfrm>
-            <a:off x="5135728" y="5056632"/>
-            <a:ext cx="4221328" cy="512064"/>
+            <a:endParaRPr lang="en-US" sz="1150" dirty="0"/>
+          </a:p>
+        </p:txBody>
+      </p:sp>
+      <p:sp>
+        <p:nvSpPr>
+          <p:cNvPr id="47" name="Shape 43"/>
+          <p:cNvSpPr/>
+          <p:nvPr/>
+        </p:nvSpPr>
+        <p:spPr>
+          <a:xfrm>
+            <a:off x="5135728" y="4562856"/>
+            <a:ext cx="4221328" cy="448056"/>
           </a:xfrm>
           <a:prstGeom prst="roundRect">
             <a:avLst>
-              <a:gd name="adj" fmla="val 8929"/>
+              <a:gd name="adj" fmla="val 10204"/>
             </a:avLst>
           </a:prstGeom>
           <a:solidFill>
@@ -4868,14 +4977,14 @@
       </p:sp>
       <p:sp>
         <p:nvSpPr>
-          <p:cNvPr id="44" name="Shape 40"/>
-          <p:cNvSpPr/>
-          <p:nvPr/>
-        </p:nvSpPr>
-        <p:spPr>
-          <a:xfrm>
-            <a:off x="5154016" y="5102352"/>
-            <a:ext cx="32004" cy="420624"/>
+          <p:cNvPr id="48" name="Shape 44"/>
+          <p:cNvSpPr/>
+          <p:nvPr/>
+        </p:nvSpPr>
+        <p:spPr>
+          <a:xfrm>
+            <a:off x="5154016" y="4608576"/>
+            <a:ext cx="32004" cy="356616"/>
           </a:xfrm>
           <a:prstGeom prst="rect">
             <a:avLst/>
@@ -4888,13 +4997,13 @@
       </p:sp>
       <p:sp>
         <p:nvSpPr>
-          <p:cNvPr id="45" name="Shape 41"/>
-          <p:cNvSpPr/>
-          <p:nvPr/>
-        </p:nvSpPr>
-        <p:spPr>
-          <a:xfrm>
-            <a:off x="5282032" y="5271516"/>
+          <p:cNvPr id="49" name="Shape 45"/>
+          <p:cNvSpPr/>
+          <p:nvPr/>
+        </p:nvSpPr>
+        <p:spPr>
+          <a:xfrm>
+            <a:off x="5282032" y="4750308"/>
             <a:ext cx="54864" cy="54864"/>
           </a:xfrm>
           <a:prstGeom prst="ellipse">
@@ -4908,14 +5017,14 @@
       </p:sp>
       <p:sp>
         <p:nvSpPr>
-          <p:cNvPr id="46" name="Text 42"/>
+          <p:cNvPr id="50" name="Text 46"/>
           <p:cNvSpPr txBox="1"/>
           <p:nvPr/>
         </p:nvSpPr>
         <p:spPr>
           <a:xfrm>
-            <a:off x="5446624" y="5166360"/>
-            <a:ext cx="3800704" cy="292608"/>
+            <a:off x="5446624" y="4645152"/>
+            <a:ext cx="3800704" cy="283464"/>
           </a:xfrm>
           <a:prstGeom prst="rect">
             <a:avLst/>
@@ -4929,12 +5038,12 @@
           <a:p>
             <a:pPr indent="0" marL="0">
               <a:lnSpc>
-                <a:spcPts val="1650"/>
+                <a:spcPts val="1600"/>
               </a:lnSpc>
               <a:buNone/>
             </a:pPr>
             <a:r>
-              <a:rPr lang="en-US" sz="1200" dirty="0">
+              <a:rPr lang="en-US" sz="1150" dirty="0">
                 <a:solidFill>
                   <a:srgbClr val="363636"/>
                 </a:solidFill>
@@ -4944,13 +5053,231 @@
               </a:rPr>
               <a:t>内部数据台账建设:建立待复核项跟踪机制并批量核实积压数据</a:t>
             </a:r>
-            <a:endParaRPr lang="en-US" sz="1200" dirty="0"/>
-          </a:p>
-        </p:txBody>
-      </p:sp>
-      <p:sp>
-        <p:nvSpPr>
-          <p:cNvPr id="47" name="Shape 43"/>
+            <a:endParaRPr lang="en-US" sz="1150" dirty="0"/>
+          </a:p>
+        </p:txBody>
+      </p:sp>
+      <p:sp>
+        <p:nvSpPr>
+          <p:cNvPr id="51" name="Shape 47"/>
+          <p:cNvSpPr/>
+          <p:nvPr/>
+        </p:nvSpPr>
+        <p:spPr>
+          <a:xfrm>
+            <a:off x="5135728" y="5111496"/>
+            <a:ext cx="4221328" cy="448056"/>
+          </a:xfrm>
+          <a:prstGeom prst="roundRect">
+            <a:avLst>
+              <a:gd name="adj" fmla="val 10204"/>
+            </a:avLst>
+          </a:prstGeom>
+          <a:solidFill>
+            <a:srgbClr val="FFFFFF"/>
+          </a:solidFill>
+          <a:ln w="9525">
+            <a:solidFill>
+              <a:srgbClr val="E8E8E8"/>
+            </a:solidFill>
+            <a:prstDash val="solid"/>
+          </a:ln>
+        </p:spPr>
+      </p:sp>
+      <p:sp>
+        <p:nvSpPr>
+          <p:cNvPr id="52" name="Shape 48"/>
+          <p:cNvSpPr/>
+          <p:nvPr/>
+        </p:nvSpPr>
+        <p:spPr>
+          <a:xfrm>
+            <a:off x="5154016" y="5157216"/>
+            <a:ext cx="32004" cy="356616"/>
+          </a:xfrm>
+          <a:prstGeom prst="rect">
+            <a:avLst/>
+          </a:prstGeom>
+          <a:solidFill>
+            <a:srgbClr val="FF6600"/>
+          </a:solidFill>
+          <a:ln/>
+        </p:spPr>
+      </p:sp>
+      <p:sp>
+        <p:nvSpPr>
+          <p:cNvPr id="53" name="Shape 49"/>
+          <p:cNvSpPr/>
+          <p:nvPr/>
+        </p:nvSpPr>
+        <p:spPr>
+          <a:xfrm>
+            <a:off x="5282032" y="5298948"/>
+            <a:ext cx="54864" cy="54864"/>
+          </a:xfrm>
+          <a:prstGeom prst="ellipse">
+            <a:avLst/>
+          </a:prstGeom>
+          <a:solidFill>
+            <a:srgbClr val="FF6600"/>
+          </a:solidFill>
+          <a:ln/>
+        </p:spPr>
+      </p:sp>
+      <p:sp>
+        <p:nvSpPr>
+          <p:cNvPr id="54" name="Text 50"/>
+          <p:cNvSpPr txBox="1"/>
+          <p:nvPr/>
+        </p:nvSpPr>
+        <p:spPr>
+          <a:xfrm>
+            <a:off x="5446624" y="5193792"/>
+            <a:ext cx="3800704" cy="283464"/>
+          </a:xfrm>
+          <a:prstGeom prst="rect">
+            <a:avLst/>
+          </a:prstGeom>
+          <a:noFill/>
+          <a:ln/>
+        </p:spPr>
+        <p:txBody>
+          <a:bodyPr wrap="square" lIns="0" tIns="0" rIns="0" bIns="0" rtlCol="0" anchor="t"/>
+          <a:lstStyle/>
+          <a:p>
+            <a:pPr indent="0" marL="0">
+              <a:lnSpc>
+                <a:spcPts val="1600"/>
+              </a:lnSpc>
+              <a:buNone/>
+            </a:pPr>
+            <a:r>
+              <a:rPr lang="en-US" sz="1150" dirty="0">
+                <a:solidFill>
+                  <a:srgbClr val="363636"/>
+                </a:solidFill>
+                <a:latin typeface="Arial" pitchFamily="34" charset="0"/>
+                <a:ea typeface="Arial" pitchFamily="34" charset="-122"/>
+                <a:cs typeface="Arial" pitchFamily="34" charset="-120"/>
+              </a:rPr>
+              <a:t>每日监测数据基线文件归档与持久化管理</a:t>
+            </a:r>
+            <a:endParaRPr lang="en-US" sz="1150" dirty="0"/>
+          </a:p>
+        </p:txBody>
+      </p:sp>
+      <p:sp>
+        <p:nvSpPr>
+          <p:cNvPr id="55" name="Shape 51"/>
+          <p:cNvSpPr/>
+          <p:nvPr/>
+        </p:nvSpPr>
+        <p:spPr>
+          <a:xfrm>
+            <a:off x="5135728" y="5660136"/>
+            <a:ext cx="4221328" cy="448056"/>
+          </a:xfrm>
+          <a:prstGeom prst="roundRect">
+            <a:avLst>
+              <a:gd name="adj" fmla="val 10204"/>
+            </a:avLst>
+          </a:prstGeom>
+          <a:solidFill>
+            <a:srgbClr val="FFFFFF"/>
+          </a:solidFill>
+          <a:ln w="9525">
+            <a:solidFill>
+              <a:srgbClr val="E8E8E8"/>
+            </a:solidFill>
+            <a:prstDash val="solid"/>
+          </a:ln>
+        </p:spPr>
+      </p:sp>
+      <p:sp>
+        <p:nvSpPr>
+          <p:cNvPr id="56" name="Shape 52"/>
+          <p:cNvSpPr/>
+          <p:nvPr/>
+        </p:nvSpPr>
+        <p:spPr>
+          <a:xfrm>
+            <a:off x="5154016" y="5705856"/>
+            <a:ext cx="32004" cy="356616"/>
+          </a:xfrm>
+          <a:prstGeom prst="rect">
+            <a:avLst/>
+          </a:prstGeom>
+          <a:solidFill>
+            <a:srgbClr val="FF6600"/>
+          </a:solidFill>
+          <a:ln/>
+        </p:spPr>
+      </p:sp>
+      <p:sp>
+        <p:nvSpPr>
+          <p:cNvPr id="57" name="Shape 53"/>
+          <p:cNvSpPr/>
+          <p:nvPr/>
+        </p:nvSpPr>
+        <p:spPr>
+          <a:xfrm>
+            <a:off x="5282032" y="5847588"/>
+            <a:ext cx="54864" cy="54864"/>
+          </a:xfrm>
+          <a:prstGeom prst="ellipse">
+            <a:avLst/>
+          </a:prstGeom>
+          <a:solidFill>
+            <a:srgbClr val="FF6600"/>
+          </a:solidFill>
+          <a:ln/>
+        </p:spPr>
+      </p:sp>
+      <p:sp>
+        <p:nvSpPr>
+          <p:cNvPr id="58" name="Text 54"/>
+          <p:cNvSpPr txBox="1"/>
+          <p:nvPr/>
+        </p:nvSpPr>
+        <p:spPr>
+          <a:xfrm>
+            <a:off x="5446624" y="5742432"/>
+            <a:ext cx="3800704" cy="283464"/>
+          </a:xfrm>
+          <a:prstGeom prst="rect">
+            <a:avLst/>
+          </a:prstGeom>
+          <a:noFill/>
+          <a:ln/>
+        </p:spPr>
+        <p:txBody>
+          <a:bodyPr wrap="square" lIns="0" tIns="0" rIns="0" bIns="0" rtlCol="0" anchor="t"/>
+          <a:lstStyle/>
+          <a:p>
+            <a:pPr indent="0" marL="0">
+              <a:lnSpc>
+                <a:spcPts val="1600"/>
+              </a:lnSpc>
+              <a:buNone/>
+            </a:pPr>
+            <a:r>
+              <a:rPr lang="en-US" sz="1150" dirty="0">
+                <a:solidFill>
+                  <a:srgbClr val="363636"/>
+                </a:solidFill>
+                <a:latin typeface="Arial" pitchFamily="34" charset="0"/>
+                <a:ea typeface="Arial" pitchFamily="34" charset="-122"/>
+                <a:cs typeface="Arial" pitchFamily="34" charset="-120"/>
+              </a:rPr>
+              <a:t>工具页面信息架构统一整理</a:t>
+            </a:r>
+            <a:endParaRPr lang="en-US" sz="1150" dirty="0"/>
+          </a:p>
+        </p:txBody>
+      </p:sp>
+      <p:sp>
+        <p:nvSpPr>
+          <p:cNvPr id="59" name="Shape 55"/>
           <p:cNvSpPr/>
           <p:nvPr/>
         </p:nvSpPr>
@@ -4973,7 +5300,7 @@
       </p:sp>
       <p:sp>
         <p:nvSpPr>
-          <p:cNvPr id="48" name="Shape 44"/>
+          <p:cNvPr id="60" name="Shape 56"/>
           <p:cNvSpPr/>
           <p:nvPr/>
         </p:nvSpPr>
@@ -4993,7 +5320,7 @@
       </p:sp>
       <p:sp>
         <p:nvSpPr>
-          <p:cNvPr id="49" name="Text 45"/>
+          <p:cNvPr id="61" name="Text 57"/>
           <p:cNvSpPr txBox="1"/>
           <p:nvPr/>
         </p:nvSpPr>
@@ -5268,11 +5595,11 @@
         <p:spPr>
           <a:xfrm>
             <a:off x="548640" y="2916936"/>
-            <a:ext cx="4221328" cy="512064"/>
+            <a:ext cx="4221328" cy="448056"/>
           </a:xfrm>
           <a:prstGeom prst="roundRect">
             <a:avLst>
-              <a:gd name="adj" fmla="val 8929"/>
+              <a:gd name="adj" fmla="val 10204"/>
             </a:avLst>
           </a:prstGeom>
           <a:solidFill>
@@ -5295,7 +5622,7 @@
         <p:spPr>
           <a:xfrm>
             <a:off x="566928" y="2962656"/>
-            <a:ext cx="32004" cy="420624"/>
+            <a:ext cx="32004" cy="356616"/>
           </a:xfrm>
           <a:prstGeom prst="rect">
             <a:avLst/>
@@ -5314,7 +5641,7 @@
         </p:nvSpPr>
         <p:spPr>
           <a:xfrm>
-            <a:off x="694944" y="3131820"/>
+            <a:off x="694944" y="3104388"/>
             <a:ext cx="54864" cy="54864"/>
           </a:xfrm>
           <a:prstGeom prst="ellipse">
@@ -5334,8 +5661,8 @@
         </p:nvSpPr>
         <p:spPr>
           <a:xfrm>
-            <a:off x="859536" y="3026664"/>
-            <a:ext cx="3800704" cy="292608"/>
+            <a:off x="859536" y="2999232"/>
+            <a:ext cx="3800704" cy="283464"/>
           </a:xfrm>
           <a:prstGeom prst="rect">
             <a:avLst/>
@@ -5349,12 +5676,12 @@
           <a:p>
             <a:pPr indent="0" marL="0">
               <a:lnSpc>
-                <a:spcPts val="1650"/>
+                <a:spcPts val="1600"/>
               </a:lnSpc>
               <a:buNone/>
             </a:pPr>
             <a:r>
-              <a:rPr lang="en-US" sz="1200" dirty="0">
+              <a:rPr lang="en-US" sz="1150" dirty="0">
                 <a:solidFill>
                   <a:srgbClr val="363636"/>
                 </a:solidFill>
@@ -5364,7 +5691,7 @@
               </a:rPr>
               <a:t>新增认证材料模板,用官方原始 PDF 重做真实页面截取</a:t>
             </a:r>
-            <a:endParaRPr lang="en-US" sz="1200" dirty="0"/>
+            <a:endParaRPr lang="en-US" sz="1150" dirty="0"/>
           </a:p>
         </p:txBody>
       </p:sp>
@@ -5376,12 +5703,12 @@
         </p:nvSpPr>
         <p:spPr>
           <a:xfrm>
-            <a:off x="548640" y="3557016"/>
-            <a:ext cx="4221328" cy="512064"/>
+            <a:off x="548640" y="3465576"/>
+            <a:ext cx="4221328" cy="448056"/>
           </a:xfrm>
           <a:prstGeom prst="roundRect">
             <a:avLst>
-              <a:gd name="adj" fmla="val 8929"/>
+              <a:gd name="adj" fmla="val 10204"/>
             </a:avLst>
           </a:prstGeom>
           <a:solidFill>
@@ -5403,8 +5730,8 @@
         </p:nvSpPr>
         <p:spPr>
           <a:xfrm>
-            <a:off x="566928" y="3602736"/>
-            <a:ext cx="32004" cy="420624"/>
+            <a:off x="566928" y="3511296"/>
+            <a:ext cx="32004" cy="356616"/>
           </a:xfrm>
           <a:prstGeom prst="rect">
             <a:avLst/>
@@ -5423,7 +5750,7 @@
         </p:nvSpPr>
         <p:spPr>
           <a:xfrm>
-            <a:off x="694944" y="3771900"/>
+            <a:off x="694944" y="3653028"/>
             <a:ext cx="54864" cy="54864"/>
           </a:xfrm>
           <a:prstGeom prst="ellipse">
@@ -5443,8 +5770,8 @@
         </p:nvSpPr>
         <p:spPr>
           <a:xfrm>
-            <a:off x="859536" y="3666744"/>
-            <a:ext cx="3800704" cy="292608"/>
+            <a:off x="859536" y="3547872"/>
+            <a:ext cx="3800704" cy="283464"/>
           </a:xfrm>
           <a:prstGeom prst="rect">
             <a:avLst/>
@@ -5458,12 +5785,12 @@
           <a:p>
             <a:pPr indent="0" marL="0">
               <a:lnSpc>
-                <a:spcPts val="1650"/>
+                <a:spcPts val="1600"/>
               </a:lnSpc>
               <a:buNone/>
             </a:pPr>
             <a:r>
-              <a:rPr lang="en-US" sz="1200" dirty="0">
+              <a:rPr lang="en-US" sz="1150" dirty="0">
                 <a:solidFill>
                   <a:srgbClr val="363636"/>
                 </a:solidFill>
@@ -5473,7 +5800,7 @@
               </a:rPr>
               <a:t>Step 5 大改:③⑤⑥站行动计划改为统计摘要,避免重复铺陈</a:t>
             </a:r>
-            <a:endParaRPr lang="en-US" sz="1200" dirty="0"/>
+            <a:endParaRPr lang="en-US" sz="1150" dirty="0"/>
           </a:p>
         </p:txBody>
       </p:sp>
@@ -5485,12 +5812,12 @@
         </p:nvSpPr>
         <p:spPr>
           <a:xfrm>
-            <a:off x="548640" y="4197096"/>
-            <a:ext cx="4221328" cy="512064"/>
+            <a:off x="548640" y="4014216"/>
+            <a:ext cx="4221328" cy="448056"/>
           </a:xfrm>
           <a:prstGeom prst="roundRect">
             <a:avLst>
-              <a:gd name="adj" fmla="val 8929"/>
+              <a:gd name="adj" fmla="val 10204"/>
             </a:avLst>
           </a:prstGeom>
           <a:solidFill>
@@ -5512,8 +5839,8 @@
         </p:nvSpPr>
         <p:spPr>
           <a:xfrm>
-            <a:off x="566928" y="4242816"/>
-            <a:ext cx="32004" cy="420624"/>
+            <a:off x="566928" y="4059936"/>
+            <a:ext cx="32004" cy="356616"/>
           </a:xfrm>
           <a:prstGeom prst="rect">
             <a:avLst/>
@@ -5532,7 +5859,7 @@
         </p:nvSpPr>
         <p:spPr>
           <a:xfrm>
-            <a:off x="694944" y="4411980"/>
+            <a:off x="694944" y="4201668"/>
             <a:ext cx="54864" cy="54864"/>
           </a:xfrm>
           <a:prstGeom prst="ellipse">
@@ -5552,8 +5879,8 @@
         </p:nvSpPr>
         <p:spPr>
           <a:xfrm>
-            <a:off x="859536" y="4306824"/>
-            <a:ext cx="3800704" cy="292608"/>
+            <a:off x="859536" y="4096512"/>
+            <a:ext cx="3800704" cy="283464"/>
           </a:xfrm>
           <a:prstGeom prst="rect">
             <a:avLst/>
@@ -5567,12 +5894,12 @@
           <a:p>
             <a:pPr indent="0" marL="0">
               <a:lnSpc>
-                <a:spcPts val="1650"/>
+                <a:spcPts val="1600"/>
               </a:lnSpc>
               <a:buNone/>
             </a:pPr>
             <a:r>
-              <a:rPr lang="en-US" sz="1200" dirty="0">
+              <a:rPr lang="en-US" sz="1150" dirty="0">
                 <a:solidFill>
                   <a:srgbClr val="363636"/>
                 </a:solidFill>
@@ -5582,7 +5909,7 @@
               </a:rPr>
               <a:t>报告能力增强:新增 Word 导出、行动清单页对齐报告结构、末尾补叙述性总结</a:t>
             </a:r>
-            <a:endParaRPr lang="en-US" sz="1200" dirty="0"/>
+            <a:endParaRPr lang="en-US" sz="1150" dirty="0"/>
           </a:p>
         </p:txBody>
       </p:sp>
@@ -5594,12 +5921,12 @@
         </p:nvSpPr>
         <p:spPr>
           <a:xfrm>
-            <a:off x="548640" y="4837176"/>
-            <a:ext cx="4221328" cy="512064"/>
+            <a:off x="548640" y="4562856"/>
+            <a:ext cx="4221328" cy="448056"/>
           </a:xfrm>
           <a:prstGeom prst="roundRect">
             <a:avLst>
-              <a:gd name="adj" fmla="val 8929"/>
+              <a:gd name="adj" fmla="val 10204"/>
             </a:avLst>
           </a:prstGeom>
           <a:solidFill>
@@ -5621,8 +5948,8 @@
         </p:nvSpPr>
         <p:spPr>
           <a:xfrm>
-            <a:off x="566928" y="4882896"/>
-            <a:ext cx="32004" cy="420624"/>
+            <a:off x="566928" y="4608576"/>
+            <a:ext cx="32004" cy="356616"/>
           </a:xfrm>
           <a:prstGeom prst="rect">
             <a:avLst/>
@@ -5641,7 +5968,7 @@
         </p:nvSpPr>
         <p:spPr>
           <a:xfrm>
-            <a:off x="694944" y="5052060"/>
+            <a:off x="694944" y="4750308"/>
             <a:ext cx="54864" cy="54864"/>
           </a:xfrm>
           <a:prstGeom prst="ellipse">
@@ -5661,8 +5988,8 @@
         </p:nvSpPr>
         <p:spPr>
           <a:xfrm>
-            <a:off x="859536" y="4946904"/>
-            <a:ext cx="3800704" cy="292608"/>
+            <a:off x="859536" y="4645152"/>
+            <a:ext cx="3800704" cy="283464"/>
           </a:xfrm>
           <a:prstGeom prst="rect">
             <a:avLst/>
@@ -5676,12 +6003,12 @@
           <a:p>
             <a:pPr indent="0" marL="0">
               <a:lnSpc>
-                <a:spcPts val="1650"/>
+                <a:spcPts val="1600"/>
               </a:lnSpc>
               <a:buNone/>
             </a:pPr>
             <a:r>
-              <a:rPr lang="en-US" sz="1200" dirty="0">
+              <a:rPr lang="en-US" sz="1150" dirty="0">
                 <a:solidFill>
                   <a:srgbClr val="363636"/>
                 </a:solidFill>
@@ -5691,13 +6018,122 @@
               </a:rPr>
               <a:t>认证旅程 10+ 项交互细节修复:官方链接/模板下载/打印样式等逐项打磨</a:t>
             </a:r>
-            <a:endParaRPr lang="en-US" sz="1200" dirty="0"/>
+            <a:endParaRPr lang="en-US" sz="1150" dirty="0"/>
+          </a:p>
+        </p:txBody>
+      </p:sp>
+      <p:sp>
+        <p:nvSpPr>
+          <p:cNvPr id="24" name="Shape 21"/>
+          <p:cNvSpPr/>
+          <p:nvPr/>
+        </p:nvSpPr>
+        <p:spPr>
+          <a:xfrm>
+            <a:off x="548640" y="5111496"/>
+            <a:ext cx="4221328" cy="448056"/>
+          </a:xfrm>
+          <a:prstGeom prst="roundRect">
+            <a:avLst>
+              <a:gd name="adj" fmla="val 10204"/>
+            </a:avLst>
+          </a:prstGeom>
+          <a:solidFill>
+            <a:srgbClr val="FFFFFF"/>
+          </a:solidFill>
+          <a:ln w="9525">
+            <a:solidFill>
+              <a:srgbClr val="E8E8E8"/>
+            </a:solidFill>
+            <a:prstDash val="solid"/>
+          </a:ln>
+        </p:spPr>
+      </p:sp>
+      <p:sp>
+        <p:nvSpPr>
+          <p:cNvPr id="25" name="Shape 22"/>
+          <p:cNvSpPr/>
+          <p:nvPr/>
+        </p:nvSpPr>
+        <p:spPr>
+          <a:xfrm>
+            <a:off x="566928" y="5157216"/>
+            <a:ext cx="32004" cy="356616"/>
+          </a:xfrm>
+          <a:prstGeom prst="rect">
+            <a:avLst/>
+          </a:prstGeom>
+          <a:solidFill>
+            <a:srgbClr val="FF6600"/>
+          </a:solidFill>
+          <a:ln/>
+        </p:spPr>
+      </p:sp>
+      <p:sp>
+        <p:nvSpPr>
+          <p:cNvPr id="26" name="Shape 23"/>
+          <p:cNvSpPr/>
+          <p:nvPr/>
+        </p:nvSpPr>
+        <p:spPr>
+          <a:xfrm>
+            <a:off x="694944" y="5298948"/>
+            <a:ext cx="54864" cy="54864"/>
+          </a:xfrm>
+          <a:prstGeom prst="ellipse">
+            <a:avLst/>
+          </a:prstGeom>
+          <a:solidFill>
+            <a:srgbClr val="FF6600"/>
+          </a:solidFill>
+          <a:ln/>
+        </p:spPr>
+      </p:sp>
+      <p:sp>
+        <p:nvSpPr>
+          <p:cNvPr id="27" name="Text 24"/>
+          <p:cNvSpPr txBox="1"/>
+          <p:nvPr/>
+        </p:nvSpPr>
+        <p:spPr>
+          <a:xfrm>
+            <a:off x="859536" y="5193792"/>
+            <a:ext cx="3800704" cy="283464"/>
+          </a:xfrm>
+          <a:prstGeom prst="rect">
+            <a:avLst/>
+          </a:prstGeom>
+          <a:noFill/>
+          <a:ln/>
+        </p:spPr>
+        <p:txBody>
+          <a:bodyPr wrap="square" lIns="0" tIns="0" rIns="0" bIns="0" rtlCol="0" anchor="t"/>
+          <a:lstStyle/>
+          <a:p>
+            <a:pPr indent="0" marL="0">
+              <a:lnSpc>
+                <a:spcPts val="1600"/>
+              </a:lnSpc>
+              <a:buNone/>
+            </a:pPr>
+            <a:r>
+              <a:rPr lang="en-US" sz="1150" dirty="0">
+                <a:solidFill>
+                  <a:srgbClr val="363636"/>
+                </a:solidFill>
+                <a:latin typeface="Arial" pitchFamily="34" charset="0"/>
+                <a:ea typeface="Arial" pitchFamily="34" charset="-122"/>
+                <a:cs typeface="Arial" pitchFamily="34" charset="-120"/>
+              </a:rPr>
+              <a:t>行动清单按风险等级重构,输出导读总览</a:t>
+            </a:r>
+            <a:endParaRPr lang="en-US" sz="1150" dirty="0"/>
           </a:p>
         </p:txBody>
       </p:sp>
       <p:pic>
         <p:nvPicPr>
-          <p:cNvPr id="24" name="Image 1" descr="/tmp/pptx_work/icons/calendar.png">    </p:cNvPr>
+          <p:cNvPr id="28" name="Image 1" descr="/tmp/pptx_work/icons/calendar.png">    </p:cNvPr>
           <p:cNvPicPr>
             <a:picLocks noChangeAspect="1"/>
           </p:cNvPicPr>
@@ -5721,7 +6157,7 @@
       </p:pic>
       <p:sp>
         <p:nvSpPr>
-          <p:cNvPr id="25" name="Text 21"/>
+          <p:cNvPr id="29" name="Text 25"/>
           <p:cNvSpPr txBox="1"/>
           <p:nvPr/>
         </p:nvSpPr>
@@ -5763,7 +6199,7 @@
       </p:sp>
       <p:sp>
         <p:nvSpPr>
-          <p:cNvPr id="26" name="Shape 22"/>
+          <p:cNvPr id="30" name="Shape 26"/>
           <p:cNvSpPr/>
           <p:nvPr/>
         </p:nvSpPr>
@@ -5786,18 +6222,18 @@
       </p:sp>
       <p:sp>
         <p:nvSpPr>
-          <p:cNvPr id="27" name="Shape 23"/>
+          <p:cNvPr id="31" name="Shape 27"/>
           <p:cNvSpPr/>
           <p:nvPr/>
         </p:nvSpPr>
         <p:spPr>
           <a:xfrm>
             <a:off x="5135728" y="2916936"/>
-            <a:ext cx="4221328" cy="512064"/>
+            <a:ext cx="4221328" cy="448056"/>
           </a:xfrm>
           <a:prstGeom prst="roundRect">
             <a:avLst>
-              <a:gd name="adj" fmla="val 8929"/>
+              <a:gd name="adj" fmla="val 10204"/>
             </a:avLst>
           </a:prstGeom>
           <a:solidFill>
@@ -5813,14 +6249,14 @@
       </p:sp>
       <p:sp>
         <p:nvSpPr>
-          <p:cNvPr id="28" name="Shape 24"/>
+          <p:cNvPr id="32" name="Shape 28"/>
           <p:cNvSpPr/>
           <p:nvPr/>
         </p:nvSpPr>
         <p:spPr>
           <a:xfrm>
             <a:off x="5154016" y="2962656"/>
-            <a:ext cx="32004" cy="420624"/>
+            <a:ext cx="32004" cy="356616"/>
           </a:xfrm>
           <a:prstGeom prst="rect">
             <a:avLst/>
@@ -5833,13 +6269,13 @@
       </p:sp>
       <p:sp>
         <p:nvSpPr>
-          <p:cNvPr id="29" name="Shape 25"/>
-          <p:cNvSpPr/>
-          <p:nvPr/>
-        </p:nvSpPr>
-        <p:spPr>
-          <a:xfrm>
-            <a:off x="5282032" y="3131820"/>
+          <p:cNvPr id="33" name="Shape 29"/>
+          <p:cNvSpPr/>
+          <p:nvPr/>
+        </p:nvSpPr>
+        <p:spPr>
+          <a:xfrm>
+            <a:off x="5282032" y="3104388"/>
             <a:ext cx="54864" cy="54864"/>
           </a:xfrm>
           <a:prstGeom prst="ellipse">
@@ -5853,14 +6289,14 @@
       </p:sp>
       <p:sp>
         <p:nvSpPr>
-          <p:cNvPr id="30" name="Text 26"/>
+          <p:cNvPr id="34" name="Text 30"/>
           <p:cNvSpPr txBox="1"/>
           <p:nvPr/>
         </p:nvSpPr>
         <p:spPr>
           <a:xfrm>
-            <a:off x="5446624" y="3026664"/>
-            <a:ext cx="3800704" cy="292608"/>
+            <a:off x="5446624" y="2999232"/>
+            <a:ext cx="3800704" cy="283464"/>
           </a:xfrm>
           <a:prstGeom prst="rect">
             <a:avLst/>
@@ -5874,12 +6310,12 @@
           <a:p>
             <a:pPr indent="0" marL="0">
               <a:lnSpc>
-                <a:spcPts val="1650"/>
+                <a:spcPts val="1600"/>
               </a:lnSpc>
               <a:buNone/>
             </a:pPr>
             <a:r>
-              <a:rPr lang="en-US" sz="1200" dirty="0">
+              <a:rPr lang="en-US" sz="1150" dirty="0">
                 <a:solidFill>
                   <a:srgbClr val="363636"/>
                 </a:solidFill>
@@ -5889,24 +6325,24 @@
               </a:rPr>
               <a:t>《全球及中国汽车法规标准月报》编制(8月刊)</a:t>
             </a:r>
-            <a:endParaRPr lang="en-US" sz="1200" dirty="0"/>
-          </a:p>
-        </p:txBody>
-      </p:sp>
-      <p:sp>
-        <p:nvSpPr>
-          <p:cNvPr id="31" name="Shape 27"/>
-          <p:cNvSpPr/>
-          <p:nvPr/>
-        </p:nvSpPr>
-        <p:spPr>
-          <a:xfrm>
-            <a:off x="5135728" y="3557016"/>
-            <a:ext cx="4221328" cy="731520"/>
+            <a:endParaRPr lang="en-US" sz="1150" dirty="0"/>
+          </a:p>
+        </p:txBody>
+      </p:sp>
+      <p:sp>
+        <p:nvSpPr>
+          <p:cNvPr id="35" name="Shape 31"/>
+          <p:cNvSpPr/>
+          <p:nvPr/>
+        </p:nvSpPr>
+        <p:spPr>
+          <a:xfrm>
+            <a:off x="5135728" y="3465576"/>
+            <a:ext cx="4221328" cy="448056"/>
           </a:xfrm>
           <a:prstGeom prst="roundRect">
             <a:avLst>
-              <a:gd name="adj" fmla="val 6250"/>
+              <a:gd name="adj" fmla="val 10204"/>
             </a:avLst>
           </a:prstGeom>
           <a:solidFill>
@@ -5922,14 +6358,14 @@
       </p:sp>
       <p:sp>
         <p:nvSpPr>
-          <p:cNvPr id="32" name="Shape 28"/>
-          <p:cNvSpPr/>
-          <p:nvPr/>
-        </p:nvSpPr>
-        <p:spPr>
-          <a:xfrm>
-            <a:off x="5154016" y="3602736"/>
-            <a:ext cx="32004" cy="640080"/>
+          <p:cNvPr id="36" name="Shape 32"/>
+          <p:cNvSpPr/>
+          <p:nvPr/>
+        </p:nvSpPr>
+        <p:spPr>
+          <a:xfrm>
+            <a:off x="5154016" y="3511296"/>
+            <a:ext cx="32004" cy="356616"/>
           </a:xfrm>
           <a:prstGeom prst="rect">
             <a:avLst/>
@@ -5942,13 +6378,13 @@
       </p:sp>
       <p:sp>
         <p:nvSpPr>
-          <p:cNvPr id="33" name="Shape 29"/>
-          <p:cNvSpPr/>
-          <p:nvPr/>
-        </p:nvSpPr>
-        <p:spPr>
-          <a:xfrm>
-            <a:off x="5282032" y="3771900"/>
+          <p:cNvPr id="37" name="Shape 33"/>
+          <p:cNvSpPr/>
+          <p:nvPr/>
+        </p:nvSpPr>
+        <p:spPr>
+          <a:xfrm>
+            <a:off x="5282032" y="3653028"/>
             <a:ext cx="54864" cy="54864"/>
           </a:xfrm>
           <a:prstGeom prst="ellipse">
@@ -5962,14 +6398,14 @@
       </p:sp>
       <p:sp>
         <p:nvSpPr>
-          <p:cNvPr id="34" name="Text 30"/>
+          <p:cNvPr id="38" name="Text 34"/>
           <p:cNvSpPr txBox="1"/>
           <p:nvPr/>
         </p:nvSpPr>
         <p:spPr>
           <a:xfrm>
-            <a:off x="5446624" y="3666744"/>
-            <a:ext cx="3800704" cy="512064"/>
+            <a:off x="5446624" y="3547872"/>
+            <a:ext cx="3800704" cy="283464"/>
           </a:xfrm>
           <a:prstGeom prst="rect">
             <a:avLst/>
@@ -5983,12 +6419,12 @@
           <a:p>
             <a:pPr indent="0" marL="0">
               <a:lnSpc>
-                <a:spcPts val="1650"/>
+                <a:spcPts val="1600"/>
               </a:lnSpc>
               <a:buNone/>
             </a:pPr>
             <a:r>
-              <a:rPr lang="en-US" sz="1200" dirty="0">
+              <a:rPr lang="en-US" sz="1150" dirty="0">
                 <a:solidFill>
                   <a:srgbClr val="363636"/>
                 </a:solidFill>
@@ -5996,26 +6432,26 @@
                 <a:ea typeface="Arial" pitchFamily="34" charset="-122"/>
                 <a:cs typeface="Arial" pitchFamily="34" charset="-120"/>
               </a:rPr>
-              <a:t>每日监测自动化流水线运维排查:多次发现定时任务未自动执行、部分日期邮件缺失等异常,及时报告 IT 跟进修复</a:t>
-            </a:r>
-            <a:endParaRPr lang="en-US" sz="1200" dirty="0"/>
-          </a:p>
-        </p:txBody>
-      </p:sp>
-      <p:sp>
-        <p:nvSpPr>
-          <p:cNvPr id="35" name="Shape 31"/>
-          <p:cNvSpPr/>
-          <p:nvPr/>
-        </p:nvSpPr>
-        <p:spPr>
-          <a:xfrm>
-            <a:off x="5135728" y="4416552"/>
-            <a:ext cx="4221328" cy="512064"/>
+              <a:t>每日监测自动化流水线运维排查:多次发现异常并及时报告 IT 跟进修复</a:t>
+            </a:r>
+            <a:endParaRPr lang="en-US" sz="1150" dirty="0"/>
+          </a:p>
+        </p:txBody>
+      </p:sp>
+      <p:sp>
+        <p:nvSpPr>
+          <p:cNvPr id="39" name="Shape 35"/>
+          <p:cNvSpPr/>
+          <p:nvPr/>
+        </p:nvSpPr>
+        <p:spPr>
+          <a:xfrm>
+            <a:off x="5135728" y="4014216"/>
+            <a:ext cx="4221328" cy="448056"/>
           </a:xfrm>
           <a:prstGeom prst="roundRect">
             <a:avLst>
-              <a:gd name="adj" fmla="val 8929"/>
+              <a:gd name="adj" fmla="val 10204"/>
             </a:avLst>
           </a:prstGeom>
           <a:solidFill>
@@ -6031,14 +6467,14 @@
       </p:sp>
       <p:sp>
         <p:nvSpPr>
-          <p:cNvPr id="36" name="Shape 32"/>
-          <p:cNvSpPr/>
-          <p:nvPr/>
-        </p:nvSpPr>
-        <p:spPr>
-          <a:xfrm>
-            <a:off x="5154016" y="4462272"/>
-            <a:ext cx="32004" cy="420624"/>
+          <p:cNvPr id="40" name="Shape 36"/>
+          <p:cNvSpPr/>
+          <p:nvPr/>
+        </p:nvSpPr>
+        <p:spPr>
+          <a:xfrm>
+            <a:off x="5154016" y="4059936"/>
+            <a:ext cx="32004" cy="356616"/>
           </a:xfrm>
           <a:prstGeom prst="rect">
             <a:avLst/>
@@ -6051,13 +6487,13 @@
       </p:sp>
       <p:sp>
         <p:nvSpPr>
-          <p:cNvPr id="37" name="Shape 33"/>
-          <p:cNvSpPr/>
-          <p:nvPr/>
-        </p:nvSpPr>
-        <p:spPr>
-          <a:xfrm>
-            <a:off x="5282032" y="4631436"/>
+          <p:cNvPr id="41" name="Shape 37"/>
+          <p:cNvSpPr/>
+          <p:nvPr/>
+        </p:nvSpPr>
+        <p:spPr>
+          <a:xfrm>
+            <a:off x="5282032" y="4201668"/>
             <a:ext cx="54864" cy="54864"/>
           </a:xfrm>
           <a:prstGeom prst="ellipse">
@@ -6071,14 +6507,14 @@
       </p:sp>
       <p:sp>
         <p:nvSpPr>
-          <p:cNvPr id="38" name="Text 34"/>
+          <p:cNvPr id="42" name="Text 38"/>
           <p:cNvSpPr txBox="1"/>
           <p:nvPr/>
         </p:nvSpPr>
         <p:spPr>
           <a:xfrm>
-            <a:off x="5446624" y="4526280"/>
-            <a:ext cx="3800704" cy="292608"/>
+            <a:off x="5446624" y="4096512"/>
+            <a:ext cx="3800704" cy="283464"/>
           </a:xfrm>
           <a:prstGeom prst="rect">
             <a:avLst/>
@@ -6092,12 +6528,12 @@
           <a:p>
             <a:pPr indent="0" marL="0">
               <a:lnSpc>
-                <a:spcPts val="1650"/>
+                <a:spcPts val="1600"/>
               </a:lnSpc>
               <a:buNone/>
             </a:pPr>
             <a:r>
-              <a:rPr lang="en-US" sz="1200" dirty="0">
+              <a:rPr lang="en-US" sz="1150" dirty="0">
                 <a:solidFill>
                   <a:srgbClr val="363636"/>
                 </a:solidFill>
@@ -6107,24 +6543,24 @@
               </a:rPr>
               <a:t>8月月报多轮口径校准:并入中国国内月报 70 项标准动态后定稿</a:t>
             </a:r>
-            <a:endParaRPr lang="en-US" sz="1200" dirty="0"/>
-          </a:p>
-        </p:txBody>
-      </p:sp>
-      <p:sp>
-        <p:nvSpPr>
-          <p:cNvPr id="39" name="Shape 35"/>
-          <p:cNvSpPr/>
-          <p:nvPr/>
-        </p:nvSpPr>
-        <p:spPr>
-          <a:xfrm>
-            <a:off x="5135728" y="5056632"/>
-            <a:ext cx="4221328" cy="512064"/>
+            <a:endParaRPr lang="en-US" sz="1150" dirty="0"/>
+          </a:p>
+        </p:txBody>
+      </p:sp>
+      <p:sp>
+        <p:nvSpPr>
+          <p:cNvPr id="43" name="Shape 39"/>
+          <p:cNvSpPr/>
+          <p:nvPr/>
+        </p:nvSpPr>
+        <p:spPr>
+          <a:xfrm>
+            <a:off x="5135728" y="4562856"/>
+            <a:ext cx="4221328" cy="448056"/>
           </a:xfrm>
           <a:prstGeom prst="roundRect">
             <a:avLst>
-              <a:gd name="adj" fmla="val 8929"/>
+              <a:gd name="adj" fmla="val 10204"/>
             </a:avLst>
           </a:prstGeom>
           <a:solidFill>
@@ -6140,14 +6576,14 @@
       </p:sp>
       <p:sp>
         <p:nvSpPr>
-          <p:cNvPr id="40" name="Shape 36"/>
-          <p:cNvSpPr/>
-          <p:nvPr/>
-        </p:nvSpPr>
-        <p:spPr>
-          <a:xfrm>
-            <a:off x="5154016" y="5102352"/>
-            <a:ext cx="32004" cy="420624"/>
+          <p:cNvPr id="44" name="Shape 40"/>
+          <p:cNvSpPr/>
+          <p:nvPr/>
+        </p:nvSpPr>
+        <p:spPr>
+          <a:xfrm>
+            <a:off x="5154016" y="4608576"/>
+            <a:ext cx="32004" cy="356616"/>
           </a:xfrm>
           <a:prstGeom prst="rect">
             <a:avLst/>
@@ -6160,13 +6596,13 @@
       </p:sp>
       <p:sp>
         <p:nvSpPr>
-          <p:cNvPr id="41" name="Shape 37"/>
-          <p:cNvSpPr/>
-          <p:nvPr/>
-        </p:nvSpPr>
-        <p:spPr>
-          <a:xfrm>
-            <a:off x="5282032" y="5271516"/>
+          <p:cNvPr id="45" name="Shape 41"/>
+          <p:cNvSpPr/>
+          <p:nvPr/>
+        </p:nvSpPr>
+        <p:spPr>
+          <a:xfrm>
+            <a:off x="5282032" y="4750308"/>
             <a:ext cx="54864" cy="54864"/>
           </a:xfrm>
           <a:prstGeom prst="ellipse">
@@ -6180,14 +6616,14 @@
       </p:sp>
       <p:sp>
         <p:nvSpPr>
-          <p:cNvPr id="42" name="Text 38"/>
+          <p:cNvPr id="46" name="Text 42"/>
           <p:cNvSpPr txBox="1"/>
           <p:nvPr/>
         </p:nvSpPr>
         <p:spPr>
           <a:xfrm>
-            <a:off x="5446624" y="5166360"/>
-            <a:ext cx="3800704" cy="292608"/>
+            <a:off x="5446624" y="4645152"/>
+            <a:ext cx="3800704" cy="283464"/>
           </a:xfrm>
           <a:prstGeom prst="rect">
             <a:avLst/>
@@ -6201,12 +6637,12 @@
           <a:p>
             <a:pPr indent="0" marL="0">
               <a:lnSpc>
-                <a:spcPts val="1650"/>
+                <a:spcPts val="1600"/>
               </a:lnSpc>
               <a:buNone/>
             </a:pPr>
             <a:r>
-              <a:rPr lang="en-US" sz="1200" dirty="0">
+              <a:rPr lang="en-US" sz="1150" dirty="0">
                 <a:solidFill>
                   <a:srgbClr val="363636"/>
                 </a:solidFill>
@@ -6216,13 +6652,122 @@
               </a:rPr>
               <a:t>合规成熟度矩阵改版:白底常显,象限优先建议更聚焦</a:t>
             </a:r>
-            <a:endParaRPr lang="en-US" sz="1200" dirty="0"/>
-          </a:p>
-        </p:txBody>
-      </p:sp>
-      <p:sp>
-        <p:nvSpPr>
-          <p:cNvPr id="43" name="Shape 39"/>
+            <a:endParaRPr lang="en-US" sz="1150" dirty="0"/>
+          </a:p>
+        </p:txBody>
+      </p:sp>
+      <p:sp>
+        <p:nvSpPr>
+          <p:cNvPr id="47" name="Shape 43"/>
+          <p:cNvSpPr/>
+          <p:nvPr/>
+        </p:nvSpPr>
+        <p:spPr>
+          <a:xfrm>
+            <a:off x="5135728" y="5111496"/>
+            <a:ext cx="4221328" cy="448056"/>
+          </a:xfrm>
+          <a:prstGeom prst="roundRect">
+            <a:avLst>
+              <a:gd name="adj" fmla="val 10204"/>
+            </a:avLst>
+          </a:prstGeom>
+          <a:solidFill>
+            <a:srgbClr val="FFFFFF"/>
+          </a:solidFill>
+          <a:ln w="9525">
+            <a:solidFill>
+              <a:srgbClr val="E8E8E8"/>
+            </a:solidFill>
+            <a:prstDash val="solid"/>
+          </a:ln>
+        </p:spPr>
+      </p:sp>
+      <p:sp>
+        <p:nvSpPr>
+          <p:cNvPr id="48" name="Shape 44"/>
+          <p:cNvSpPr/>
+          <p:nvPr/>
+        </p:nvSpPr>
+        <p:spPr>
+          <a:xfrm>
+            <a:off x="5154016" y="5157216"/>
+            <a:ext cx="32004" cy="356616"/>
+          </a:xfrm>
+          <a:prstGeom prst="rect">
+            <a:avLst/>
+          </a:prstGeom>
+          <a:solidFill>
+            <a:srgbClr val="FF6600"/>
+          </a:solidFill>
+          <a:ln/>
+        </p:spPr>
+      </p:sp>
+      <p:sp>
+        <p:nvSpPr>
+          <p:cNvPr id="49" name="Shape 45"/>
+          <p:cNvSpPr/>
+          <p:nvPr/>
+        </p:nvSpPr>
+        <p:spPr>
+          <a:xfrm>
+            <a:off x="5282032" y="5298948"/>
+            <a:ext cx="54864" cy="54864"/>
+          </a:xfrm>
+          <a:prstGeom prst="ellipse">
+            <a:avLst/>
+          </a:prstGeom>
+          <a:solidFill>
+            <a:srgbClr val="FF6600"/>
+          </a:solidFill>
+          <a:ln/>
+        </p:spPr>
+      </p:sp>
+      <p:sp>
+        <p:nvSpPr>
+          <p:cNvPr id="50" name="Text 46"/>
+          <p:cNvSpPr txBox="1"/>
+          <p:nvPr/>
+        </p:nvSpPr>
+        <p:spPr>
+          <a:xfrm>
+            <a:off x="5446624" y="5193792"/>
+            <a:ext cx="3800704" cy="283464"/>
+          </a:xfrm>
+          <a:prstGeom prst="rect">
+            <a:avLst/>
+          </a:prstGeom>
+          <a:noFill/>
+          <a:ln/>
+        </p:spPr>
+        <p:txBody>
+          <a:bodyPr wrap="square" lIns="0" tIns="0" rIns="0" bIns="0" rtlCol="0" anchor="t"/>
+          <a:lstStyle/>
+          <a:p>
+            <a:pPr indent="0" marL="0">
+              <a:lnSpc>
+                <a:spcPts val="1600"/>
+              </a:lnSpc>
+              <a:buNone/>
+            </a:pPr>
+            <a:r>
+              <a:rPr lang="en-US" sz="1150" dirty="0">
+                <a:solidFill>
+                  <a:srgbClr val="363636"/>
+                </a:solidFill>
+                <a:latin typeface="Arial" pitchFamily="34" charset="0"/>
+                <a:ea typeface="Arial" pitchFamily="34" charset="-122"/>
+                <a:cs typeface="Arial" pitchFamily="34" charset="-120"/>
+              </a:rPr>
+              <a:t>每日监测数据基线持续归档维护</a:t>
+            </a:r>
+            <a:endParaRPr lang="en-US" sz="1150" dirty="0"/>
+          </a:p>
+        </p:txBody>
+      </p:sp>
+      <p:sp>
+        <p:nvSpPr>
+          <p:cNvPr id="51" name="Shape 47"/>
           <p:cNvSpPr/>
           <p:nvPr/>
         </p:nvSpPr>
@@ -6245,7 +6790,7 @@
       </p:sp>
       <p:sp>
         <p:nvSpPr>
-          <p:cNvPr id="44" name="Shape 40"/>
+          <p:cNvPr id="52" name="Shape 48"/>
           <p:cNvSpPr/>
           <p:nvPr/>
         </p:nvSpPr>
@@ -6265,7 +6810,7 @@
       </p:sp>
       <p:sp>
         <p:nvSpPr>
-          <p:cNvPr id="45" name="Text 41"/>
+          <p:cNvPr id="53" name="Text 49"/>
           <p:cNvSpPr txBox="1"/>
           <p:nvPr/>
         </p:nvSpPr>
@@ -6540,11 +7085,11 @@
         <p:spPr>
           <a:xfrm>
             <a:off x="548640" y="2916936"/>
-            <a:ext cx="4221328" cy="731520"/>
+            <a:ext cx="4221328" cy="658368"/>
           </a:xfrm>
           <a:prstGeom prst="roundRect">
             <a:avLst>
-              <a:gd name="adj" fmla="val 6250"/>
+              <a:gd name="adj" fmla="val 6944"/>
             </a:avLst>
           </a:prstGeom>
           <a:solidFill>
@@ -6567,7 +7112,7 @@
         <p:spPr>
           <a:xfrm>
             <a:off x="566928" y="2962656"/>
-            <a:ext cx="32004" cy="640080"/>
+            <a:ext cx="32004" cy="566928"/>
           </a:xfrm>
           <a:prstGeom prst="rect">
             <a:avLst/>
@@ -6586,7 +7131,7 @@
         </p:nvSpPr>
         <p:spPr>
           <a:xfrm>
-            <a:off x="694944" y="3131820"/>
+            <a:off x="694944" y="3104388"/>
             <a:ext cx="54864" cy="54864"/>
           </a:xfrm>
           <a:prstGeom prst="ellipse">
@@ -6606,8 +7151,8 @@
         </p:nvSpPr>
         <p:spPr>
           <a:xfrm>
-            <a:off x="859536" y="3026664"/>
-            <a:ext cx="3800704" cy="512064"/>
+            <a:off x="859536" y="2999232"/>
+            <a:ext cx="3800704" cy="493776"/>
           </a:xfrm>
           <a:prstGeom prst="rect">
             <a:avLst/>
@@ -6621,12 +7166,12 @@
           <a:p>
             <a:pPr indent="0" marL="0">
               <a:lnSpc>
-                <a:spcPts val="1650"/>
+                <a:spcPts val="1600"/>
               </a:lnSpc>
               <a:buNone/>
             </a:pPr>
             <a:r>
-              <a:rPr lang="en-US" sz="1200" dirty="0">
+              <a:rPr lang="en-US" sz="1150" dirty="0">
                 <a:solidFill>
                   <a:srgbClr val="363636"/>
                 </a:solidFill>
@@ -6636,7 +7181,7 @@
               </a:rPr>
               <a:t>拉美/北美七国(墨西哥/哥伦比亚/巴西/阿根廷/智利/秘鲁/美国/加拿大)充电插头插座标准检索,交付 Excel 数据表 + 原文压缩包</a:t>
             </a:r>
-            <a:endParaRPr lang="en-US" sz="1200" dirty="0"/>
+            <a:endParaRPr lang="en-US" sz="1150" dirty="0"/>
           </a:p>
         </p:txBody>
       </p:sp>
@@ -6648,12 +7193,12 @@
         </p:nvSpPr>
         <p:spPr>
           <a:xfrm>
-            <a:off x="548640" y="3776472"/>
-            <a:ext cx="4221328" cy="512064"/>
+            <a:off x="548640" y="3675888"/>
+            <a:ext cx="4221328" cy="448056"/>
           </a:xfrm>
           <a:prstGeom prst="roundRect">
             <a:avLst>
-              <a:gd name="adj" fmla="val 8929"/>
+              <a:gd name="adj" fmla="val 10204"/>
             </a:avLst>
           </a:prstGeom>
           <a:solidFill>
@@ -6675,8 +7220,8 @@
         </p:nvSpPr>
         <p:spPr>
           <a:xfrm>
-            <a:off x="566928" y="3822192"/>
-            <a:ext cx="32004" cy="420624"/>
+            <a:off x="566928" y="3721608"/>
+            <a:ext cx="32004" cy="356616"/>
           </a:xfrm>
           <a:prstGeom prst="rect">
             <a:avLst/>
@@ -6695,7 +7240,7 @@
         </p:nvSpPr>
         <p:spPr>
           <a:xfrm>
-            <a:off x="694944" y="3991356"/>
+            <a:off x="694944" y="3863340"/>
             <a:ext cx="54864" cy="54864"/>
           </a:xfrm>
           <a:prstGeom prst="ellipse">
@@ -6715,8 +7260,8 @@
         </p:nvSpPr>
         <p:spPr>
           <a:xfrm>
-            <a:off x="859536" y="3886200"/>
-            <a:ext cx="3800704" cy="292608"/>
+            <a:off x="859536" y="3758184"/>
+            <a:ext cx="3800704" cy="283464"/>
           </a:xfrm>
           <a:prstGeom prst="rect">
             <a:avLst/>
@@ -6730,12 +7275,12 @@
           <a:p>
             <a:pPr indent="0" marL="0">
               <a:lnSpc>
-                <a:spcPts val="1650"/>
+                <a:spcPts val="1600"/>
               </a:lnSpc>
               <a:buNone/>
             </a:pPr>
             <a:r>
-              <a:rPr lang="en-US" sz="1200" dirty="0">
+              <a:rPr lang="en-US" sz="1150" dirty="0">
                 <a:solidFill>
                   <a:srgbClr val="363636"/>
                 </a:solidFill>
@@ -6745,7 +7290,7 @@
               </a:rPr>
               <a:t>核对「清单有原文但未收集」表,澄清数量差异(废止/合并共6条)原因</a:t>
             </a:r>
-            <a:endParaRPr lang="en-US" sz="1200" dirty="0"/>
+            <a:endParaRPr lang="en-US" sz="1150" dirty="0"/>
           </a:p>
         </p:txBody>
       </p:sp>
@@ -6757,12 +7302,12 @@
         </p:nvSpPr>
         <p:spPr>
           <a:xfrm>
-            <a:off x="548640" y="4416552"/>
-            <a:ext cx="4221328" cy="512064"/>
+            <a:off x="548640" y="4224528"/>
+            <a:ext cx="4221328" cy="448056"/>
           </a:xfrm>
           <a:prstGeom prst="roundRect">
             <a:avLst>
-              <a:gd name="adj" fmla="val 8929"/>
+              <a:gd name="adj" fmla="val 10204"/>
             </a:avLst>
           </a:prstGeom>
           <a:solidFill>
@@ -6784,8 +7329,8 @@
         </p:nvSpPr>
         <p:spPr>
           <a:xfrm>
-            <a:off x="566928" y="4462272"/>
-            <a:ext cx="32004" cy="420624"/>
+            <a:off x="566928" y="4270248"/>
+            <a:ext cx="32004" cy="356616"/>
           </a:xfrm>
           <a:prstGeom prst="rect">
             <a:avLst/>
@@ -6804,7 +7349,7 @@
         </p:nvSpPr>
         <p:spPr>
           <a:xfrm>
-            <a:off x="694944" y="4631436"/>
+            <a:off x="694944" y="4411980"/>
             <a:ext cx="54864" cy="54864"/>
           </a:xfrm>
           <a:prstGeom prst="ellipse">
@@ -6824,8 +7369,8 @@
         </p:nvSpPr>
         <p:spPr>
           <a:xfrm>
-            <a:off x="859536" y="4526280"/>
-            <a:ext cx="3800704" cy="292608"/>
+            <a:off x="859536" y="4306824"/>
+            <a:ext cx="3800704" cy="283464"/>
           </a:xfrm>
           <a:prstGeom prst="rect">
             <a:avLst/>
@@ -6839,12 +7384,12 @@
           <a:p>
             <a:pPr indent="0" marL="0">
               <a:lnSpc>
-                <a:spcPts val="1650"/>
+                <a:spcPts val="1600"/>
               </a:lnSpc>
               <a:buNone/>
             </a:pPr>
             <a:r>
-              <a:rPr lang="en-US" sz="1200" dirty="0">
+              <a:rPr lang="en-US" sz="1150" dirty="0">
                 <a:solidFill>
                   <a:srgbClr val="363636"/>
                 </a:solidFill>
@@ -6854,7 +7399,7 @@
               </a:rPr>
               <a:t>WP29 第199届会议提案作为法规动态线上推送汽研</a:t>
             </a:r>
-            <a:endParaRPr lang="en-US" sz="1200" dirty="0"/>
+            <a:endParaRPr lang="en-US" sz="1150" dirty="0"/>
           </a:p>
         </p:txBody>
       </p:sp>
@@ -6866,12 +7411,12 @@
         </p:nvSpPr>
         <p:spPr>
           <a:xfrm>
-            <a:off x="548640" y="5056632"/>
-            <a:ext cx="4221328" cy="512064"/>
+            <a:off x="548640" y="4773168"/>
+            <a:ext cx="4221328" cy="448056"/>
           </a:xfrm>
           <a:prstGeom prst="roundRect">
             <a:avLst>
-              <a:gd name="adj" fmla="val 8929"/>
+              <a:gd name="adj" fmla="val 10204"/>
             </a:avLst>
           </a:prstGeom>
           <a:solidFill>
@@ -6893,8 +7438,8 @@
         </p:nvSpPr>
         <p:spPr>
           <a:xfrm>
-            <a:off x="566928" y="5102352"/>
-            <a:ext cx="32004" cy="420624"/>
+            <a:off x="566928" y="4818888"/>
+            <a:ext cx="32004" cy="356616"/>
           </a:xfrm>
           <a:prstGeom prst="rect">
             <a:avLst/>
@@ -6913,7 +7458,7 @@
         </p:nvSpPr>
         <p:spPr>
           <a:xfrm>
-            <a:off x="694944" y="5271516"/>
+            <a:off x="694944" y="4960620"/>
             <a:ext cx="54864" cy="54864"/>
           </a:xfrm>
           <a:prstGeom prst="ellipse">
@@ -6933,8 +7478,8 @@
         </p:nvSpPr>
         <p:spPr>
           <a:xfrm>
-            <a:off x="859536" y="5166360"/>
-            <a:ext cx="3800704" cy="292608"/>
+            <a:off x="859536" y="4855464"/>
+            <a:ext cx="3800704" cy="283464"/>
           </a:xfrm>
           <a:prstGeom prst="rect">
             <a:avLst/>
@@ -6948,12 +7493,12 @@
           <a:p>
             <a:pPr indent="0" marL="0">
               <a:lnSpc>
-                <a:spcPts val="1650"/>
+                <a:spcPts val="1600"/>
               </a:lnSpc>
               <a:buNone/>
             </a:pPr>
             <a:r>
-              <a:rPr lang="en-US" sz="1200" dirty="0">
+              <a:rPr lang="en-US" sz="1150" dirty="0">
                 <a:solidFill>
                   <a:srgbClr val="363636"/>
                 </a:solidFill>
@@ -6963,7 +7508,7 @@
               </a:rPr>
               <a:t>Q2及Q3海外法规监测工作季度总结</a:t>
             </a:r>
-            <a:endParaRPr lang="en-US" sz="1200" dirty="0"/>
+            <a:endParaRPr lang="en-US" sz="1150" dirty="0"/>
           </a:p>
         </p:txBody>
       </p:sp>
@@ -6975,12 +7520,12 @@
         </p:nvSpPr>
         <p:spPr>
           <a:xfrm>
-            <a:off x="548640" y="5696712"/>
-            <a:ext cx="4221328" cy="512064"/>
+            <a:off x="548640" y="5321808"/>
+            <a:ext cx="4221328" cy="448056"/>
           </a:xfrm>
           <a:prstGeom prst="roundRect">
             <a:avLst>
-              <a:gd name="adj" fmla="val 8929"/>
+              <a:gd name="adj" fmla="val 10204"/>
             </a:avLst>
           </a:prstGeom>
           <a:solidFill>
@@ -7002,8 +7547,8 @@
         </p:nvSpPr>
         <p:spPr>
           <a:xfrm>
-            <a:off x="566928" y="5742432"/>
-            <a:ext cx="32004" cy="420624"/>
+            <a:off x="566928" y="5367528"/>
+            <a:ext cx="32004" cy="356616"/>
           </a:xfrm>
           <a:prstGeom prst="rect">
             <a:avLst/>
@@ -7022,7 +7567,7 @@
         </p:nvSpPr>
         <p:spPr>
           <a:xfrm>
-            <a:off x="694944" y="5911596"/>
+            <a:off x="694944" y="5509260"/>
             <a:ext cx="54864" cy="54864"/>
           </a:xfrm>
           <a:prstGeom prst="ellipse">
@@ -7042,8 +7587,8 @@
         </p:nvSpPr>
         <p:spPr>
           <a:xfrm>
-            <a:off x="859536" y="5806440"/>
-            <a:ext cx="3800704" cy="292608"/>
+            <a:off x="859536" y="5404104"/>
+            <a:ext cx="3800704" cy="283464"/>
           </a:xfrm>
           <a:prstGeom prst="rect">
             <a:avLst/>
@@ -7057,12 +7602,12 @@
           <a:p>
             <a:pPr indent="0" marL="0">
               <a:lnSpc>
-                <a:spcPts val="1650"/>
+                <a:spcPts val="1600"/>
               </a:lnSpc>
               <a:buNone/>
             </a:pPr>
             <a:r>
-              <a:rPr lang="en-US" sz="1200" dirty="0">
+              <a:rPr lang="en-US" sz="1150" dirty="0">
                 <a:solidFill>
                   <a:srgbClr val="363636"/>
                 </a:solidFill>
@@ -7072,7 +7617,7 @@
               </a:rPr>
               <a:t>多国法规清单持续补充交付与归类口径答疑</a:t>
             </a:r>
-            <a:endParaRPr lang="en-US" sz="1200" dirty="0"/>
+            <a:endParaRPr lang="en-US" sz="1150" dirty="0"/>
           </a:p>
         </p:txBody>
       </p:sp>
@@ -7174,11 +7719,11 @@
         <p:spPr>
           <a:xfrm>
             <a:off x="5135728" y="2916936"/>
-            <a:ext cx="4221328" cy="512064"/>
+            <a:ext cx="4221328" cy="448056"/>
           </a:xfrm>
           <a:prstGeom prst="roundRect">
             <a:avLst>
-              <a:gd name="adj" fmla="val 8929"/>
+              <a:gd name="adj" fmla="val 10204"/>
             </a:avLst>
           </a:prstGeom>
           <a:solidFill>
@@ -7201,7 +7746,7 @@
         <p:spPr>
           <a:xfrm>
             <a:off x="5154016" y="2962656"/>
-            <a:ext cx="32004" cy="420624"/>
+            <a:ext cx="32004" cy="356616"/>
           </a:xfrm>
           <a:prstGeom prst="rect">
             <a:avLst/>
@@ -7220,7 +7765,7 @@
         </p:nvSpPr>
         <p:spPr>
           <a:xfrm>
-            <a:off x="5282032" y="3131820"/>
+            <a:off x="5282032" y="3104388"/>
             <a:ext cx="54864" cy="54864"/>
           </a:xfrm>
           <a:prstGeom prst="ellipse">
@@ -7240,8 +7785,8 @@
         </p:nvSpPr>
         <p:spPr>
           <a:xfrm>
-            <a:off x="5446624" y="3026664"/>
-            <a:ext cx="3800704" cy="292608"/>
+            <a:off x="5446624" y="2999232"/>
+            <a:ext cx="3800704" cy="283464"/>
           </a:xfrm>
           <a:prstGeom prst="rect">
             <a:avLst/>
@@ -7255,12 +7800,12 @@
           <a:p>
             <a:pPr indent="0" marL="0">
               <a:lnSpc>
-                <a:spcPts val="1650"/>
+                <a:spcPts val="1600"/>
               </a:lnSpc>
               <a:buNone/>
             </a:pPr>
             <a:r>
-              <a:rPr lang="en-US" sz="1200" dirty="0">
+              <a:rPr lang="en-US" sz="1150" dirty="0">
                 <a:solidFill>
                   <a:srgbClr val="363636"/>
                 </a:solidFill>
@@ -7270,7 +7815,7 @@
               </a:rPr>
               <a:t>录制【有问必答】视频</a:t>
             </a:r>
-            <a:endParaRPr lang="en-US" sz="1200" dirty="0"/>
+            <a:endParaRPr lang="en-US" sz="1150" dirty="0"/>
           </a:p>
         </p:txBody>
       </p:sp>
@@ -7282,12 +7827,12 @@
         </p:nvSpPr>
         <p:spPr>
           <a:xfrm>
-            <a:off x="5135728" y="3557016"/>
-            <a:ext cx="4221328" cy="512064"/>
+            <a:off x="5135728" y="3465576"/>
+            <a:ext cx="4221328" cy="448056"/>
           </a:xfrm>
           <a:prstGeom prst="roundRect">
             <a:avLst>
-              <a:gd name="adj" fmla="val 8929"/>
+              <a:gd name="adj" fmla="val 10204"/>
             </a:avLst>
           </a:prstGeom>
           <a:solidFill>
@@ -7309,8 +7854,8 @@
         </p:nvSpPr>
         <p:spPr>
           <a:xfrm>
-            <a:off x="5154016" y="3602736"/>
-            <a:ext cx="32004" cy="420624"/>
+            <a:off x="5154016" y="3511296"/>
+            <a:ext cx="32004" cy="356616"/>
           </a:xfrm>
           <a:prstGeom prst="rect">
             <a:avLst/>
@@ -7329,7 +7874,7 @@
         </p:nvSpPr>
         <p:spPr>
           <a:xfrm>
-            <a:off x="5282032" y="3771900"/>
+            <a:off x="5282032" y="3653028"/>
             <a:ext cx="54864" cy="54864"/>
           </a:xfrm>
           <a:prstGeom prst="ellipse">
@@ -7349,8 +7894,8 @@
         </p:nvSpPr>
         <p:spPr>
           <a:xfrm>
-            <a:off x="5446624" y="3666744"/>
-            <a:ext cx="3800704" cy="292608"/>
+            <a:off x="5446624" y="3547872"/>
+            <a:ext cx="3800704" cy="283464"/>
           </a:xfrm>
           <a:prstGeom prst="rect">
             <a:avLst/>
@@ -7364,12 +7909,12 @@
           <a:p>
             <a:pPr indent="0" marL="0">
               <a:lnSpc>
-                <a:spcPts val="1650"/>
+                <a:spcPts val="1600"/>
               </a:lnSpc>
               <a:buNone/>
             </a:pPr>
             <a:r>
-              <a:rPr lang="en-US" sz="1200" dirty="0">
+              <a:rPr lang="en-US" sz="1150" dirty="0">
                 <a:solidFill>
                   <a:srgbClr val="363636"/>
                 </a:solidFill>
@@ -7379,7 +7924,7 @@
               </a:rPr>
               <a:t>「汽车制造」系列推广文章周更审阅(8-9月共9篇)</a:t>
             </a:r>
-            <a:endParaRPr lang="en-US" sz="1200" dirty="0"/>
+            <a:endParaRPr lang="en-US" sz="1150" dirty="0"/>
           </a:p>
         </p:txBody>
       </p:sp>
@@ -7391,12 +7936,12 @@
         </p:nvSpPr>
         <p:spPr>
           <a:xfrm>
-            <a:off x="5135728" y="4197096"/>
-            <a:ext cx="4221328" cy="512064"/>
+            <a:off x="5135728" y="4014216"/>
+            <a:ext cx="4221328" cy="448056"/>
           </a:xfrm>
           <a:prstGeom prst="roundRect">
             <a:avLst>
-              <a:gd name="adj" fmla="val 8929"/>
+              <a:gd name="adj" fmla="val 10204"/>
             </a:avLst>
           </a:prstGeom>
           <a:solidFill>
@@ -7418,8 +7963,8 @@
         </p:nvSpPr>
         <p:spPr>
           <a:xfrm>
-            <a:off x="5154016" y="4242816"/>
-            <a:ext cx="32004" cy="420624"/>
+            <a:off x="5154016" y="4059936"/>
+            <a:ext cx="32004" cy="356616"/>
           </a:xfrm>
           <a:prstGeom prst="rect">
             <a:avLst/>
@@ -7438,7 +7983,7 @@
         </p:nvSpPr>
         <p:spPr>
           <a:xfrm>
-            <a:off x="5282032" y="4411980"/>
+            <a:off x="5282032" y="4201668"/>
             <a:ext cx="54864" cy="54864"/>
           </a:xfrm>
           <a:prstGeom prst="ellipse">
@@ -7458,8 +8003,8 @@
         </p:nvSpPr>
         <p:spPr>
           <a:xfrm>
-            <a:off x="5446624" y="4306824"/>
-            <a:ext cx="3800704" cy="292608"/>
+            <a:off x="5446624" y="4096512"/>
+            <a:ext cx="3800704" cy="283464"/>
           </a:xfrm>
           <a:prstGeom prst="rect">
             <a:avLst/>
@@ -7473,12 +8018,12 @@
           <a:p>
             <a:pPr indent="0" marL="0">
               <a:lnSpc>
-                <a:spcPts val="1650"/>
+                <a:spcPts val="1600"/>
               </a:lnSpc>
               <a:buNone/>
             </a:pPr>
             <a:r>
-              <a:rPr lang="en-US" sz="1200" dirty="0">
+              <a:rPr lang="en-US" sz="1150" dirty="0">
                 <a:solidFill>
                   <a:srgbClr val="363636"/>
                 </a:solidFill>
@@ -7488,7 +8033,7 @@
               </a:rPr>
               <a:t>EU 2026/1738 循环设计法规直播内容制作支持(大纲/PPT)</a:t>
             </a:r>
-            <a:endParaRPr lang="en-US" sz="1200" dirty="0"/>
+            <a:endParaRPr lang="en-US" sz="1150" dirty="0"/>
           </a:p>
         </p:txBody>
       </p:sp>
@@ -7500,12 +8045,12 @@
         </p:nvSpPr>
         <p:spPr>
           <a:xfrm>
-            <a:off x="5135728" y="4837176"/>
-            <a:ext cx="4221328" cy="512064"/>
+            <a:off x="5135728" y="4562856"/>
+            <a:ext cx="4221328" cy="448056"/>
           </a:xfrm>
           <a:prstGeom prst="roundRect">
             <a:avLst>
-              <a:gd name="adj" fmla="val 8929"/>
+              <a:gd name="adj" fmla="val 10204"/>
             </a:avLst>
           </a:prstGeom>
           <a:solidFill>
@@ -7527,8 +8072,8 @@
         </p:nvSpPr>
         <p:spPr>
           <a:xfrm>
-            <a:off x="5154016" y="4882896"/>
-            <a:ext cx="32004" cy="420624"/>
+            <a:off x="5154016" y="4608576"/>
+            <a:ext cx="32004" cy="356616"/>
           </a:xfrm>
           <a:prstGeom prst="rect">
             <a:avLst/>
@@ -7547,7 +8092,7 @@
         </p:nvSpPr>
         <p:spPr>
           <a:xfrm>
-            <a:off x="5282032" y="5052060"/>
+            <a:off x="5282032" y="4750308"/>
             <a:ext cx="54864" cy="54864"/>
           </a:xfrm>
           <a:prstGeom prst="ellipse">
@@ -7567,8 +8112,8 @@
         </p:nvSpPr>
         <p:spPr>
           <a:xfrm>
-            <a:off x="5446624" y="4946904"/>
-            <a:ext cx="3800704" cy="292608"/>
+            <a:off x="5446624" y="4645152"/>
+            <a:ext cx="3800704" cy="283464"/>
           </a:xfrm>
           <a:prstGeom prst="rect">
             <a:avLst/>
@@ -7582,12 +8127,12 @@
           <a:p>
             <a:pPr indent="0" marL="0">
               <a:lnSpc>
-                <a:spcPts val="1650"/>
+                <a:spcPts val="1600"/>
               </a:lnSpc>
               <a:buNone/>
             </a:pPr>
             <a:r>
-              <a:rPr lang="en-US" sz="1200" dirty="0">
+              <a:rPr lang="en-US" sz="1150" dirty="0">
                 <a:solidFill>
                   <a:srgbClr val="363636"/>
                 </a:solidFill>
@@ -7597,13 +8142,122 @@
               </a:rPr>
               <a:t>法规月报按时分发至汽研客户并跟进反馈</a:t>
             </a:r>
-            <a:endParaRPr lang="en-US" sz="1200" dirty="0"/>
+            <a:endParaRPr lang="en-US" sz="1150" dirty="0"/>
           </a:p>
         </p:txBody>
       </p:sp>
       <p:sp>
         <p:nvSpPr>
           <p:cNvPr id="47" name="Shape 43"/>
+          <p:cNvSpPr/>
+          <p:nvPr/>
+        </p:nvSpPr>
+        <p:spPr>
+          <a:xfrm>
+            <a:off x="5135728" y="5111496"/>
+            <a:ext cx="4221328" cy="448056"/>
+          </a:xfrm>
+          <a:prstGeom prst="roundRect">
+            <a:avLst>
+              <a:gd name="adj" fmla="val 10204"/>
+            </a:avLst>
+          </a:prstGeom>
+          <a:solidFill>
+            <a:srgbClr val="FFFFFF"/>
+          </a:solidFill>
+          <a:ln w="9525">
+            <a:solidFill>
+              <a:srgbClr val="E8E8E8"/>
+            </a:solidFill>
+            <a:prstDash val="solid"/>
+          </a:ln>
+        </p:spPr>
+      </p:sp>
+      <p:sp>
+        <p:nvSpPr>
+          <p:cNvPr id="48" name="Shape 44"/>
+          <p:cNvSpPr/>
+          <p:nvPr/>
+        </p:nvSpPr>
+        <p:spPr>
+          <a:xfrm>
+            <a:off x="5154016" y="5157216"/>
+            <a:ext cx="32004" cy="356616"/>
+          </a:xfrm>
+          <a:prstGeom prst="rect">
+            <a:avLst/>
+          </a:prstGeom>
+          <a:solidFill>
+            <a:srgbClr val="FF6600"/>
+          </a:solidFill>
+          <a:ln/>
+        </p:spPr>
+      </p:sp>
+      <p:sp>
+        <p:nvSpPr>
+          <p:cNvPr id="49" name="Shape 45"/>
+          <p:cNvSpPr/>
+          <p:nvPr/>
+        </p:nvSpPr>
+        <p:spPr>
+          <a:xfrm>
+            <a:off x="5282032" y="5298948"/>
+            <a:ext cx="54864" cy="54864"/>
+          </a:xfrm>
+          <a:prstGeom prst="ellipse">
+            <a:avLst/>
+          </a:prstGeom>
+          <a:solidFill>
+            <a:srgbClr val="FF6600"/>
+          </a:solidFill>
+          <a:ln/>
+        </p:spPr>
+      </p:sp>
+      <p:sp>
+        <p:nvSpPr>
+          <p:cNvPr id="50" name="Text 46"/>
+          <p:cNvSpPr txBox="1"/>
+          <p:nvPr/>
+        </p:nvSpPr>
+        <p:spPr>
+          <a:xfrm>
+            <a:off x="5446624" y="5193792"/>
+            <a:ext cx="3800704" cy="283464"/>
+          </a:xfrm>
+          <a:prstGeom prst="rect">
+            <a:avLst/>
+          </a:prstGeom>
+          <a:noFill/>
+          <a:ln/>
+        </p:spPr>
+        <p:txBody>
+          <a:bodyPr wrap="square" lIns="0" tIns="0" rIns="0" bIns="0" rtlCol="0" anchor="t"/>
+          <a:lstStyle/>
+          <a:p>
+            <a:pPr indent="0" marL="0">
+              <a:lnSpc>
+                <a:spcPts val="1600"/>
+              </a:lnSpc>
+              <a:buNone/>
+            </a:pPr>
+            <a:r>
+              <a:rPr lang="en-US" sz="1150" dirty="0">
+                <a:solidFill>
+                  <a:srgbClr val="363636"/>
+                </a:solidFill>
+                <a:latin typeface="Arial" pitchFamily="34" charset="0"/>
+                <a:ea typeface="Arial" pitchFamily="34" charset="-122"/>
+                <a:cs typeface="Arial" pitchFamily="34" charset="-120"/>
+              </a:rPr>
+              <a:t>月报 Spotlight 专题内容策划与选题调整</a:t>
+            </a:r>
+            <a:endParaRPr lang="en-US" sz="1150" dirty="0"/>
+          </a:p>
+        </p:txBody>
+      </p:sp>
+      <p:sp>
+        <p:nvSpPr>
+          <p:cNvPr id="51" name="Shape 47"/>
           <p:cNvSpPr/>
           <p:nvPr/>
         </p:nvSpPr>
@@ -7626,7 +8280,7 @@
       </p:sp>
       <p:sp>
         <p:nvSpPr>
-          <p:cNvPr id="48" name="Shape 44"/>
+          <p:cNvPr id="52" name="Shape 48"/>
           <p:cNvSpPr/>
           <p:nvPr/>
         </p:nvSpPr>
@@ -7646,7 +8300,7 @@
       </p:sp>
       <p:sp>
         <p:nvSpPr>
-          <p:cNvPr id="49" name="Text 45"/>
+          <p:cNvPr id="53" name="Text 49"/>
           <p:cNvSpPr txBox="1"/>
           <p:nvPr/>
         </p:nvSpPr>
@@ -8271,6 +8925,226 @@
         </p:nvSpPr>
         <p:spPr>
           <a:xfrm>
+            <a:off x="548640" y="4818888"/>
+            <a:ext cx="8808415" cy="512064"/>
+          </a:xfrm>
+          <a:prstGeom prst="roundRect">
+            <a:avLst>
+              <a:gd name="adj" fmla="val 8036"/>
+            </a:avLst>
+          </a:prstGeom>
+          <a:solidFill>
+            <a:srgbClr val="FFFFFF"/>
+          </a:solidFill>
+          <a:ln w="9525">
+            <a:solidFill>
+              <a:srgbClr val="E8E8E8"/>
+            </a:solidFill>
+            <a:prstDash val="solid"/>
+          </a:ln>
+        </p:spPr>
+      </p:sp>
+      <p:sp>
+        <p:nvSpPr>
+          <p:cNvPr id="22" name="Shape 16"/>
+          <p:cNvSpPr/>
+          <p:nvPr/>
+        </p:nvSpPr>
+        <p:spPr>
+          <a:xfrm>
+            <a:off x="566928" y="4855464"/>
+            <a:ext cx="32004" cy="438912"/>
+          </a:xfrm>
+          <a:prstGeom prst="rect">
+            <a:avLst/>
+          </a:prstGeom>
+          <a:solidFill>
+            <a:srgbClr val="FF6600"/>
+          </a:solidFill>
+          <a:ln/>
+        </p:spPr>
+      </p:sp>
+      <p:pic>
+        <p:nvPicPr>
+          <p:cNvPr id="23" name="Image 4" descr="/tmp/pptx_work/icons/check.png">    </p:cNvPr>
+          <p:cNvPicPr>
+            <a:picLocks noChangeAspect="1"/>
+          </p:cNvPicPr>
+          <p:nvPr/>
+        </p:nvPicPr>
+        <p:blipFill>
+          <a:blip r:embed="rId6"/>
+          <a:stretch>
+            <a:fillRect/>
+          </a:stretch>
+        </p:blipFill>
+        <p:spPr>
+          <a:xfrm>
+            <a:off x="676656" y="4910328"/>
+            <a:ext cx="329184" cy="329184"/>
+          </a:xfrm>
+          <a:prstGeom prst="rect">
+            <a:avLst/>
+          </a:prstGeom>
+        </p:spPr>
+      </p:pic>
+      <p:sp>
+        <p:nvSpPr>
+          <p:cNvPr id="24" name="Text 17"/>
+          <p:cNvSpPr txBox="1"/>
+          <p:nvPr/>
+        </p:nvSpPr>
+        <p:spPr>
+          <a:xfrm>
+            <a:off x="1188720" y="4818888"/>
+            <a:ext cx="7985455" cy="512064"/>
+          </a:xfrm>
+          <a:prstGeom prst="rect">
+            <a:avLst/>
+          </a:prstGeom>
+          <a:noFill/>
+          <a:ln/>
+        </p:spPr>
+        <p:txBody>
+          <a:bodyPr wrap="square" lIns="0" tIns="0" rIns="0" bIns="0" rtlCol="0" anchor="ctr"/>
+          <a:lstStyle/>
+          <a:p>
+            <a:pPr indent="0" marL="0">
+              <a:buNone/>
+            </a:pPr>
+            <a:r>
+              <a:rPr lang="en-US" sz="1150" dirty="0">
+                <a:solidFill>
+                  <a:srgbClr val="363636"/>
+                </a:solidFill>
+                <a:latin typeface="Arial" pitchFamily="34" charset="0"/>
+                <a:ea typeface="Arial" pitchFamily="34" charset="-122"/>
+                <a:cs typeface="Arial" pitchFamily="34" charset="-120"/>
+              </a:rPr>
+              <a:t>配合 Q4 海外法规监测季度总结</a:t>
+            </a:r>
+            <a:endParaRPr lang="en-US" sz="1150" dirty="0"/>
+          </a:p>
+        </p:txBody>
+      </p:sp>
+      <p:sp>
+        <p:nvSpPr>
+          <p:cNvPr id="25" name="Shape 18"/>
+          <p:cNvSpPr/>
+          <p:nvPr/>
+        </p:nvSpPr>
+        <p:spPr>
+          <a:xfrm>
+            <a:off x="548640" y="5440680"/>
+            <a:ext cx="8808415" cy="512064"/>
+          </a:xfrm>
+          <a:prstGeom prst="roundRect">
+            <a:avLst>
+              <a:gd name="adj" fmla="val 8036"/>
+            </a:avLst>
+          </a:prstGeom>
+          <a:solidFill>
+            <a:srgbClr val="FFFFFF"/>
+          </a:solidFill>
+          <a:ln w="9525">
+            <a:solidFill>
+              <a:srgbClr val="E8E8E8"/>
+            </a:solidFill>
+            <a:prstDash val="solid"/>
+          </a:ln>
+        </p:spPr>
+      </p:sp>
+      <p:sp>
+        <p:nvSpPr>
+          <p:cNvPr id="26" name="Shape 19"/>
+          <p:cNvSpPr/>
+          <p:nvPr/>
+        </p:nvSpPr>
+        <p:spPr>
+          <a:xfrm>
+            <a:off x="566928" y="5477256"/>
+            <a:ext cx="32004" cy="438912"/>
+          </a:xfrm>
+          <a:prstGeom prst="rect">
+            <a:avLst/>
+          </a:prstGeom>
+          <a:solidFill>
+            <a:srgbClr val="FF6600"/>
+          </a:solidFill>
+          <a:ln/>
+        </p:spPr>
+      </p:sp>
+      <p:pic>
+        <p:nvPicPr>
+          <p:cNvPr id="27" name="Image 5" descr="/tmp/pptx_work/icons/check.png">    </p:cNvPr>
+          <p:cNvPicPr>
+            <a:picLocks noChangeAspect="1"/>
+          </p:cNvPicPr>
+          <p:nvPr/>
+        </p:nvPicPr>
+        <p:blipFill>
+          <a:blip r:embed="rId7"/>
+          <a:stretch>
+            <a:fillRect/>
+          </a:stretch>
+        </p:blipFill>
+        <p:spPr>
+          <a:xfrm>
+            <a:off x="676656" y="5532120"/>
+            <a:ext cx="329184" cy="329184"/>
+          </a:xfrm>
+          <a:prstGeom prst="rect">
+            <a:avLst/>
+          </a:prstGeom>
+        </p:spPr>
+      </p:pic>
+      <p:sp>
+        <p:nvSpPr>
+          <p:cNvPr id="28" name="Text 20"/>
+          <p:cNvSpPr txBox="1"/>
+          <p:nvPr/>
+        </p:nvSpPr>
+        <p:spPr>
+          <a:xfrm>
+            <a:off x="1188720" y="5440680"/>
+            <a:ext cx="7985455" cy="512064"/>
+          </a:xfrm>
+          <a:prstGeom prst="rect">
+            <a:avLst/>
+          </a:prstGeom>
+          <a:noFill/>
+          <a:ln/>
+        </p:spPr>
+        <p:txBody>
+          <a:bodyPr wrap="square" lIns="0" tIns="0" rIns="0" bIns="0" rtlCol="0" anchor="ctr"/>
+          <a:lstStyle/>
+          <a:p>
+            <a:pPr indent="0" marL="0">
+              <a:buNone/>
+            </a:pPr>
+            <a:r>
+              <a:rPr lang="en-US" sz="1150" dirty="0">
+                <a:solidFill>
+                  <a:srgbClr val="363636"/>
+                </a:solidFill>
+                <a:latin typeface="Arial" pitchFamily="34" charset="0"/>
+                <a:ea typeface="Arial" pitchFamily="34" charset="-122"/>
+                <a:cs typeface="Arial" pitchFamily="34" charset="-120"/>
+              </a:rPr>
+              <a:t>汽车制造系列推广文章持续审阅与内容支持</a:t>
+            </a:r>
+            <a:endParaRPr lang="en-US" sz="1150" dirty="0"/>
+          </a:p>
+        </p:txBody>
+      </p:sp>
+      <p:sp>
+        <p:nvSpPr>
+          <p:cNvPr id="29" name="Shape 21"/>
+          <p:cNvSpPr/>
+          <p:nvPr/>
+        </p:nvSpPr>
+        <p:spPr>
+          <a:xfrm>
             <a:off x="0" y="6803136"/>
             <a:ext cx="9905695" cy="54864"/>
           </a:xfrm>
@@ -8285,7 +9159,7 @@
       </p:sp>
       <p:sp>
         <p:nvSpPr>
-          <p:cNvPr id="22" name="Text 16"/>
+          <p:cNvPr id="30" name="Text 22"/>
           <p:cNvSpPr txBox="1"/>
           <p:nvPr/>
         </p:nvSpPr>

</xml_diff>

<commit_message>
Add E-mark tool highlights slide with real tool screenshots
Co-Authored-By: Claude Sonnet 5 <noreply@anthropic.com>
Claude-Session: https://claude.ai/code/session_015nf3knxVoVVLYAWgtjzRg9
</commit_message>
<xml_diff>
--- a/2026年8-9月工作汇报.pptx
+++ b/2026年8-9月工作汇报.pptx
@@ -11,9 +11,10 @@
     <p:sldId id="259" r:id="rId5"/>
     <p:sldId id="260" r:id="rId6"/>
     <p:sldId id="261" r:id="rId7"/>
+    <p:sldId id="262" r:id="rId8"/>
   </p:sldIdLst>
   <p:notesMasterIdLst>
-    <p:notesMasterId r:id="rId8"/>
+    <p:notesMasterId r:id="rId9"/>
   </p:notesMasterIdLst>
   <p:sldSz cx="9905695" cy="6858000"/>
   <p:notesSz cx="6858000" cy="9905695"/>
@@ -989,6 +990,94 @@
 </p:notes>
 </file>
 
+<file path=ppt/notesSlides/notesSlide7.xml><?xml version="1.0" encoding="utf-8"?>
+<p:notes xmlns:a="http://schemas.openxmlformats.org/drawingml/2006/main" xmlns:r="http://schemas.openxmlformats.org/officeDocument/2006/relationships" xmlns:p="http://schemas.openxmlformats.org/presentationml/2006/main">
+  <p:cSld>
+    <p:spTree>
+      <p:nvGrpSpPr>
+        <p:cNvPr id="1" name=""/>
+        <p:cNvGrpSpPr/>
+        <p:nvPr/>
+      </p:nvGrpSpPr>
+      <p:grpSpPr>
+        <a:xfrm>
+          <a:off x="0" y="0"/>
+          <a:ext cx="0" cy="0"/>
+          <a:chOff x="0" y="0"/>
+          <a:chExt cx="0" cy="0"/>
+        </a:xfrm>
+      </p:grpSpPr>
+      <p:sp>
+        <p:nvSpPr>
+          <p:cNvPr id="2" name="Slide Image Placeholder 1"/>
+          <p:cNvSpPr>
+            <a:spLocks noGrp="1" noRot="1" noChangeAspect="1"/>
+          </p:cNvSpPr>
+          <p:nvPr>
+            <p:ph type="sldImg"/>
+          </p:nvPr>
+        </p:nvSpPr>
+        <p:spPr/>
+      </p:sp>
+      <p:sp>
+        <p:nvSpPr>
+          <p:cNvPr id="3" name="Notes Placeholder 2"/>
+          <p:cNvSpPr>
+            <a:spLocks noGrp="1"/>
+          </p:cNvSpPr>
+          <p:nvPr>
+            <p:ph type="body" idx="1"/>
+          </p:nvPr>
+        </p:nvSpPr>
+        <p:spPr/>
+        <p:txBody>
+          <a:bodyPr/>
+          <a:lstStyle/>
+          <a:p>
+            <a:r>
+              <a:rPr lang="en-US" dirty="0"/>
+              <a:t/>
+            </a:r>
+            <a:endParaRPr lang="en-US" dirty="0"/>
+          </a:p>
+        </p:txBody>
+      </p:sp>
+      <p:sp>
+        <p:nvSpPr>
+          <p:cNvPr id="4" name="Slide Number Placeholder 3"/>
+          <p:cNvSpPr>
+            <a:spLocks noGrp="1"/>
+          </p:cNvSpPr>
+          <p:nvPr>
+            <p:ph type="sldNum" sz="quarter" idx="10"/>
+          </p:nvPr>
+        </p:nvSpPr>
+        <p:spPr/>
+        <p:txBody>
+          <a:bodyPr/>
+          <a:lstStyle/>
+          <a:p>
+            <a:fld id="{F7021451-1387-4CA6-816F-3879F97B5CBC}" type="slidenum">
+              <a:rPr lang="en-US"/>
+              <a:t>7</a:t>
+            </a:fld>
+            <a:endParaRPr lang="en-US"/>
+          </a:p>
+        </p:txBody>
+      </p:sp>
+    </p:spTree>
+    <p:extLst>
+      <p:ext uri="{BB962C8B-B14F-4D97-AF65-F5344CB8AC3E}">
+        <p14:creationId xmlns:p14="http://schemas.microsoft.com/office/powerpoint/2010/main" val="1024086991"/>
+      </p:ext>
+    </p:extLst>
+  </p:cSld>
+  <p:clrMapOvr>
+    <a:masterClrMapping/>
+  </p:clrMapOvr>
+</p:notes>
+</file>
+
 <file path=ppt/slideLayouts/slideLayout1.xml><?xml version="1.0" encoding="utf-8"?>
 <p:sldLayout xmlns:a="http://schemas.openxmlformats.org/drawingml/2006/main" xmlns:r="http://schemas.openxmlformats.org/officeDocument/2006/relationships" xmlns:p="http://schemas.openxmlformats.org/presentationml/2006/main" preserve="1">
   <p:cSld name="DEFAULT">
@@ -2222,7 +2311,7 @@
                 <a:ea typeface="Arial" pitchFamily="34" charset="-122"/>
                 <a:cs typeface="Arial" pitchFamily="34" charset="-120"/>
               </a:rPr>
-              <a:t>1/6</a:t>
+              <a:t>1/7</a:t>
             </a:r>
             <a:endParaRPr lang="en-US" sz="900" dirty="0"/>
           </a:p>
@@ -3643,7 +3732,7 @@
                 <a:ea typeface="Arial" pitchFamily="34" charset="-122"/>
                 <a:cs typeface="Arial" pitchFamily="34" charset="-120"/>
               </a:rPr>
-              <a:t>2/6</a:t>
+              <a:t>2/7</a:t>
             </a:r>
             <a:endParaRPr lang="en-US" sz="900" dirty="0"/>
           </a:p>
@@ -5351,7 +5440,7 @@
                 <a:ea typeface="Arial" pitchFamily="34" charset="-122"/>
                 <a:cs typeface="Arial" pitchFamily="34" charset="-120"/>
               </a:rPr>
-              <a:t>3/6</a:t>
+              <a:t>3/7</a:t>
             </a:r>
             <a:endParaRPr lang="en-US" sz="900" dirty="0"/>
           </a:p>
@@ -6841,7 +6930,7 @@
                 <a:ea typeface="Arial" pitchFamily="34" charset="-122"/>
                 <a:cs typeface="Arial" pitchFamily="34" charset="-120"/>
               </a:rPr>
-              <a:t>4/6</a:t>
+              <a:t>4/7</a:t>
             </a:r>
             <a:endParaRPr lang="en-US" sz="900" dirty="0"/>
           </a:p>
@@ -6919,7 +7008,7 @@
                 <a:ea typeface="Arial" pitchFamily="34" charset="-122"/>
                 <a:cs typeface="Arial" pitchFamily="34" charset="-120"/>
               </a:rPr>
-              <a:t>第三部分 · 市场支持情况</a:t>
+              <a:t>第二部分 · 非项目情况 · 工具亮点</a:t>
             </a:r>
             <a:endParaRPr lang="en-US" sz="1050" dirty="0"/>
           </a:p>
@@ -6958,7 +7047,7 @@
                 <a:ea typeface="Georgia" pitchFamily="34" charset="-122"/>
                 <a:cs typeface="Georgia" pitchFamily="34" charset="-120"/>
               </a:rPr>
-              <a:t>市场支持情况</a:t>
+              <a:t>E-mark 合规工具亮点</a:t>
             </a:r>
             <a:endParaRPr lang="en-US" sz="1900" dirty="0"/>
           </a:p>
@@ -6987,9 +7076,95 @@
           </a:ln>
         </p:spPr>
       </p:sp>
+      <p:sp>
+        <p:nvSpPr>
+          <p:cNvPr id="5" name="Text 3"/>
+          <p:cNvSpPr txBox="1"/>
+          <p:nvPr/>
+        </p:nvSpPr>
+        <p:spPr>
+          <a:xfrm>
+            <a:off x="548640" y="2304288"/>
+            <a:ext cx="8808415" cy="274320"/>
+          </a:xfrm>
+          <a:prstGeom prst="rect">
+            <a:avLst/>
+          </a:prstGeom>
+          <a:noFill/>
+          <a:ln/>
+        </p:spPr>
+        <p:txBody>
+          <a:bodyPr wrap="square" lIns="0" tIns="0" rIns="0" bIns="0" rtlCol="0" anchor="ctr"/>
+          <a:lstStyle/>
+          <a:p>
+            <a:pPr indent="0" marL="0">
+              <a:buNone/>
+            </a:pPr>
+            <a:r>
+              <a:rPr lang="en-US" sz="1100" dirty="0">
+                <a:solidFill>
+                  <a:srgbClr val="848685"/>
+                </a:solidFill>
+                <a:latin typeface="Arial" pitchFamily="34" charset="0"/>
+                <a:ea typeface="Arial" pitchFamily="34" charset="-122"/>
+                <a:cs typeface="Arial" pitchFamily="34" charset="-120"/>
+              </a:rPr>
+              <a:t>覆盖整车/系统/部件三类角色,逐条自评联动多国认证结论,专项评估模块按法规持续扩展。</a:t>
+            </a:r>
+            <a:endParaRPr lang="en-US" sz="1100" dirty="0"/>
+          </a:p>
+        </p:txBody>
+      </p:sp>
+      <p:sp>
+        <p:nvSpPr>
+          <p:cNvPr id="6" name="Shape 4"/>
+          <p:cNvSpPr/>
+          <p:nvPr/>
+        </p:nvSpPr>
+        <p:spPr>
+          <a:xfrm>
+            <a:off x="548640" y="2642616"/>
+            <a:ext cx="4645152" cy="2645664"/>
+          </a:xfrm>
+          <a:prstGeom prst="roundRect">
+            <a:avLst>
+              <a:gd name="adj" fmla="val 2074"/>
+            </a:avLst>
+          </a:prstGeom>
+          <a:solidFill>
+            <a:srgbClr val="FFFFFF"/>
+          </a:solidFill>
+          <a:ln w="9525">
+            <a:solidFill>
+              <a:srgbClr val="E8E8E8"/>
+            </a:solidFill>
+            <a:prstDash val="solid"/>
+          </a:ln>
+        </p:spPr>
+      </p:sp>
+      <p:sp>
+        <p:nvSpPr>
+          <p:cNvPr id="7" name="Shape 5"/>
+          <p:cNvSpPr/>
+          <p:nvPr/>
+        </p:nvSpPr>
+        <p:spPr>
+          <a:xfrm>
+            <a:off x="548640" y="2642616"/>
+            <a:ext cx="4645152" cy="45720"/>
+          </a:xfrm>
+          <a:prstGeom prst="rect">
+            <a:avLst/>
+          </a:prstGeom>
+          <a:solidFill>
+            <a:srgbClr val="FF6600"/>
+          </a:solidFill>
+          <a:ln/>
+        </p:spPr>
+      </p:sp>
       <p:pic>
         <p:nvPicPr>
-          <p:cNvPr id="5" name="Image 0" descr="/tmp/pptx_work/icons/search.png">    </p:cNvPr>
+          <p:cNvPr id="8" name="Image 0" descr="/tmp/pptx_work/screenshots/c1_landing.png">    </p:cNvPr>
           <p:cNvPicPr>
             <a:picLocks noChangeAspect="1"/>
           </p:cNvPicPr>
@@ -7003,8 +7178,8 @@
         </p:blipFill>
         <p:spPr>
           <a:xfrm>
-            <a:off x="548640" y="2331720"/>
-            <a:ext cx="384048" cy="384048"/>
+            <a:off x="676656" y="2770632"/>
+            <a:ext cx="4389120" cy="1859280"/>
           </a:xfrm>
           <a:prstGeom prst="rect">
             <a:avLst/>
@@ -7013,33 +7188,56 @@
       </p:pic>
       <p:sp>
         <p:nvSpPr>
-          <p:cNvPr id="6" name="Text 3"/>
+          <p:cNvPr id="9" name="Shape 6"/>
+          <p:cNvSpPr/>
+          <p:nvPr/>
+        </p:nvSpPr>
+        <p:spPr>
+          <a:xfrm>
+            <a:off x="676656" y="4684776"/>
+            <a:ext cx="4389120" cy="0"/>
+          </a:xfrm>
+          <a:prstGeom prst="line">
+            <a:avLst/>
+          </a:prstGeom>
+          <a:noFill/>
+          <a:ln w="6350">
+            <a:solidFill>
+              <a:srgbClr val="E0E0E0"/>
+            </a:solidFill>
+            <a:prstDash val="solid"/>
+          </a:ln>
+        </p:spPr>
+      </p:sp>
+      <p:sp>
+        <p:nvSpPr>
+          <p:cNvPr id="10" name="Text 7"/>
           <p:cNvSpPr txBox="1"/>
           <p:nvPr/>
         </p:nvSpPr>
         <p:spPr>
           <a:xfrm>
-            <a:off x="1042416" y="2313432"/>
-            <a:ext cx="3727552" cy="420624"/>
-          </a:xfrm>
-          <a:prstGeom prst="rect">
-            <a:avLst/>
-          </a:prstGeom>
-          <a:noFill/>
-          <a:ln/>
-        </p:spPr>
-        <p:txBody>
-          <a:bodyPr wrap="square" lIns="0" tIns="0" rIns="0" bIns="0" rtlCol="0" anchor="ctr"/>
+            <a:off x="676656" y="4739640"/>
+            <a:ext cx="4389120" cy="457200"/>
+          </a:xfrm>
+          <a:prstGeom prst="rect">
+            <a:avLst/>
+          </a:prstGeom>
+          <a:noFill/>
+          <a:ln/>
+        </p:spPr>
+        <p:txBody>
+          <a:bodyPr wrap="square" lIns="0" tIns="0" rIns="0" bIns="0" rtlCol="0" anchor="t"/>
           <a:lstStyle/>
           <a:p>
             <a:pPr indent="0" marL="0">
               <a:lnSpc>
-                <a:spcPts val="1500"/>
+                <a:spcPts val="1400"/>
               </a:lnSpc>
               <a:buNone/>
             </a:pPr>
             <a:r>
-              <a:rPr lang="en-US" sz="1300" b="1" dirty="0">
+              <a:rPr lang="en-US" sz="1050" dirty="0">
                 <a:solidFill>
                   <a:srgbClr val="363636"/>
                 </a:solidFill>
@@ -7047,49 +7245,26 @@
                 <a:ea typeface="Arial" pitchFamily="34" charset="-122"/>
                 <a:cs typeface="Arial" pitchFamily="34" charset="-120"/>
               </a:rPr>
-              <a:t>法规检索与数据交付(对接汽研)</a:t>
-            </a:r>
-            <a:endParaRPr lang="en-US" sz="1300" dirty="0"/>
-          </a:p>
-        </p:txBody>
-      </p:sp>
-      <p:sp>
-        <p:nvSpPr>
-          <p:cNvPr id="7" name="Shape 4"/>
-          <p:cNvSpPr/>
-          <p:nvPr/>
-        </p:nvSpPr>
-        <p:spPr>
-          <a:xfrm>
-            <a:off x="548640" y="2788920"/>
-            <a:ext cx="4221328" cy="0"/>
-          </a:xfrm>
-          <a:prstGeom prst="line">
-            <a:avLst/>
-          </a:prstGeom>
-          <a:noFill/>
-          <a:ln w="19050">
-            <a:solidFill>
-              <a:srgbClr val="FF6600"/>
-            </a:solidFill>
-            <a:prstDash val="solid"/>
-          </a:ln>
-        </p:spPr>
-      </p:sp>
-      <p:sp>
-        <p:nvSpPr>
-          <p:cNvPr id="8" name="Shape 5"/>
-          <p:cNvSpPr/>
-          <p:nvPr/>
-        </p:nvSpPr>
-        <p:spPr>
-          <a:xfrm>
-            <a:off x="548640" y="2916936"/>
-            <a:ext cx="4221328" cy="658368"/>
+              <a:t>六步智能导航:企业画像→范围界定→法规盘点→体系自评→认证旅程→行动清单,全流程闭环</a:t>
+            </a:r>
+            <a:endParaRPr lang="en-US" sz="1050" dirty="0"/>
+          </a:p>
+        </p:txBody>
+      </p:sp>
+      <p:sp>
+        <p:nvSpPr>
+          <p:cNvPr id="11" name="Shape 8"/>
+          <p:cNvSpPr/>
+          <p:nvPr/>
+        </p:nvSpPr>
+        <p:spPr>
+          <a:xfrm>
+            <a:off x="5468112" y="2642616"/>
+            <a:ext cx="3319272" cy="4085258"/>
           </a:xfrm>
           <a:prstGeom prst="roundRect">
             <a:avLst>
-              <a:gd name="adj" fmla="val 6944"/>
+              <a:gd name="adj" fmla="val 1653"/>
             </a:avLst>
           </a:prstGeom>
           <a:solidFill>
@@ -7105,14 +7280,14 @@
       </p:sp>
       <p:sp>
         <p:nvSpPr>
-          <p:cNvPr id="9" name="Shape 6"/>
-          <p:cNvSpPr/>
-          <p:nvPr/>
-        </p:nvSpPr>
-        <p:spPr>
-          <a:xfrm>
-            <a:off x="566928" y="2962656"/>
-            <a:ext cx="32004" cy="566928"/>
+          <p:cNvPr id="12" name="Shape 9"/>
+          <p:cNvSpPr/>
+          <p:nvPr/>
+        </p:nvSpPr>
+        <p:spPr>
+          <a:xfrm>
+            <a:off x="5468112" y="2642616"/>
+            <a:ext cx="3319272" cy="45720"/>
           </a:xfrm>
           <a:prstGeom prst="rect">
             <a:avLst/>
@@ -7123,36 +7298,63 @@
           <a:ln/>
         </p:spPr>
       </p:sp>
-      <p:sp>
-        <p:nvSpPr>
-          <p:cNvPr id="10" name="Shape 7"/>
-          <p:cNvSpPr/>
-          <p:nvPr/>
-        </p:nvSpPr>
-        <p:spPr>
-          <a:xfrm>
-            <a:off x="694944" y="3104388"/>
-            <a:ext cx="54864" cy="54864"/>
-          </a:xfrm>
-          <a:prstGeom prst="ellipse">
-            <a:avLst/>
-          </a:prstGeom>
-          <a:solidFill>
-            <a:srgbClr val="FF6600"/>
-          </a:solidFill>
-          <a:ln/>
-        </p:spPr>
-      </p:sp>
-      <p:sp>
-        <p:nvSpPr>
-          <p:cNvPr id="11" name="Text 8"/>
+      <p:pic>
+        <p:nvPicPr>
+          <p:cNvPr id="13" name="Image 1" descr="/tmp/pptx_work/screenshots/c2_conclusion.png">    </p:cNvPr>
+          <p:cNvPicPr>
+            <a:picLocks noChangeAspect="1"/>
+          </p:cNvPicPr>
+          <p:nvPr/>
+        </p:nvPicPr>
+        <p:blipFill>
+          <a:blip r:embed="rId3"/>
+          <a:stretch>
+            <a:fillRect/>
+          </a:stretch>
+        </p:blipFill>
+        <p:spPr>
+          <a:xfrm>
+            <a:off x="5596128" y="2770632"/>
+            <a:ext cx="3063240" cy="3298874"/>
+          </a:xfrm>
+          <a:prstGeom prst="rect">
+            <a:avLst/>
+          </a:prstGeom>
+        </p:spPr>
+      </p:pic>
+      <p:sp>
+        <p:nvSpPr>
+          <p:cNvPr id="14" name="Shape 10"/>
+          <p:cNvSpPr/>
+          <p:nvPr/>
+        </p:nvSpPr>
+        <p:spPr>
+          <a:xfrm>
+            <a:off x="5596128" y="6124370"/>
+            <a:ext cx="3063240" cy="0"/>
+          </a:xfrm>
+          <a:prstGeom prst="line">
+            <a:avLst/>
+          </a:prstGeom>
+          <a:noFill/>
+          <a:ln w="6350">
+            <a:solidFill>
+              <a:srgbClr val="E0E0E0"/>
+            </a:solidFill>
+            <a:prstDash val="solid"/>
+          </a:ln>
+        </p:spPr>
+      </p:sp>
+      <p:sp>
+        <p:nvSpPr>
+          <p:cNvPr id="15" name="Text 11"/>
           <p:cNvSpPr txBox="1"/>
           <p:nvPr/>
         </p:nvSpPr>
         <p:spPr>
           <a:xfrm>
-            <a:off x="859536" y="2999232"/>
-            <a:ext cx="3800704" cy="493776"/>
+            <a:off x="5596128" y="6179234"/>
+            <a:ext cx="3063240" cy="457200"/>
           </a:xfrm>
           <a:prstGeom prst="rect">
             <a:avLst/>
@@ -7166,12 +7368,12 @@
           <a:p>
             <a:pPr indent="0" marL="0">
               <a:lnSpc>
-                <a:spcPts val="1600"/>
+                <a:spcPts val="1400"/>
               </a:lnSpc>
               <a:buNone/>
             </a:pPr>
             <a:r>
-              <a:rPr lang="en-US" sz="1150" dirty="0">
+              <a:rPr lang="en-US" sz="1050" dirty="0">
                 <a:solidFill>
                   <a:srgbClr val="363636"/>
                 </a:solidFill>
@@ -7179,1108 +7381,15 @@
                 <a:ea typeface="Arial" pitchFamily="34" charset="-122"/>
                 <a:cs typeface="Arial" pitchFamily="34" charset="-120"/>
               </a:rPr>
-              <a:t>拉美/北美七国(墨西哥/哥伦比亚/巴西/阿根廷/智利/秘鲁/美国/加拿大)充电插头插座标准检索,交付 Excel 数据表 + 原文压缩包</a:t>
-            </a:r>
-            <a:endParaRPr lang="en-US" sz="1150" dirty="0"/>
-          </a:p>
-        </p:txBody>
-      </p:sp>
-      <p:sp>
-        <p:nvSpPr>
-          <p:cNvPr id="12" name="Shape 9"/>
-          <p:cNvSpPr/>
-          <p:nvPr/>
-        </p:nvSpPr>
-        <p:spPr>
-          <a:xfrm>
-            <a:off x="548640" y="3675888"/>
-            <a:ext cx="4221328" cy="448056"/>
-          </a:xfrm>
-          <a:prstGeom prst="roundRect">
-            <a:avLst>
-              <a:gd name="adj" fmla="val 10204"/>
-            </a:avLst>
-          </a:prstGeom>
-          <a:solidFill>
-            <a:srgbClr val="FFFFFF"/>
-          </a:solidFill>
-          <a:ln w="9525">
-            <a:solidFill>
-              <a:srgbClr val="E8E8E8"/>
-            </a:solidFill>
-            <a:prstDash val="solid"/>
-          </a:ln>
-        </p:spPr>
-      </p:sp>
-      <p:sp>
-        <p:nvSpPr>
-          <p:cNvPr id="13" name="Shape 10"/>
-          <p:cNvSpPr/>
-          <p:nvPr/>
-        </p:nvSpPr>
-        <p:spPr>
-          <a:xfrm>
-            <a:off x="566928" y="3721608"/>
-            <a:ext cx="32004" cy="356616"/>
-          </a:xfrm>
-          <a:prstGeom prst="rect">
-            <a:avLst/>
-          </a:prstGeom>
-          <a:solidFill>
-            <a:srgbClr val="FF6600"/>
-          </a:solidFill>
-          <a:ln/>
-        </p:spPr>
-      </p:sp>
-      <p:sp>
-        <p:nvSpPr>
-          <p:cNvPr id="14" name="Shape 11"/>
-          <p:cNvSpPr/>
-          <p:nvPr/>
-        </p:nvSpPr>
-        <p:spPr>
-          <a:xfrm>
-            <a:off x="694944" y="3863340"/>
-            <a:ext cx="54864" cy="54864"/>
-          </a:xfrm>
-          <a:prstGeom prst="ellipse">
-            <a:avLst/>
-          </a:prstGeom>
-          <a:solidFill>
-            <a:srgbClr val="FF6600"/>
-          </a:solidFill>
-          <a:ln/>
-        </p:spPr>
-      </p:sp>
-      <p:sp>
-        <p:nvSpPr>
-          <p:cNvPr id="15" name="Text 12"/>
-          <p:cNvSpPr txBox="1"/>
-          <p:nvPr/>
-        </p:nvSpPr>
-        <p:spPr>
-          <a:xfrm>
-            <a:off x="859536" y="3758184"/>
-            <a:ext cx="3800704" cy="283464"/>
-          </a:xfrm>
-          <a:prstGeom prst="rect">
-            <a:avLst/>
-          </a:prstGeom>
-          <a:noFill/>
-          <a:ln/>
-        </p:spPr>
-        <p:txBody>
-          <a:bodyPr wrap="square" lIns="0" tIns="0" rIns="0" bIns="0" rtlCol="0" anchor="t"/>
-          <a:lstStyle/>
-          <a:p>
-            <a:pPr indent="0" marL="0">
-              <a:lnSpc>
-                <a:spcPts val="1600"/>
-              </a:lnSpc>
-              <a:buNone/>
-            </a:pPr>
-            <a:r>
-              <a:rPr lang="en-US" sz="1150" dirty="0">
-                <a:solidFill>
-                  <a:srgbClr val="363636"/>
-                </a:solidFill>
-                <a:latin typeface="Arial" pitchFamily="34" charset="0"/>
-                <a:ea typeface="Arial" pitchFamily="34" charset="-122"/>
-                <a:cs typeface="Arial" pitchFamily="34" charset="-120"/>
-              </a:rPr>
-              <a:t>核对「清单有原文但未收集」表,澄清数量差异(废止/合并共6条)原因</a:t>
-            </a:r>
-            <a:endParaRPr lang="en-US" sz="1150" dirty="0"/>
-          </a:p>
-        </p:txBody>
-      </p:sp>
-      <p:sp>
-        <p:nvSpPr>
-          <p:cNvPr id="16" name="Shape 13"/>
-          <p:cNvSpPr/>
-          <p:nvPr/>
-        </p:nvSpPr>
-        <p:spPr>
-          <a:xfrm>
-            <a:off x="548640" y="4224528"/>
-            <a:ext cx="4221328" cy="448056"/>
-          </a:xfrm>
-          <a:prstGeom prst="roundRect">
-            <a:avLst>
-              <a:gd name="adj" fmla="val 10204"/>
-            </a:avLst>
-          </a:prstGeom>
-          <a:solidFill>
-            <a:srgbClr val="FFFFFF"/>
-          </a:solidFill>
-          <a:ln w="9525">
-            <a:solidFill>
-              <a:srgbClr val="E8E8E8"/>
-            </a:solidFill>
-            <a:prstDash val="solid"/>
-          </a:ln>
-        </p:spPr>
-      </p:sp>
-      <p:sp>
-        <p:nvSpPr>
-          <p:cNvPr id="17" name="Shape 14"/>
-          <p:cNvSpPr/>
-          <p:nvPr/>
-        </p:nvSpPr>
-        <p:spPr>
-          <a:xfrm>
-            <a:off x="566928" y="4270248"/>
-            <a:ext cx="32004" cy="356616"/>
-          </a:xfrm>
-          <a:prstGeom prst="rect">
-            <a:avLst/>
-          </a:prstGeom>
-          <a:solidFill>
-            <a:srgbClr val="FF6600"/>
-          </a:solidFill>
-          <a:ln/>
-        </p:spPr>
-      </p:sp>
-      <p:sp>
-        <p:nvSpPr>
-          <p:cNvPr id="18" name="Shape 15"/>
-          <p:cNvSpPr/>
-          <p:nvPr/>
-        </p:nvSpPr>
-        <p:spPr>
-          <a:xfrm>
-            <a:off x="694944" y="4411980"/>
-            <a:ext cx="54864" cy="54864"/>
-          </a:xfrm>
-          <a:prstGeom prst="ellipse">
-            <a:avLst/>
-          </a:prstGeom>
-          <a:solidFill>
-            <a:srgbClr val="FF6600"/>
-          </a:solidFill>
-          <a:ln/>
-        </p:spPr>
-      </p:sp>
-      <p:sp>
-        <p:nvSpPr>
-          <p:cNvPr id="19" name="Text 16"/>
-          <p:cNvSpPr txBox="1"/>
-          <p:nvPr/>
-        </p:nvSpPr>
-        <p:spPr>
-          <a:xfrm>
-            <a:off x="859536" y="4306824"/>
-            <a:ext cx="3800704" cy="283464"/>
-          </a:xfrm>
-          <a:prstGeom prst="rect">
-            <a:avLst/>
-          </a:prstGeom>
-          <a:noFill/>
-          <a:ln/>
-        </p:spPr>
-        <p:txBody>
-          <a:bodyPr wrap="square" lIns="0" tIns="0" rIns="0" bIns="0" rtlCol="0" anchor="t"/>
-          <a:lstStyle/>
-          <a:p>
-            <a:pPr indent="0" marL="0">
-              <a:lnSpc>
-                <a:spcPts val="1600"/>
-              </a:lnSpc>
-              <a:buNone/>
-            </a:pPr>
-            <a:r>
-              <a:rPr lang="en-US" sz="1150" dirty="0">
-                <a:solidFill>
-                  <a:srgbClr val="363636"/>
-                </a:solidFill>
-                <a:latin typeface="Arial" pitchFamily="34" charset="0"/>
-                <a:ea typeface="Arial" pitchFamily="34" charset="-122"/>
-                <a:cs typeface="Arial" pitchFamily="34" charset="-120"/>
-              </a:rPr>
-              <a:t>WP29 第199届会议提案作为法规动态线上推送汽研</a:t>
-            </a:r>
-            <a:endParaRPr lang="en-US" sz="1150" dirty="0"/>
-          </a:p>
-        </p:txBody>
-      </p:sp>
-      <p:sp>
-        <p:nvSpPr>
-          <p:cNvPr id="20" name="Shape 17"/>
-          <p:cNvSpPr/>
-          <p:nvPr/>
-        </p:nvSpPr>
-        <p:spPr>
-          <a:xfrm>
-            <a:off x="548640" y="4773168"/>
-            <a:ext cx="4221328" cy="448056"/>
-          </a:xfrm>
-          <a:prstGeom prst="roundRect">
-            <a:avLst>
-              <a:gd name="adj" fmla="val 10204"/>
-            </a:avLst>
-          </a:prstGeom>
-          <a:solidFill>
-            <a:srgbClr val="FFFFFF"/>
-          </a:solidFill>
-          <a:ln w="9525">
-            <a:solidFill>
-              <a:srgbClr val="E8E8E8"/>
-            </a:solidFill>
-            <a:prstDash val="solid"/>
-          </a:ln>
-        </p:spPr>
-      </p:sp>
-      <p:sp>
-        <p:nvSpPr>
-          <p:cNvPr id="21" name="Shape 18"/>
-          <p:cNvSpPr/>
-          <p:nvPr/>
-        </p:nvSpPr>
-        <p:spPr>
-          <a:xfrm>
-            <a:off x="566928" y="4818888"/>
-            <a:ext cx="32004" cy="356616"/>
-          </a:xfrm>
-          <a:prstGeom prst="rect">
-            <a:avLst/>
-          </a:prstGeom>
-          <a:solidFill>
-            <a:srgbClr val="FF6600"/>
-          </a:solidFill>
-          <a:ln/>
-        </p:spPr>
-      </p:sp>
-      <p:sp>
-        <p:nvSpPr>
-          <p:cNvPr id="22" name="Shape 19"/>
-          <p:cNvSpPr/>
-          <p:nvPr/>
-        </p:nvSpPr>
-        <p:spPr>
-          <a:xfrm>
-            <a:off x="694944" y="4960620"/>
-            <a:ext cx="54864" cy="54864"/>
-          </a:xfrm>
-          <a:prstGeom prst="ellipse">
-            <a:avLst/>
-          </a:prstGeom>
-          <a:solidFill>
-            <a:srgbClr val="FF6600"/>
-          </a:solidFill>
-          <a:ln/>
-        </p:spPr>
-      </p:sp>
-      <p:sp>
-        <p:nvSpPr>
-          <p:cNvPr id="23" name="Text 20"/>
-          <p:cNvSpPr txBox="1"/>
-          <p:nvPr/>
-        </p:nvSpPr>
-        <p:spPr>
-          <a:xfrm>
-            <a:off x="859536" y="4855464"/>
-            <a:ext cx="3800704" cy="283464"/>
-          </a:xfrm>
-          <a:prstGeom prst="rect">
-            <a:avLst/>
-          </a:prstGeom>
-          <a:noFill/>
-          <a:ln/>
-        </p:spPr>
-        <p:txBody>
-          <a:bodyPr wrap="square" lIns="0" tIns="0" rIns="0" bIns="0" rtlCol="0" anchor="t"/>
-          <a:lstStyle/>
-          <a:p>
-            <a:pPr indent="0" marL="0">
-              <a:lnSpc>
-                <a:spcPts val="1600"/>
-              </a:lnSpc>
-              <a:buNone/>
-            </a:pPr>
-            <a:r>
-              <a:rPr lang="en-US" sz="1150" dirty="0">
-                <a:solidFill>
-                  <a:srgbClr val="363636"/>
-                </a:solidFill>
-                <a:latin typeface="Arial" pitchFamily="34" charset="0"/>
-                <a:ea typeface="Arial" pitchFamily="34" charset="-122"/>
-                <a:cs typeface="Arial" pitchFamily="34" charset="-120"/>
-              </a:rPr>
-              <a:t>Q2及Q3海外法规监测工作季度总结</a:t>
-            </a:r>
-            <a:endParaRPr lang="en-US" sz="1150" dirty="0"/>
-          </a:p>
-        </p:txBody>
-      </p:sp>
-      <p:sp>
-        <p:nvSpPr>
-          <p:cNvPr id="24" name="Shape 21"/>
-          <p:cNvSpPr/>
-          <p:nvPr/>
-        </p:nvSpPr>
-        <p:spPr>
-          <a:xfrm>
-            <a:off x="548640" y="5321808"/>
-            <a:ext cx="4221328" cy="448056"/>
-          </a:xfrm>
-          <a:prstGeom prst="roundRect">
-            <a:avLst>
-              <a:gd name="adj" fmla="val 10204"/>
-            </a:avLst>
-          </a:prstGeom>
-          <a:solidFill>
-            <a:srgbClr val="FFFFFF"/>
-          </a:solidFill>
-          <a:ln w="9525">
-            <a:solidFill>
-              <a:srgbClr val="E8E8E8"/>
-            </a:solidFill>
-            <a:prstDash val="solid"/>
-          </a:ln>
-        </p:spPr>
-      </p:sp>
-      <p:sp>
-        <p:nvSpPr>
-          <p:cNvPr id="25" name="Shape 22"/>
-          <p:cNvSpPr/>
-          <p:nvPr/>
-        </p:nvSpPr>
-        <p:spPr>
-          <a:xfrm>
-            <a:off x="566928" y="5367528"/>
-            <a:ext cx="32004" cy="356616"/>
-          </a:xfrm>
-          <a:prstGeom prst="rect">
-            <a:avLst/>
-          </a:prstGeom>
-          <a:solidFill>
-            <a:srgbClr val="FF6600"/>
-          </a:solidFill>
-          <a:ln/>
-        </p:spPr>
-      </p:sp>
-      <p:sp>
-        <p:nvSpPr>
-          <p:cNvPr id="26" name="Shape 23"/>
-          <p:cNvSpPr/>
-          <p:nvPr/>
-        </p:nvSpPr>
-        <p:spPr>
-          <a:xfrm>
-            <a:off x="694944" y="5509260"/>
-            <a:ext cx="54864" cy="54864"/>
-          </a:xfrm>
-          <a:prstGeom prst="ellipse">
-            <a:avLst/>
-          </a:prstGeom>
-          <a:solidFill>
-            <a:srgbClr val="FF6600"/>
-          </a:solidFill>
-          <a:ln/>
-        </p:spPr>
-      </p:sp>
-      <p:sp>
-        <p:nvSpPr>
-          <p:cNvPr id="27" name="Text 24"/>
-          <p:cNvSpPr txBox="1"/>
-          <p:nvPr/>
-        </p:nvSpPr>
-        <p:spPr>
-          <a:xfrm>
-            <a:off x="859536" y="5404104"/>
-            <a:ext cx="3800704" cy="283464"/>
-          </a:xfrm>
-          <a:prstGeom prst="rect">
-            <a:avLst/>
-          </a:prstGeom>
-          <a:noFill/>
-          <a:ln/>
-        </p:spPr>
-        <p:txBody>
-          <a:bodyPr wrap="square" lIns="0" tIns="0" rIns="0" bIns="0" rtlCol="0" anchor="t"/>
-          <a:lstStyle/>
-          <a:p>
-            <a:pPr indent="0" marL="0">
-              <a:lnSpc>
-                <a:spcPts val="1600"/>
-              </a:lnSpc>
-              <a:buNone/>
-            </a:pPr>
-            <a:r>
-              <a:rPr lang="en-US" sz="1150" dirty="0">
-                <a:solidFill>
-                  <a:srgbClr val="363636"/>
-                </a:solidFill>
-                <a:latin typeface="Arial" pitchFamily="34" charset="0"/>
-                <a:ea typeface="Arial" pitchFamily="34" charset="-122"/>
-                <a:cs typeface="Arial" pitchFamily="34" charset="-120"/>
-              </a:rPr>
-              <a:t>多国法规清单持续补充交付与归类口径答疑</a:t>
-            </a:r>
-            <a:endParaRPr lang="en-US" sz="1150" dirty="0"/>
-          </a:p>
-        </p:txBody>
-      </p:sp>
-      <p:pic>
-        <p:nvPicPr>
-          <p:cNvPr id="28" name="Image 1" descr="/tmp/pptx_work/icons/send.png">    </p:cNvPr>
-          <p:cNvPicPr>
-            <a:picLocks noChangeAspect="1"/>
-          </p:cNvPicPr>
-          <p:nvPr/>
-        </p:nvPicPr>
-        <p:blipFill>
-          <a:blip r:embed="rId3"/>
-          <a:stretch>
-            <a:fillRect/>
-          </a:stretch>
-        </p:blipFill>
-        <p:spPr>
-          <a:xfrm>
-            <a:off x="5135728" y="2331720"/>
-            <a:ext cx="384048" cy="384048"/>
-          </a:xfrm>
-          <a:prstGeom prst="rect">
-            <a:avLst/>
-          </a:prstGeom>
-        </p:spPr>
-      </p:pic>
-      <p:sp>
-        <p:nvSpPr>
-          <p:cNvPr id="29" name="Text 25"/>
-          <p:cNvSpPr txBox="1"/>
-          <p:nvPr/>
-        </p:nvSpPr>
-        <p:spPr>
-          <a:xfrm>
-            <a:off x="5629504" y="2313432"/>
-            <a:ext cx="3727552" cy="420624"/>
-          </a:xfrm>
-          <a:prstGeom prst="rect">
-            <a:avLst/>
-          </a:prstGeom>
-          <a:noFill/>
-          <a:ln/>
-        </p:spPr>
-        <p:txBody>
-          <a:bodyPr wrap="square" lIns="0" tIns="0" rIns="0" bIns="0" rtlCol="0" anchor="ctr"/>
-          <a:lstStyle/>
-          <a:p>
-            <a:pPr indent="0" marL="0">
-              <a:lnSpc>
-                <a:spcPts val="1500"/>
-              </a:lnSpc>
-              <a:buNone/>
-            </a:pPr>
-            <a:r>
-              <a:rPr lang="en-US" sz="1300" b="1" dirty="0">
-                <a:solidFill>
-                  <a:srgbClr val="363636"/>
-                </a:solidFill>
-                <a:latin typeface="Arial" pitchFamily="34" charset="0"/>
-                <a:ea typeface="Arial" pitchFamily="34" charset="-122"/>
-                <a:cs typeface="Arial" pitchFamily="34" charset="-120"/>
-              </a:rPr>
-              <a:t>月报分发与内容营销支持</a:t>
-            </a:r>
-            <a:endParaRPr lang="en-US" sz="1300" dirty="0"/>
-          </a:p>
-        </p:txBody>
-      </p:sp>
-      <p:sp>
-        <p:nvSpPr>
-          <p:cNvPr id="30" name="Shape 26"/>
-          <p:cNvSpPr/>
-          <p:nvPr/>
-        </p:nvSpPr>
-        <p:spPr>
-          <a:xfrm>
-            <a:off x="5135728" y="2788920"/>
-            <a:ext cx="4221328" cy="0"/>
-          </a:xfrm>
-          <a:prstGeom prst="line">
-            <a:avLst/>
-          </a:prstGeom>
-          <a:noFill/>
-          <a:ln w="19050">
-            <a:solidFill>
-              <a:srgbClr val="FF6600"/>
-            </a:solidFill>
-            <a:prstDash val="solid"/>
-          </a:ln>
-        </p:spPr>
-      </p:sp>
-      <p:sp>
-        <p:nvSpPr>
-          <p:cNvPr id="31" name="Shape 27"/>
-          <p:cNvSpPr/>
-          <p:nvPr/>
-        </p:nvSpPr>
-        <p:spPr>
-          <a:xfrm>
-            <a:off x="5135728" y="2916936"/>
-            <a:ext cx="4221328" cy="448056"/>
-          </a:xfrm>
-          <a:prstGeom prst="roundRect">
-            <a:avLst>
-              <a:gd name="adj" fmla="val 10204"/>
-            </a:avLst>
-          </a:prstGeom>
-          <a:solidFill>
-            <a:srgbClr val="FFFFFF"/>
-          </a:solidFill>
-          <a:ln w="9525">
-            <a:solidFill>
-              <a:srgbClr val="E8E8E8"/>
-            </a:solidFill>
-            <a:prstDash val="solid"/>
-          </a:ln>
-        </p:spPr>
-      </p:sp>
-      <p:sp>
-        <p:nvSpPr>
-          <p:cNvPr id="32" name="Shape 28"/>
-          <p:cNvSpPr/>
-          <p:nvPr/>
-        </p:nvSpPr>
-        <p:spPr>
-          <a:xfrm>
-            <a:off x="5154016" y="2962656"/>
-            <a:ext cx="32004" cy="356616"/>
-          </a:xfrm>
-          <a:prstGeom prst="rect">
-            <a:avLst/>
-          </a:prstGeom>
-          <a:solidFill>
-            <a:srgbClr val="FF6600"/>
-          </a:solidFill>
-          <a:ln/>
-        </p:spPr>
-      </p:sp>
-      <p:sp>
-        <p:nvSpPr>
-          <p:cNvPr id="33" name="Shape 29"/>
-          <p:cNvSpPr/>
-          <p:nvPr/>
-        </p:nvSpPr>
-        <p:spPr>
-          <a:xfrm>
-            <a:off x="5282032" y="3104388"/>
-            <a:ext cx="54864" cy="54864"/>
-          </a:xfrm>
-          <a:prstGeom prst="ellipse">
-            <a:avLst/>
-          </a:prstGeom>
-          <a:solidFill>
-            <a:srgbClr val="FF6600"/>
-          </a:solidFill>
-          <a:ln/>
-        </p:spPr>
-      </p:sp>
-      <p:sp>
-        <p:nvSpPr>
-          <p:cNvPr id="34" name="Text 30"/>
-          <p:cNvSpPr txBox="1"/>
-          <p:nvPr/>
-        </p:nvSpPr>
-        <p:spPr>
-          <a:xfrm>
-            <a:off x="5446624" y="2999232"/>
-            <a:ext cx="3800704" cy="283464"/>
-          </a:xfrm>
-          <a:prstGeom prst="rect">
-            <a:avLst/>
-          </a:prstGeom>
-          <a:noFill/>
-          <a:ln/>
-        </p:spPr>
-        <p:txBody>
-          <a:bodyPr wrap="square" lIns="0" tIns="0" rIns="0" bIns="0" rtlCol="0" anchor="t"/>
-          <a:lstStyle/>
-          <a:p>
-            <a:pPr indent="0" marL="0">
-              <a:lnSpc>
-                <a:spcPts val="1600"/>
-              </a:lnSpc>
-              <a:buNone/>
-            </a:pPr>
-            <a:r>
-              <a:rPr lang="en-US" sz="1150" dirty="0">
-                <a:solidFill>
-                  <a:srgbClr val="363636"/>
-                </a:solidFill>
-                <a:latin typeface="Arial" pitchFamily="34" charset="0"/>
-                <a:ea typeface="Arial" pitchFamily="34" charset="-122"/>
-                <a:cs typeface="Arial" pitchFamily="34" charset="-120"/>
-              </a:rPr>
-              <a:t>录制【有问必答】视频</a:t>
-            </a:r>
-            <a:endParaRPr lang="en-US" sz="1150" dirty="0"/>
-          </a:p>
-        </p:txBody>
-      </p:sp>
-      <p:sp>
-        <p:nvSpPr>
-          <p:cNvPr id="35" name="Shape 31"/>
-          <p:cNvSpPr/>
-          <p:nvPr/>
-        </p:nvSpPr>
-        <p:spPr>
-          <a:xfrm>
-            <a:off x="5135728" y="3465576"/>
-            <a:ext cx="4221328" cy="448056"/>
-          </a:xfrm>
-          <a:prstGeom prst="roundRect">
-            <a:avLst>
-              <a:gd name="adj" fmla="val 10204"/>
-            </a:avLst>
-          </a:prstGeom>
-          <a:solidFill>
-            <a:srgbClr val="FFFFFF"/>
-          </a:solidFill>
-          <a:ln w="9525">
-            <a:solidFill>
-              <a:srgbClr val="E8E8E8"/>
-            </a:solidFill>
-            <a:prstDash val="solid"/>
-          </a:ln>
-        </p:spPr>
-      </p:sp>
-      <p:sp>
-        <p:nvSpPr>
-          <p:cNvPr id="36" name="Shape 32"/>
-          <p:cNvSpPr/>
-          <p:nvPr/>
-        </p:nvSpPr>
-        <p:spPr>
-          <a:xfrm>
-            <a:off x="5154016" y="3511296"/>
-            <a:ext cx="32004" cy="356616"/>
-          </a:xfrm>
-          <a:prstGeom prst="rect">
-            <a:avLst/>
-          </a:prstGeom>
-          <a:solidFill>
-            <a:srgbClr val="FF6600"/>
-          </a:solidFill>
-          <a:ln/>
-        </p:spPr>
-      </p:sp>
-      <p:sp>
-        <p:nvSpPr>
-          <p:cNvPr id="37" name="Shape 33"/>
-          <p:cNvSpPr/>
-          <p:nvPr/>
-        </p:nvSpPr>
-        <p:spPr>
-          <a:xfrm>
-            <a:off x="5282032" y="3653028"/>
-            <a:ext cx="54864" cy="54864"/>
-          </a:xfrm>
-          <a:prstGeom prst="ellipse">
-            <a:avLst/>
-          </a:prstGeom>
-          <a:solidFill>
-            <a:srgbClr val="FF6600"/>
-          </a:solidFill>
-          <a:ln/>
-        </p:spPr>
-      </p:sp>
-      <p:sp>
-        <p:nvSpPr>
-          <p:cNvPr id="38" name="Text 34"/>
-          <p:cNvSpPr txBox="1"/>
-          <p:nvPr/>
-        </p:nvSpPr>
-        <p:spPr>
-          <a:xfrm>
-            <a:off x="5446624" y="3547872"/>
-            <a:ext cx="3800704" cy="283464"/>
-          </a:xfrm>
-          <a:prstGeom prst="rect">
-            <a:avLst/>
-          </a:prstGeom>
-          <a:noFill/>
-          <a:ln/>
-        </p:spPr>
-        <p:txBody>
-          <a:bodyPr wrap="square" lIns="0" tIns="0" rIns="0" bIns="0" rtlCol="0" anchor="t"/>
-          <a:lstStyle/>
-          <a:p>
-            <a:pPr indent="0" marL="0">
-              <a:lnSpc>
-                <a:spcPts val="1600"/>
-              </a:lnSpc>
-              <a:buNone/>
-            </a:pPr>
-            <a:r>
-              <a:rPr lang="en-US" sz="1150" dirty="0">
-                <a:solidFill>
-                  <a:srgbClr val="363636"/>
-                </a:solidFill>
-                <a:latin typeface="Arial" pitchFamily="34" charset="0"/>
-                <a:ea typeface="Arial" pitchFamily="34" charset="-122"/>
-                <a:cs typeface="Arial" pitchFamily="34" charset="-120"/>
-              </a:rPr>
-              <a:t>「汽车制造」系列推广文章周更审阅(8-9月共9篇)</a:t>
-            </a:r>
-            <a:endParaRPr lang="en-US" sz="1150" dirty="0"/>
-          </a:p>
-        </p:txBody>
-      </p:sp>
-      <p:sp>
-        <p:nvSpPr>
-          <p:cNvPr id="39" name="Shape 35"/>
-          <p:cNvSpPr/>
-          <p:nvPr/>
-        </p:nvSpPr>
-        <p:spPr>
-          <a:xfrm>
-            <a:off x="5135728" y="4014216"/>
-            <a:ext cx="4221328" cy="448056"/>
-          </a:xfrm>
-          <a:prstGeom prst="roundRect">
-            <a:avLst>
-              <a:gd name="adj" fmla="val 10204"/>
-            </a:avLst>
-          </a:prstGeom>
-          <a:solidFill>
-            <a:srgbClr val="FFFFFF"/>
-          </a:solidFill>
-          <a:ln w="9525">
-            <a:solidFill>
-              <a:srgbClr val="E8E8E8"/>
-            </a:solidFill>
-            <a:prstDash val="solid"/>
-          </a:ln>
-        </p:spPr>
-      </p:sp>
-      <p:sp>
-        <p:nvSpPr>
-          <p:cNvPr id="40" name="Shape 36"/>
-          <p:cNvSpPr/>
-          <p:nvPr/>
-        </p:nvSpPr>
-        <p:spPr>
-          <a:xfrm>
-            <a:off x="5154016" y="4059936"/>
-            <a:ext cx="32004" cy="356616"/>
-          </a:xfrm>
-          <a:prstGeom prst="rect">
-            <a:avLst/>
-          </a:prstGeom>
-          <a:solidFill>
-            <a:srgbClr val="FF6600"/>
-          </a:solidFill>
-          <a:ln/>
-        </p:spPr>
-      </p:sp>
-      <p:sp>
-        <p:nvSpPr>
-          <p:cNvPr id="41" name="Shape 37"/>
-          <p:cNvSpPr/>
-          <p:nvPr/>
-        </p:nvSpPr>
-        <p:spPr>
-          <a:xfrm>
-            <a:off x="5282032" y="4201668"/>
-            <a:ext cx="54864" cy="54864"/>
-          </a:xfrm>
-          <a:prstGeom prst="ellipse">
-            <a:avLst/>
-          </a:prstGeom>
-          <a:solidFill>
-            <a:srgbClr val="FF6600"/>
-          </a:solidFill>
-          <a:ln/>
-        </p:spPr>
-      </p:sp>
-      <p:sp>
-        <p:nvSpPr>
-          <p:cNvPr id="42" name="Text 38"/>
-          <p:cNvSpPr txBox="1"/>
-          <p:nvPr/>
-        </p:nvSpPr>
-        <p:spPr>
-          <a:xfrm>
-            <a:off x="5446624" y="4096512"/>
-            <a:ext cx="3800704" cy="283464"/>
-          </a:xfrm>
-          <a:prstGeom prst="rect">
-            <a:avLst/>
-          </a:prstGeom>
-          <a:noFill/>
-          <a:ln/>
-        </p:spPr>
-        <p:txBody>
-          <a:bodyPr wrap="square" lIns="0" tIns="0" rIns="0" bIns="0" rtlCol="0" anchor="t"/>
-          <a:lstStyle/>
-          <a:p>
-            <a:pPr indent="0" marL="0">
-              <a:lnSpc>
-                <a:spcPts val="1600"/>
-              </a:lnSpc>
-              <a:buNone/>
-            </a:pPr>
-            <a:r>
-              <a:rPr lang="en-US" sz="1150" dirty="0">
-                <a:solidFill>
-                  <a:srgbClr val="363636"/>
-                </a:solidFill>
-                <a:latin typeface="Arial" pitchFamily="34" charset="0"/>
-                <a:ea typeface="Arial" pitchFamily="34" charset="-122"/>
-                <a:cs typeface="Arial" pitchFamily="34" charset="-120"/>
-              </a:rPr>
-              <a:t>EU 2026/1738 循环设计法规直播内容制作支持(大纲/PPT)</a:t>
-            </a:r>
-            <a:endParaRPr lang="en-US" sz="1150" dirty="0"/>
-          </a:p>
-        </p:txBody>
-      </p:sp>
-      <p:sp>
-        <p:nvSpPr>
-          <p:cNvPr id="43" name="Shape 39"/>
-          <p:cNvSpPr/>
-          <p:nvPr/>
-        </p:nvSpPr>
-        <p:spPr>
-          <a:xfrm>
-            <a:off x="5135728" y="4562856"/>
-            <a:ext cx="4221328" cy="448056"/>
-          </a:xfrm>
-          <a:prstGeom prst="roundRect">
-            <a:avLst>
-              <a:gd name="adj" fmla="val 10204"/>
-            </a:avLst>
-          </a:prstGeom>
-          <a:solidFill>
-            <a:srgbClr val="FFFFFF"/>
-          </a:solidFill>
-          <a:ln w="9525">
-            <a:solidFill>
-              <a:srgbClr val="E8E8E8"/>
-            </a:solidFill>
-            <a:prstDash val="solid"/>
-          </a:ln>
-        </p:spPr>
-      </p:sp>
-      <p:sp>
-        <p:nvSpPr>
-          <p:cNvPr id="44" name="Shape 40"/>
-          <p:cNvSpPr/>
-          <p:nvPr/>
-        </p:nvSpPr>
-        <p:spPr>
-          <a:xfrm>
-            <a:off x="5154016" y="4608576"/>
-            <a:ext cx="32004" cy="356616"/>
-          </a:xfrm>
-          <a:prstGeom prst="rect">
-            <a:avLst/>
-          </a:prstGeom>
-          <a:solidFill>
-            <a:srgbClr val="FF6600"/>
-          </a:solidFill>
-          <a:ln/>
-        </p:spPr>
-      </p:sp>
-      <p:sp>
-        <p:nvSpPr>
-          <p:cNvPr id="45" name="Shape 41"/>
-          <p:cNvSpPr/>
-          <p:nvPr/>
-        </p:nvSpPr>
-        <p:spPr>
-          <a:xfrm>
-            <a:off x="5282032" y="4750308"/>
-            <a:ext cx="54864" cy="54864"/>
-          </a:xfrm>
-          <a:prstGeom prst="ellipse">
-            <a:avLst/>
-          </a:prstGeom>
-          <a:solidFill>
-            <a:srgbClr val="FF6600"/>
-          </a:solidFill>
-          <a:ln/>
-        </p:spPr>
-      </p:sp>
-      <p:sp>
-        <p:nvSpPr>
-          <p:cNvPr id="46" name="Text 42"/>
-          <p:cNvSpPr txBox="1"/>
-          <p:nvPr/>
-        </p:nvSpPr>
-        <p:spPr>
-          <a:xfrm>
-            <a:off x="5446624" y="4645152"/>
-            <a:ext cx="3800704" cy="283464"/>
-          </a:xfrm>
-          <a:prstGeom prst="rect">
-            <a:avLst/>
-          </a:prstGeom>
-          <a:noFill/>
-          <a:ln/>
-        </p:spPr>
-        <p:txBody>
-          <a:bodyPr wrap="square" lIns="0" tIns="0" rIns="0" bIns="0" rtlCol="0" anchor="t"/>
-          <a:lstStyle/>
-          <a:p>
-            <a:pPr indent="0" marL="0">
-              <a:lnSpc>
-                <a:spcPts val="1600"/>
-              </a:lnSpc>
-              <a:buNone/>
-            </a:pPr>
-            <a:r>
-              <a:rPr lang="en-US" sz="1150" dirty="0">
-                <a:solidFill>
-                  <a:srgbClr val="363636"/>
-                </a:solidFill>
-                <a:latin typeface="Arial" pitchFamily="34" charset="0"/>
-                <a:ea typeface="Arial" pitchFamily="34" charset="-122"/>
-                <a:cs typeface="Arial" pitchFamily="34" charset="-120"/>
-              </a:rPr>
-              <a:t>法规月报按时分发至汽研客户并跟进反馈</a:t>
-            </a:r>
-            <a:endParaRPr lang="en-US" sz="1150" dirty="0"/>
-          </a:p>
-        </p:txBody>
-      </p:sp>
-      <p:sp>
-        <p:nvSpPr>
-          <p:cNvPr id="47" name="Shape 43"/>
-          <p:cNvSpPr/>
-          <p:nvPr/>
-        </p:nvSpPr>
-        <p:spPr>
-          <a:xfrm>
-            <a:off x="5135728" y="5111496"/>
-            <a:ext cx="4221328" cy="448056"/>
-          </a:xfrm>
-          <a:prstGeom prst="roundRect">
-            <a:avLst>
-              <a:gd name="adj" fmla="val 10204"/>
-            </a:avLst>
-          </a:prstGeom>
-          <a:solidFill>
-            <a:srgbClr val="FFFFFF"/>
-          </a:solidFill>
-          <a:ln w="9525">
-            <a:solidFill>
-              <a:srgbClr val="E8E8E8"/>
-            </a:solidFill>
-            <a:prstDash val="solid"/>
-          </a:ln>
-        </p:spPr>
-      </p:sp>
-      <p:sp>
-        <p:nvSpPr>
-          <p:cNvPr id="48" name="Shape 44"/>
-          <p:cNvSpPr/>
-          <p:nvPr/>
-        </p:nvSpPr>
-        <p:spPr>
-          <a:xfrm>
-            <a:off x="5154016" y="5157216"/>
-            <a:ext cx="32004" cy="356616"/>
-          </a:xfrm>
-          <a:prstGeom prst="rect">
-            <a:avLst/>
-          </a:prstGeom>
-          <a:solidFill>
-            <a:srgbClr val="FF6600"/>
-          </a:solidFill>
-          <a:ln/>
-        </p:spPr>
-      </p:sp>
-      <p:sp>
-        <p:nvSpPr>
-          <p:cNvPr id="49" name="Shape 45"/>
-          <p:cNvSpPr/>
-          <p:nvPr/>
-        </p:nvSpPr>
-        <p:spPr>
-          <a:xfrm>
-            <a:off x="5282032" y="5298948"/>
-            <a:ext cx="54864" cy="54864"/>
-          </a:xfrm>
-          <a:prstGeom prst="ellipse">
-            <a:avLst/>
-          </a:prstGeom>
-          <a:solidFill>
-            <a:srgbClr val="FF6600"/>
-          </a:solidFill>
-          <a:ln/>
-        </p:spPr>
-      </p:sp>
-      <p:sp>
-        <p:nvSpPr>
-          <p:cNvPr id="50" name="Text 46"/>
-          <p:cNvSpPr txBox="1"/>
-          <p:nvPr/>
-        </p:nvSpPr>
-        <p:spPr>
-          <a:xfrm>
-            <a:off x="5446624" y="5193792"/>
-            <a:ext cx="3800704" cy="283464"/>
-          </a:xfrm>
-          <a:prstGeom prst="rect">
-            <a:avLst/>
-          </a:prstGeom>
-          <a:noFill/>
-          <a:ln/>
-        </p:spPr>
-        <p:txBody>
-          <a:bodyPr wrap="square" lIns="0" tIns="0" rIns="0" bIns="0" rtlCol="0" anchor="t"/>
-          <a:lstStyle/>
-          <a:p>
-            <a:pPr indent="0" marL="0">
-              <a:lnSpc>
-                <a:spcPts val="1600"/>
-              </a:lnSpc>
-              <a:buNone/>
-            </a:pPr>
-            <a:r>
-              <a:rPr lang="en-US" sz="1150" dirty="0">
-                <a:solidFill>
-                  <a:srgbClr val="363636"/>
-                </a:solidFill>
-                <a:latin typeface="Arial" pitchFamily="34" charset="0"/>
-                <a:ea typeface="Arial" pitchFamily="34" charset="-122"/>
-                <a:cs typeface="Arial" pitchFamily="34" charset="-120"/>
-              </a:rPr>
-              <a:t>月报 Spotlight 专题内容策划与选题调整</a:t>
-            </a:r>
-            <a:endParaRPr lang="en-US" sz="1150" dirty="0"/>
-          </a:p>
-        </p:txBody>
-      </p:sp>
-      <p:sp>
-        <p:nvSpPr>
-          <p:cNvPr id="51" name="Shape 47"/>
-          <p:cNvSpPr/>
-          <p:nvPr/>
-        </p:nvSpPr>
-        <p:spPr>
-          <a:xfrm>
-            <a:off x="4952848" y="2423160"/>
-            <a:ext cx="0" cy="3886200"/>
-          </a:xfrm>
-          <a:prstGeom prst="line">
-            <a:avLst/>
-          </a:prstGeom>
-          <a:noFill/>
-          <a:ln w="6350">
-            <a:solidFill>
-              <a:srgbClr val="E0E0E0"/>
-            </a:solidFill>
-            <a:prstDash val="solid"/>
-          </a:ln>
-        </p:spPr>
-      </p:sp>
-      <p:sp>
-        <p:nvSpPr>
-          <p:cNvPr id="52" name="Shape 48"/>
+              <a:t>逐条自评联动「认证与通行结论」:74 个国家/地区可搜索查询互认范围</a:t>
+            </a:r>
+            <a:endParaRPr lang="en-US" sz="1050" dirty="0"/>
+          </a:p>
+        </p:txBody>
+      </p:sp>
+      <p:sp>
+        <p:nvSpPr>
+          <p:cNvPr id="16" name="Shape 12"/>
           <p:cNvSpPr/>
           <p:nvPr/>
         </p:nvSpPr>
@@ -8300,7 +7409,7 @@
       </p:sp>
       <p:sp>
         <p:nvSpPr>
-          <p:cNvPr id="53" name="Text 49"/>
+          <p:cNvPr id="17" name="Text 13"/>
           <p:cNvSpPr txBox="1"/>
           <p:nvPr/>
         </p:nvSpPr>
@@ -8331,7 +7440,7 @@
                 <a:ea typeface="Arial" pitchFamily="34" charset="-122"/>
                 <a:cs typeface="Arial" pitchFamily="34" charset="-120"/>
               </a:rPr>
-              <a:t>5/6</a:t>
+              <a:t>5/7</a:t>
             </a:r>
             <a:endParaRPr lang="en-US" sz="900" dirty="0"/>
           </a:p>
@@ -8409,6 +7518,1496 @@
                 <a:ea typeface="Arial" pitchFamily="34" charset="-122"/>
                 <a:cs typeface="Arial" pitchFamily="34" charset="-120"/>
               </a:rPr>
+              <a:t>第三部分 · 市场支持情况</a:t>
+            </a:r>
+            <a:endParaRPr lang="en-US" sz="1050" dirty="0"/>
+          </a:p>
+        </p:txBody>
+      </p:sp>
+      <p:sp>
+        <p:nvSpPr>
+          <p:cNvPr id="3" name="Text 1"/>
+          <p:cNvSpPr txBox="1"/>
+          <p:nvPr/>
+        </p:nvSpPr>
+        <p:spPr>
+          <a:xfrm>
+            <a:off x="548640" y="1947672"/>
+            <a:ext cx="8808415" cy="347472"/>
+          </a:xfrm>
+          <a:prstGeom prst="rect">
+            <a:avLst/>
+          </a:prstGeom>
+          <a:noFill/>
+          <a:ln/>
+        </p:spPr>
+        <p:txBody>
+          <a:bodyPr wrap="square" lIns="0" tIns="0" rIns="0" bIns="0" rtlCol="0" anchor="ctr"/>
+          <a:lstStyle/>
+          <a:p>
+            <a:pPr indent="0" marL="0">
+              <a:buNone/>
+            </a:pPr>
+            <a:r>
+              <a:rPr lang="en-US" sz="1900" b="1" dirty="0">
+                <a:solidFill>
+                  <a:srgbClr val="363636"/>
+                </a:solidFill>
+                <a:latin typeface="Georgia" pitchFamily="34" charset="0"/>
+                <a:ea typeface="Georgia" pitchFamily="34" charset="-122"/>
+                <a:cs typeface="Georgia" pitchFamily="34" charset="-120"/>
+              </a:rPr>
+              <a:t>市场支持情况</a:t>
+            </a:r>
+            <a:endParaRPr lang="en-US" sz="1900" dirty="0"/>
+          </a:p>
+        </p:txBody>
+      </p:sp>
+      <p:sp>
+        <p:nvSpPr>
+          <p:cNvPr id="4" name="Shape 2"/>
+          <p:cNvSpPr/>
+          <p:nvPr/>
+        </p:nvSpPr>
+        <p:spPr>
+          <a:xfrm>
+            <a:off x="548640" y="2286000"/>
+            <a:ext cx="1097280" cy="0"/>
+          </a:xfrm>
+          <a:prstGeom prst="line">
+            <a:avLst/>
+          </a:prstGeom>
+          <a:noFill/>
+          <a:ln w="31750">
+            <a:solidFill>
+              <a:srgbClr val="FF6600"/>
+            </a:solidFill>
+            <a:prstDash val="solid"/>
+          </a:ln>
+        </p:spPr>
+      </p:sp>
+      <p:pic>
+        <p:nvPicPr>
+          <p:cNvPr id="5" name="Image 0" descr="/tmp/pptx_work/icons/search.png">    </p:cNvPr>
+          <p:cNvPicPr>
+            <a:picLocks noChangeAspect="1"/>
+          </p:cNvPicPr>
+          <p:nvPr/>
+        </p:nvPicPr>
+        <p:blipFill>
+          <a:blip r:embed="rId2"/>
+          <a:stretch>
+            <a:fillRect/>
+          </a:stretch>
+        </p:blipFill>
+        <p:spPr>
+          <a:xfrm>
+            <a:off x="548640" y="2331720"/>
+            <a:ext cx="384048" cy="384048"/>
+          </a:xfrm>
+          <a:prstGeom prst="rect">
+            <a:avLst/>
+          </a:prstGeom>
+        </p:spPr>
+      </p:pic>
+      <p:sp>
+        <p:nvSpPr>
+          <p:cNvPr id="6" name="Text 3"/>
+          <p:cNvSpPr txBox="1"/>
+          <p:nvPr/>
+        </p:nvSpPr>
+        <p:spPr>
+          <a:xfrm>
+            <a:off x="1042416" y="2313432"/>
+            <a:ext cx="3727552" cy="420624"/>
+          </a:xfrm>
+          <a:prstGeom prst="rect">
+            <a:avLst/>
+          </a:prstGeom>
+          <a:noFill/>
+          <a:ln/>
+        </p:spPr>
+        <p:txBody>
+          <a:bodyPr wrap="square" lIns="0" tIns="0" rIns="0" bIns="0" rtlCol="0" anchor="ctr"/>
+          <a:lstStyle/>
+          <a:p>
+            <a:pPr indent="0" marL="0">
+              <a:lnSpc>
+                <a:spcPts val="1500"/>
+              </a:lnSpc>
+              <a:buNone/>
+            </a:pPr>
+            <a:r>
+              <a:rPr lang="en-US" sz="1300" b="1" dirty="0">
+                <a:solidFill>
+                  <a:srgbClr val="363636"/>
+                </a:solidFill>
+                <a:latin typeface="Arial" pitchFamily="34" charset="0"/>
+                <a:ea typeface="Arial" pitchFamily="34" charset="-122"/>
+                <a:cs typeface="Arial" pitchFamily="34" charset="-120"/>
+              </a:rPr>
+              <a:t>法规检索与数据交付(对接汽研)</a:t>
+            </a:r>
+            <a:endParaRPr lang="en-US" sz="1300" dirty="0"/>
+          </a:p>
+        </p:txBody>
+      </p:sp>
+      <p:sp>
+        <p:nvSpPr>
+          <p:cNvPr id="7" name="Shape 4"/>
+          <p:cNvSpPr/>
+          <p:nvPr/>
+        </p:nvSpPr>
+        <p:spPr>
+          <a:xfrm>
+            <a:off x="548640" y="2788920"/>
+            <a:ext cx="4221328" cy="0"/>
+          </a:xfrm>
+          <a:prstGeom prst="line">
+            <a:avLst/>
+          </a:prstGeom>
+          <a:noFill/>
+          <a:ln w="19050">
+            <a:solidFill>
+              <a:srgbClr val="FF6600"/>
+            </a:solidFill>
+            <a:prstDash val="solid"/>
+          </a:ln>
+        </p:spPr>
+      </p:sp>
+      <p:sp>
+        <p:nvSpPr>
+          <p:cNvPr id="8" name="Shape 5"/>
+          <p:cNvSpPr/>
+          <p:nvPr/>
+        </p:nvSpPr>
+        <p:spPr>
+          <a:xfrm>
+            <a:off x="548640" y="2916936"/>
+            <a:ext cx="4221328" cy="658368"/>
+          </a:xfrm>
+          <a:prstGeom prst="roundRect">
+            <a:avLst>
+              <a:gd name="adj" fmla="val 6944"/>
+            </a:avLst>
+          </a:prstGeom>
+          <a:solidFill>
+            <a:srgbClr val="FFFFFF"/>
+          </a:solidFill>
+          <a:ln w="9525">
+            <a:solidFill>
+              <a:srgbClr val="E8E8E8"/>
+            </a:solidFill>
+            <a:prstDash val="solid"/>
+          </a:ln>
+        </p:spPr>
+      </p:sp>
+      <p:sp>
+        <p:nvSpPr>
+          <p:cNvPr id="9" name="Shape 6"/>
+          <p:cNvSpPr/>
+          <p:nvPr/>
+        </p:nvSpPr>
+        <p:spPr>
+          <a:xfrm>
+            <a:off x="566928" y="2962656"/>
+            <a:ext cx="32004" cy="566928"/>
+          </a:xfrm>
+          <a:prstGeom prst="rect">
+            <a:avLst/>
+          </a:prstGeom>
+          <a:solidFill>
+            <a:srgbClr val="FF6600"/>
+          </a:solidFill>
+          <a:ln/>
+        </p:spPr>
+      </p:sp>
+      <p:sp>
+        <p:nvSpPr>
+          <p:cNvPr id="10" name="Shape 7"/>
+          <p:cNvSpPr/>
+          <p:nvPr/>
+        </p:nvSpPr>
+        <p:spPr>
+          <a:xfrm>
+            <a:off x="694944" y="3104388"/>
+            <a:ext cx="54864" cy="54864"/>
+          </a:xfrm>
+          <a:prstGeom prst="ellipse">
+            <a:avLst/>
+          </a:prstGeom>
+          <a:solidFill>
+            <a:srgbClr val="FF6600"/>
+          </a:solidFill>
+          <a:ln/>
+        </p:spPr>
+      </p:sp>
+      <p:sp>
+        <p:nvSpPr>
+          <p:cNvPr id="11" name="Text 8"/>
+          <p:cNvSpPr txBox="1"/>
+          <p:nvPr/>
+        </p:nvSpPr>
+        <p:spPr>
+          <a:xfrm>
+            <a:off x="859536" y="2999232"/>
+            <a:ext cx="3800704" cy="493776"/>
+          </a:xfrm>
+          <a:prstGeom prst="rect">
+            <a:avLst/>
+          </a:prstGeom>
+          <a:noFill/>
+          <a:ln/>
+        </p:spPr>
+        <p:txBody>
+          <a:bodyPr wrap="square" lIns="0" tIns="0" rIns="0" bIns="0" rtlCol="0" anchor="t"/>
+          <a:lstStyle/>
+          <a:p>
+            <a:pPr indent="0" marL="0">
+              <a:lnSpc>
+                <a:spcPts val="1600"/>
+              </a:lnSpc>
+              <a:buNone/>
+            </a:pPr>
+            <a:r>
+              <a:rPr lang="en-US" sz="1150" dirty="0">
+                <a:solidFill>
+                  <a:srgbClr val="363636"/>
+                </a:solidFill>
+                <a:latin typeface="Arial" pitchFamily="34" charset="0"/>
+                <a:ea typeface="Arial" pitchFamily="34" charset="-122"/>
+                <a:cs typeface="Arial" pitchFamily="34" charset="-120"/>
+              </a:rPr>
+              <a:t>拉美/北美七国(墨西哥/哥伦比亚/巴西/阿根廷/智利/秘鲁/美国/加拿大)充电插头插座标准检索,交付 Excel 数据表 + 原文压缩包</a:t>
+            </a:r>
+            <a:endParaRPr lang="en-US" sz="1150" dirty="0"/>
+          </a:p>
+        </p:txBody>
+      </p:sp>
+      <p:sp>
+        <p:nvSpPr>
+          <p:cNvPr id="12" name="Shape 9"/>
+          <p:cNvSpPr/>
+          <p:nvPr/>
+        </p:nvSpPr>
+        <p:spPr>
+          <a:xfrm>
+            <a:off x="548640" y="3675888"/>
+            <a:ext cx="4221328" cy="448056"/>
+          </a:xfrm>
+          <a:prstGeom prst="roundRect">
+            <a:avLst>
+              <a:gd name="adj" fmla="val 10204"/>
+            </a:avLst>
+          </a:prstGeom>
+          <a:solidFill>
+            <a:srgbClr val="FFFFFF"/>
+          </a:solidFill>
+          <a:ln w="9525">
+            <a:solidFill>
+              <a:srgbClr val="E8E8E8"/>
+            </a:solidFill>
+            <a:prstDash val="solid"/>
+          </a:ln>
+        </p:spPr>
+      </p:sp>
+      <p:sp>
+        <p:nvSpPr>
+          <p:cNvPr id="13" name="Shape 10"/>
+          <p:cNvSpPr/>
+          <p:nvPr/>
+        </p:nvSpPr>
+        <p:spPr>
+          <a:xfrm>
+            <a:off x="566928" y="3721608"/>
+            <a:ext cx="32004" cy="356616"/>
+          </a:xfrm>
+          <a:prstGeom prst="rect">
+            <a:avLst/>
+          </a:prstGeom>
+          <a:solidFill>
+            <a:srgbClr val="FF6600"/>
+          </a:solidFill>
+          <a:ln/>
+        </p:spPr>
+      </p:sp>
+      <p:sp>
+        <p:nvSpPr>
+          <p:cNvPr id="14" name="Shape 11"/>
+          <p:cNvSpPr/>
+          <p:nvPr/>
+        </p:nvSpPr>
+        <p:spPr>
+          <a:xfrm>
+            <a:off x="694944" y="3863340"/>
+            <a:ext cx="54864" cy="54864"/>
+          </a:xfrm>
+          <a:prstGeom prst="ellipse">
+            <a:avLst/>
+          </a:prstGeom>
+          <a:solidFill>
+            <a:srgbClr val="FF6600"/>
+          </a:solidFill>
+          <a:ln/>
+        </p:spPr>
+      </p:sp>
+      <p:sp>
+        <p:nvSpPr>
+          <p:cNvPr id="15" name="Text 12"/>
+          <p:cNvSpPr txBox="1"/>
+          <p:nvPr/>
+        </p:nvSpPr>
+        <p:spPr>
+          <a:xfrm>
+            <a:off x="859536" y="3758184"/>
+            <a:ext cx="3800704" cy="283464"/>
+          </a:xfrm>
+          <a:prstGeom prst="rect">
+            <a:avLst/>
+          </a:prstGeom>
+          <a:noFill/>
+          <a:ln/>
+        </p:spPr>
+        <p:txBody>
+          <a:bodyPr wrap="square" lIns="0" tIns="0" rIns="0" bIns="0" rtlCol="0" anchor="t"/>
+          <a:lstStyle/>
+          <a:p>
+            <a:pPr indent="0" marL="0">
+              <a:lnSpc>
+                <a:spcPts val="1600"/>
+              </a:lnSpc>
+              <a:buNone/>
+            </a:pPr>
+            <a:r>
+              <a:rPr lang="en-US" sz="1150" dirty="0">
+                <a:solidFill>
+                  <a:srgbClr val="363636"/>
+                </a:solidFill>
+                <a:latin typeface="Arial" pitchFamily="34" charset="0"/>
+                <a:ea typeface="Arial" pitchFamily="34" charset="-122"/>
+                <a:cs typeface="Arial" pitchFamily="34" charset="-120"/>
+              </a:rPr>
+              <a:t>核对「清单有原文但未收集」表,澄清数量差异(废止/合并共6条)原因</a:t>
+            </a:r>
+            <a:endParaRPr lang="en-US" sz="1150" dirty="0"/>
+          </a:p>
+        </p:txBody>
+      </p:sp>
+      <p:sp>
+        <p:nvSpPr>
+          <p:cNvPr id="16" name="Shape 13"/>
+          <p:cNvSpPr/>
+          <p:nvPr/>
+        </p:nvSpPr>
+        <p:spPr>
+          <a:xfrm>
+            <a:off x="548640" y="4224528"/>
+            <a:ext cx="4221328" cy="448056"/>
+          </a:xfrm>
+          <a:prstGeom prst="roundRect">
+            <a:avLst>
+              <a:gd name="adj" fmla="val 10204"/>
+            </a:avLst>
+          </a:prstGeom>
+          <a:solidFill>
+            <a:srgbClr val="FFFFFF"/>
+          </a:solidFill>
+          <a:ln w="9525">
+            <a:solidFill>
+              <a:srgbClr val="E8E8E8"/>
+            </a:solidFill>
+            <a:prstDash val="solid"/>
+          </a:ln>
+        </p:spPr>
+      </p:sp>
+      <p:sp>
+        <p:nvSpPr>
+          <p:cNvPr id="17" name="Shape 14"/>
+          <p:cNvSpPr/>
+          <p:nvPr/>
+        </p:nvSpPr>
+        <p:spPr>
+          <a:xfrm>
+            <a:off x="566928" y="4270248"/>
+            <a:ext cx="32004" cy="356616"/>
+          </a:xfrm>
+          <a:prstGeom prst="rect">
+            <a:avLst/>
+          </a:prstGeom>
+          <a:solidFill>
+            <a:srgbClr val="FF6600"/>
+          </a:solidFill>
+          <a:ln/>
+        </p:spPr>
+      </p:sp>
+      <p:sp>
+        <p:nvSpPr>
+          <p:cNvPr id="18" name="Shape 15"/>
+          <p:cNvSpPr/>
+          <p:nvPr/>
+        </p:nvSpPr>
+        <p:spPr>
+          <a:xfrm>
+            <a:off x="694944" y="4411980"/>
+            <a:ext cx="54864" cy="54864"/>
+          </a:xfrm>
+          <a:prstGeom prst="ellipse">
+            <a:avLst/>
+          </a:prstGeom>
+          <a:solidFill>
+            <a:srgbClr val="FF6600"/>
+          </a:solidFill>
+          <a:ln/>
+        </p:spPr>
+      </p:sp>
+      <p:sp>
+        <p:nvSpPr>
+          <p:cNvPr id="19" name="Text 16"/>
+          <p:cNvSpPr txBox="1"/>
+          <p:nvPr/>
+        </p:nvSpPr>
+        <p:spPr>
+          <a:xfrm>
+            <a:off x="859536" y="4306824"/>
+            <a:ext cx="3800704" cy="283464"/>
+          </a:xfrm>
+          <a:prstGeom prst="rect">
+            <a:avLst/>
+          </a:prstGeom>
+          <a:noFill/>
+          <a:ln/>
+        </p:spPr>
+        <p:txBody>
+          <a:bodyPr wrap="square" lIns="0" tIns="0" rIns="0" bIns="0" rtlCol="0" anchor="t"/>
+          <a:lstStyle/>
+          <a:p>
+            <a:pPr indent="0" marL="0">
+              <a:lnSpc>
+                <a:spcPts val="1600"/>
+              </a:lnSpc>
+              <a:buNone/>
+            </a:pPr>
+            <a:r>
+              <a:rPr lang="en-US" sz="1150" dirty="0">
+                <a:solidFill>
+                  <a:srgbClr val="363636"/>
+                </a:solidFill>
+                <a:latin typeface="Arial" pitchFamily="34" charset="0"/>
+                <a:ea typeface="Arial" pitchFamily="34" charset="-122"/>
+                <a:cs typeface="Arial" pitchFamily="34" charset="-120"/>
+              </a:rPr>
+              <a:t>WP29 第199届会议提案作为法规动态线上推送汽研</a:t>
+            </a:r>
+            <a:endParaRPr lang="en-US" sz="1150" dirty="0"/>
+          </a:p>
+        </p:txBody>
+      </p:sp>
+      <p:sp>
+        <p:nvSpPr>
+          <p:cNvPr id="20" name="Shape 17"/>
+          <p:cNvSpPr/>
+          <p:nvPr/>
+        </p:nvSpPr>
+        <p:spPr>
+          <a:xfrm>
+            <a:off x="548640" y="4773168"/>
+            <a:ext cx="4221328" cy="448056"/>
+          </a:xfrm>
+          <a:prstGeom prst="roundRect">
+            <a:avLst>
+              <a:gd name="adj" fmla="val 10204"/>
+            </a:avLst>
+          </a:prstGeom>
+          <a:solidFill>
+            <a:srgbClr val="FFFFFF"/>
+          </a:solidFill>
+          <a:ln w="9525">
+            <a:solidFill>
+              <a:srgbClr val="E8E8E8"/>
+            </a:solidFill>
+            <a:prstDash val="solid"/>
+          </a:ln>
+        </p:spPr>
+      </p:sp>
+      <p:sp>
+        <p:nvSpPr>
+          <p:cNvPr id="21" name="Shape 18"/>
+          <p:cNvSpPr/>
+          <p:nvPr/>
+        </p:nvSpPr>
+        <p:spPr>
+          <a:xfrm>
+            <a:off x="566928" y="4818888"/>
+            <a:ext cx="32004" cy="356616"/>
+          </a:xfrm>
+          <a:prstGeom prst="rect">
+            <a:avLst/>
+          </a:prstGeom>
+          <a:solidFill>
+            <a:srgbClr val="FF6600"/>
+          </a:solidFill>
+          <a:ln/>
+        </p:spPr>
+      </p:sp>
+      <p:sp>
+        <p:nvSpPr>
+          <p:cNvPr id="22" name="Shape 19"/>
+          <p:cNvSpPr/>
+          <p:nvPr/>
+        </p:nvSpPr>
+        <p:spPr>
+          <a:xfrm>
+            <a:off x="694944" y="4960620"/>
+            <a:ext cx="54864" cy="54864"/>
+          </a:xfrm>
+          <a:prstGeom prst="ellipse">
+            <a:avLst/>
+          </a:prstGeom>
+          <a:solidFill>
+            <a:srgbClr val="FF6600"/>
+          </a:solidFill>
+          <a:ln/>
+        </p:spPr>
+      </p:sp>
+      <p:sp>
+        <p:nvSpPr>
+          <p:cNvPr id="23" name="Text 20"/>
+          <p:cNvSpPr txBox="1"/>
+          <p:nvPr/>
+        </p:nvSpPr>
+        <p:spPr>
+          <a:xfrm>
+            <a:off x="859536" y="4855464"/>
+            <a:ext cx="3800704" cy="283464"/>
+          </a:xfrm>
+          <a:prstGeom prst="rect">
+            <a:avLst/>
+          </a:prstGeom>
+          <a:noFill/>
+          <a:ln/>
+        </p:spPr>
+        <p:txBody>
+          <a:bodyPr wrap="square" lIns="0" tIns="0" rIns="0" bIns="0" rtlCol="0" anchor="t"/>
+          <a:lstStyle/>
+          <a:p>
+            <a:pPr indent="0" marL="0">
+              <a:lnSpc>
+                <a:spcPts val="1600"/>
+              </a:lnSpc>
+              <a:buNone/>
+            </a:pPr>
+            <a:r>
+              <a:rPr lang="en-US" sz="1150" dirty="0">
+                <a:solidFill>
+                  <a:srgbClr val="363636"/>
+                </a:solidFill>
+                <a:latin typeface="Arial" pitchFamily="34" charset="0"/>
+                <a:ea typeface="Arial" pitchFamily="34" charset="-122"/>
+                <a:cs typeface="Arial" pitchFamily="34" charset="-120"/>
+              </a:rPr>
+              <a:t>Q2及Q3海外法规监测工作季度总结</a:t>
+            </a:r>
+            <a:endParaRPr lang="en-US" sz="1150" dirty="0"/>
+          </a:p>
+        </p:txBody>
+      </p:sp>
+      <p:sp>
+        <p:nvSpPr>
+          <p:cNvPr id="24" name="Shape 21"/>
+          <p:cNvSpPr/>
+          <p:nvPr/>
+        </p:nvSpPr>
+        <p:spPr>
+          <a:xfrm>
+            <a:off x="548640" y="5321808"/>
+            <a:ext cx="4221328" cy="448056"/>
+          </a:xfrm>
+          <a:prstGeom prst="roundRect">
+            <a:avLst>
+              <a:gd name="adj" fmla="val 10204"/>
+            </a:avLst>
+          </a:prstGeom>
+          <a:solidFill>
+            <a:srgbClr val="FFFFFF"/>
+          </a:solidFill>
+          <a:ln w="9525">
+            <a:solidFill>
+              <a:srgbClr val="E8E8E8"/>
+            </a:solidFill>
+            <a:prstDash val="solid"/>
+          </a:ln>
+        </p:spPr>
+      </p:sp>
+      <p:sp>
+        <p:nvSpPr>
+          <p:cNvPr id="25" name="Shape 22"/>
+          <p:cNvSpPr/>
+          <p:nvPr/>
+        </p:nvSpPr>
+        <p:spPr>
+          <a:xfrm>
+            <a:off x="566928" y="5367528"/>
+            <a:ext cx="32004" cy="356616"/>
+          </a:xfrm>
+          <a:prstGeom prst="rect">
+            <a:avLst/>
+          </a:prstGeom>
+          <a:solidFill>
+            <a:srgbClr val="FF6600"/>
+          </a:solidFill>
+          <a:ln/>
+        </p:spPr>
+      </p:sp>
+      <p:sp>
+        <p:nvSpPr>
+          <p:cNvPr id="26" name="Shape 23"/>
+          <p:cNvSpPr/>
+          <p:nvPr/>
+        </p:nvSpPr>
+        <p:spPr>
+          <a:xfrm>
+            <a:off x="694944" y="5509260"/>
+            <a:ext cx="54864" cy="54864"/>
+          </a:xfrm>
+          <a:prstGeom prst="ellipse">
+            <a:avLst/>
+          </a:prstGeom>
+          <a:solidFill>
+            <a:srgbClr val="FF6600"/>
+          </a:solidFill>
+          <a:ln/>
+        </p:spPr>
+      </p:sp>
+      <p:sp>
+        <p:nvSpPr>
+          <p:cNvPr id="27" name="Text 24"/>
+          <p:cNvSpPr txBox="1"/>
+          <p:nvPr/>
+        </p:nvSpPr>
+        <p:spPr>
+          <a:xfrm>
+            <a:off x="859536" y="5404104"/>
+            <a:ext cx="3800704" cy="283464"/>
+          </a:xfrm>
+          <a:prstGeom prst="rect">
+            <a:avLst/>
+          </a:prstGeom>
+          <a:noFill/>
+          <a:ln/>
+        </p:spPr>
+        <p:txBody>
+          <a:bodyPr wrap="square" lIns="0" tIns="0" rIns="0" bIns="0" rtlCol="0" anchor="t"/>
+          <a:lstStyle/>
+          <a:p>
+            <a:pPr indent="0" marL="0">
+              <a:lnSpc>
+                <a:spcPts val="1600"/>
+              </a:lnSpc>
+              <a:buNone/>
+            </a:pPr>
+            <a:r>
+              <a:rPr lang="en-US" sz="1150" dirty="0">
+                <a:solidFill>
+                  <a:srgbClr val="363636"/>
+                </a:solidFill>
+                <a:latin typeface="Arial" pitchFamily="34" charset="0"/>
+                <a:ea typeface="Arial" pitchFamily="34" charset="-122"/>
+                <a:cs typeface="Arial" pitchFamily="34" charset="-120"/>
+              </a:rPr>
+              <a:t>多国法规清单持续补充交付与归类口径答疑</a:t>
+            </a:r>
+            <a:endParaRPr lang="en-US" sz="1150" dirty="0"/>
+          </a:p>
+        </p:txBody>
+      </p:sp>
+      <p:pic>
+        <p:nvPicPr>
+          <p:cNvPr id="28" name="Image 1" descr="/tmp/pptx_work/icons/send.png">    </p:cNvPr>
+          <p:cNvPicPr>
+            <a:picLocks noChangeAspect="1"/>
+          </p:cNvPicPr>
+          <p:nvPr/>
+        </p:nvPicPr>
+        <p:blipFill>
+          <a:blip r:embed="rId3"/>
+          <a:stretch>
+            <a:fillRect/>
+          </a:stretch>
+        </p:blipFill>
+        <p:spPr>
+          <a:xfrm>
+            <a:off x="5135728" y="2331720"/>
+            <a:ext cx="384048" cy="384048"/>
+          </a:xfrm>
+          <a:prstGeom prst="rect">
+            <a:avLst/>
+          </a:prstGeom>
+        </p:spPr>
+      </p:pic>
+      <p:sp>
+        <p:nvSpPr>
+          <p:cNvPr id="29" name="Text 25"/>
+          <p:cNvSpPr txBox="1"/>
+          <p:nvPr/>
+        </p:nvSpPr>
+        <p:spPr>
+          <a:xfrm>
+            <a:off x="5629504" y="2313432"/>
+            <a:ext cx="3727552" cy="420624"/>
+          </a:xfrm>
+          <a:prstGeom prst="rect">
+            <a:avLst/>
+          </a:prstGeom>
+          <a:noFill/>
+          <a:ln/>
+        </p:spPr>
+        <p:txBody>
+          <a:bodyPr wrap="square" lIns="0" tIns="0" rIns="0" bIns="0" rtlCol="0" anchor="ctr"/>
+          <a:lstStyle/>
+          <a:p>
+            <a:pPr indent="0" marL="0">
+              <a:lnSpc>
+                <a:spcPts val="1500"/>
+              </a:lnSpc>
+              <a:buNone/>
+            </a:pPr>
+            <a:r>
+              <a:rPr lang="en-US" sz="1300" b="1" dirty="0">
+                <a:solidFill>
+                  <a:srgbClr val="363636"/>
+                </a:solidFill>
+                <a:latin typeface="Arial" pitchFamily="34" charset="0"/>
+                <a:ea typeface="Arial" pitchFamily="34" charset="-122"/>
+                <a:cs typeface="Arial" pitchFamily="34" charset="-120"/>
+              </a:rPr>
+              <a:t>月报分发与内容营销支持</a:t>
+            </a:r>
+            <a:endParaRPr lang="en-US" sz="1300" dirty="0"/>
+          </a:p>
+        </p:txBody>
+      </p:sp>
+      <p:sp>
+        <p:nvSpPr>
+          <p:cNvPr id="30" name="Shape 26"/>
+          <p:cNvSpPr/>
+          <p:nvPr/>
+        </p:nvSpPr>
+        <p:spPr>
+          <a:xfrm>
+            <a:off x="5135728" y="2788920"/>
+            <a:ext cx="4221328" cy="0"/>
+          </a:xfrm>
+          <a:prstGeom prst="line">
+            <a:avLst/>
+          </a:prstGeom>
+          <a:noFill/>
+          <a:ln w="19050">
+            <a:solidFill>
+              <a:srgbClr val="FF6600"/>
+            </a:solidFill>
+            <a:prstDash val="solid"/>
+          </a:ln>
+        </p:spPr>
+      </p:sp>
+      <p:sp>
+        <p:nvSpPr>
+          <p:cNvPr id="31" name="Shape 27"/>
+          <p:cNvSpPr/>
+          <p:nvPr/>
+        </p:nvSpPr>
+        <p:spPr>
+          <a:xfrm>
+            <a:off x="5135728" y="2916936"/>
+            <a:ext cx="4221328" cy="448056"/>
+          </a:xfrm>
+          <a:prstGeom prst="roundRect">
+            <a:avLst>
+              <a:gd name="adj" fmla="val 10204"/>
+            </a:avLst>
+          </a:prstGeom>
+          <a:solidFill>
+            <a:srgbClr val="FFFFFF"/>
+          </a:solidFill>
+          <a:ln w="9525">
+            <a:solidFill>
+              <a:srgbClr val="E8E8E8"/>
+            </a:solidFill>
+            <a:prstDash val="solid"/>
+          </a:ln>
+        </p:spPr>
+      </p:sp>
+      <p:sp>
+        <p:nvSpPr>
+          <p:cNvPr id="32" name="Shape 28"/>
+          <p:cNvSpPr/>
+          <p:nvPr/>
+        </p:nvSpPr>
+        <p:spPr>
+          <a:xfrm>
+            <a:off x="5154016" y="2962656"/>
+            <a:ext cx="32004" cy="356616"/>
+          </a:xfrm>
+          <a:prstGeom prst="rect">
+            <a:avLst/>
+          </a:prstGeom>
+          <a:solidFill>
+            <a:srgbClr val="FF6600"/>
+          </a:solidFill>
+          <a:ln/>
+        </p:spPr>
+      </p:sp>
+      <p:sp>
+        <p:nvSpPr>
+          <p:cNvPr id="33" name="Shape 29"/>
+          <p:cNvSpPr/>
+          <p:nvPr/>
+        </p:nvSpPr>
+        <p:spPr>
+          <a:xfrm>
+            <a:off x="5282032" y="3104388"/>
+            <a:ext cx="54864" cy="54864"/>
+          </a:xfrm>
+          <a:prstGeom prst="ellipse">
+            <a:avLst/>
+          </a:prstGeom>
+          <a:solidFill>
+            <a:srgbClr val="FF6600"/>
+          </a:solidFill>
+          <a:ln/>
+        </p:spPr>
+      </p:sp>
+      <p:sp>
+        <p:nvSpPr>
+          <p:cNvPr id="34" name="Text 30"/>
+          <p:cNvSpPr txBox="1"/>
+          <p:nvPr/>
+        </p:nvSpPr>
+        <p:spPr>
+          <a:xfrm>
+            <a:off x="5446624" y="2999232"/>
+            <a:ext cx="3800704" cy="283464"/>
+          </a:xfrm>
+          <a:prstGeom prst="rect">
+            <a:avLst/>
+          </a:prstGeom>
+          <a:noFill/>
+          <a:ln/>
+        </p:spPr>
+        <p:txBody>
+          <a:bodyPr wrap="square" lIns="0" tIns="0" rIns="0" bIns="0" rtlCol="0" anchor="t"/>
+          <a:lstStyle/>
+          <a:p>
+            <a:pPr indent="0" marL="0">
+              <a:lnSpc>
+                <a:spcPts val="1600"/>
+              </a:lnSpc>
+              <a:buNone/>
+            </a:pPr>
+            <a:r>
+              <a:rPr lang="en-US" sz="1150" dirty="0">
+                <a:solidFill>
+                  <a:srgbClr val="363636"/>
+                </a:solidFill>
+                <a:latin typeface="Arial" pitchFamily="34" charset="0"/>
+                <a:ea typeface="Arial" pitchFamily="34" charset="-122"/>
+                <a:cs typeface="Arial" pitchFamily="34" charset="-120"/>
+              </a:rPr>
+              <a:t>录制【有问必答】视频</a:t>
+            </a:r>
+            <a:endParaRPr lang="en-US" sz="1150" dirty="0"/>
+          </a:p>
+        </p:txBody>
+      </p:sp>
+      <p:sp>
+        <p:nvSpPr>
+          <p:cNvPr id="35" name="Shape 31"/>
+          <p:cNvSpPr/>
+          <p:nvPr/>
+        </p:nvSpPr>
+        <p:spPr>
+          <a:xfrm>
+            <a:off x="5135728" y="3465576"/>
+            <a:ext cx="4221328" cy="448056"/>
+          </a:xfrm>
+          <a:prstGeom prst="roundRect">
+            <a:avLst>
+              <a:gd name="adj" fmla="val 10204"/>
+            </a:avLst>
+          </a:prstGeom>
+          <a:solidFill>
+            <a:srgbClr val="FFFFFF"/>
+          </a:solidFill>
+          <a:ln w="9525">
+            <a:solidFill>
+              <a:srgbClr val="E8E8E8"/>
+            </a:solidFill>
+            <a:prstDash val="solid"/>
+          </a:ln>
+        </p:spPr>
+      </p:sp>
+      <p:sp>
+        <p:nvSpPr>
+          <p:cNvPr id="36" name="Shape 32"/>
+          <p:cNvSpPr/>
+          <p:nvPr/>
+        </p:nvSpPr>
+        <p:spPr>
+          <a:xfrm>
+            <a:off x="5154016" y="3511296"/>
+            <a:ext cx="32004" cy="356616"/>
+          </a:xfrm>
+          <a:prstGeom prst="rect">
+            <a:avLst/>
+          </a:prstGeom>
+          <a:solidFill>
+            <a:srgbClr val="FF6600"/>
+          </a:solidFill>
+          <a:ln/>
+        </p:spPr>
+      </p:sp>
+      <p:sp>
+        <p:nvSpPr>
+          <p:cNvPr id="37" name="Shape 33"/>
+          <p:cNvSpPr/>
+          <p:nvPr/>
+        </p:nvSpPr>
+        <p:spPr>
+          <a:xfrm>
+            <a:off x="5282032" y="3653028"/>
+            <a:ext cx="54864" cy="54864"/>
+          </a:xfrm>
+          <a:prstGeom prst="ellipse">
+            <a:avLst/>
+          </a:prstGeom>
+          <a:solidFill>
+            <a:srgbClr val="FF6600"/>
+          </a:solidFill>
+          <a:ln/>
+        </p:spPr>
+      </p:sp>
+      <p:sp>
+        <p:nvSpPr>
+          <p:cNvPr id="38" name="Text 34"/>
+          <p:cNvSpPr txBox="1"/>
+          <p:nvPr/>
+        </p:nvSpPr>
+        <p:spPr>
+          <a:xfrm>
+            <a:off x="5446624" y="3547872"/>
+            <a:ext cx="3800704" cy="283464"/>
+          </a:xfrm>
+          <a:prstGeom prst="rect">
+            <a:avLst/>
+          </a:prstGeom>
+          <a:noFill/>
+          <a:ln/>
+        </p:spPr>
+        <p:txBody>
+          <a:bodyPr wrap="square" lIns="0" tIns="0" rIns="0" bIns="0" rtlCol="0" anchor="t"/>
+          <a:lstStyle/>
+          <a:p>
+            <a:pPr indent="0" marL="0">
+              <a:lnSpc>
+                <a:spcPts val="1600"/>
+              </a:lnSpc>
+              <a:buNone/>
+            </a:pPr>
+            <a:r>
+              <a:rPr lang="en-US" sz="1150" dirty="0">
+                <a:solidFill>
+                  <a:srgbClr val="363636"/>
+                </a:solidFill>
+                <a:latin typeface="Arial" pitchFamily="34" charset="0"/>
+                <a:ea typeface="Arial" pitchFamily="34" charset="-122"/>
+                <a:cs typeface="Arial" pitchFamily="34" charset="-120"/>
+              </a:rPr>
+              <a:t>「汽车制造」系列推广文章周更审阅(8-9月共9篇)</a:t>
+            </a:r>
+            <a:endParaRPr lang="en-US" sz="1150" dirty="0"/>
+          </a:p>
+        </p:txBody>
+      </p:sp>
+      <p:sp>
+        <p:nvSpPr>
+          <p:cNvPr id="39" name="Shape 35"/>
+          <p:cNvSpPr/>
+          <p:nvPr/>
+        </p:nvSpPr>
+        <p:spPr>
+          <a:xfrm>
+            <a:off x="5135728" y="4014216"/>
+            <a:ext cx="4221328" cy="448056"/>
+          </a:xfrm>
+          <a:prstGeom prst="roundRect">
+            <a:avLst>
+              <a:gd name="adj" fmla="val 10204"/>
+            </a:avLst>
+          </a:prstGeom>
+          <a:solidFill>
+            <a:srgbClr val="FFFFFF"/>
+          </a:solidFill>
+          <a:ln w="9525">
+            <a:solidFill>
+              <a:srgbClr val="E8E8E8"/>
+            </a:solidFill>
+            <a:prstDash val="solid"/>
+          </a:ln>
+        </p:spPr>
+      </p:sp>
+      <p:sp>
+        <p:nvSpPr>
+          <p:cNvPr id="40" name="Shape 36"/>
+          <p:cNvSpPr/>
+          <p:nvPr/>
+        </p:nvSpPr>
+        <p:spPr>
+          <a:xfrm>
+            <a:off x="5154016" y="4059936"/>
+            <a:ext cx="32004" cy="356616"/>
+          </a:xfrm>
+          <a:prstGeom prst="rect">
+            <a:avLst/>
+          </a:prstGeom>
+          <a:solidFill>
+            <a:srgbClr val="FF6600"/>
+          </a:solidFill>
+          <a:ln/>
+        </p:spPr>
+      </p:sp>
+      <p:sp>
+        <p:nvSpPr>
+          <p:cNvPr id="41" name="Shape 37"/>
+          <p:cNvSpPr/>
+          <p:nvPr/>
+        </p:nvSpPr>
+        <p:spPr>
+          <a:xfrm>
+            <a:off x="5282032" y="4201668"/>
+            <a:ext cx="54864" cy="54864"/>
+          </a:xfrm>
+          <a:prstGeom prst="ellipse">
+            <a:avLst/>
+          </a:prstGeom>
+          <a:solidFill>
+            <a:srgbClr val="FF6600"/>
+          </a:solidFill>
+          <a:ln/>
+        </p:spPr>
+      </p:sp>
+      <p:sp>
+        <p:nvSpPr>
+          <p:cNvPr id="42" name="Text 38"/>
+          <p:cNvSpPr txBox="1"/>
+          <p:nvPr/>
+        </p:nvSpPr>
+        <p:spPr>
+          <a:xfrm>
+            <a:off x="5446624" y="4096512"/>
+            <a:ext cx="3800704" cy="283464"/>
+          </a:xfrm>
+          <a:prstGeom prst="rect">
+            <a:avLst/>
+          </a:prstGeom>
+          <a:noFill/>
+          <a:ln/>
+        </p:spPr>
+        <p:txBody>
+          <a:bodyPr wrap="square" lIns="0" tIns="0" rIns="0" bIns="0" rtlCol="0" anchor="t"/>
+          <a:lstStyle/>
+          <a:p>
+            <a:pPr indent="0" marL="0">
+              <a:lnSpc>
+                <a:spcPts val="1600"/>
+              </a:lnSpc>
+              <a:buNone/>
+            </a:pPr>
+            <a:r>
+              <a:rPr lang="en-US" sz="1150" dirty="0">
+                <a:solidFill>
+                  <a:srgbClr val="363636"/>
+                </a:solidFill>
+                <a:latin typeface="Arial" pitchFamily="34" charset="0"/>
+                <a:ea typeface="Arial" pitchFamily="34" charset="-122"/>
+                <a:cs typeface="Arial" pitchFamily="34" charset="-120"/>
+              </a:rPr>
+              <a:t>EU 2026/1738 循环设计法规直播内容制作支持(大纲/PPT)</a:t>
+            </a:r>
+            <a:endParaRPr lang="en-US" sz="1150" dirty="0"/>
+          </a:p>
+        </p:txBody>
+      </p:sp>
+      <p:sp>
+        <p:nvSpPr>
+          <p:cNvPr id="43" name="Shape 39"/>
+          <p:cNvSpPr/>
+          <p:nvPr/>
+        </p:nvSpPr>
+        <p:spPr>
+          <a:xfrm>
+            <a:off x="5135728" y="4562856"/>
+            <a:ext cx="4221328" cy="448056"/>
+          </a:xfrm>
+          <a:prstGeom prst="roundRect">
+            <a:avLst>
+              <a:gd name="adj" fmla="val 10204"/>
+            </a:avLst>
+          </a:prstGeom>
+          <a:solidFill>
+            <a:srgbClr val="FFFFFF"/>
+          </a:solidFill>
+          <a:ln w="9525">
+            <a:solidFill>
+              <a:srgbClr val="E8E8E8"/>
+            </a:solidFill>
+            <a:prstDash val="solid"/>
+          </a:ln>
+        </p:spPr>
+      </p:sp>
+      <p:sp>
+        <p:nvSpPr>
+          <p:cNvPr id="44" name="Shape 40"/>
+          <p:cNvSpPr/>
+          <p:nvPr/>
+        </p:nvSpPr>
+        <p:spPr>
+          <a:xfrm>
+            <a:off x="5154016" y="4608576"/>
+            <a:ext cx="32004" cy="356616"/>
+          </a:xfrm>
+          <a:prstGeom prst="rect">
+            <a:avLst/>
+          </a:prstGeom>
+          <a:solidFill>
+            <a:srgbClr val="FF6600"/>
+          </a:solidFill>
+          <a:ln/>
+        </p:spPr>
+      </p:sp>
+      <p:sp>
+        <p:nvSpPr>
+          <p:cNvPr id="45" name="Shape 41"/>
+          <p:cNvSpPr/>
+          <p:nvPr/>
+        </p:nvSpPr>
+        <p:spPr>
+          <a:xfrm>
+            <a:off x="5282032" y="4750308"/>
+            <a:ext cx="54864" cy="54864"/>
+          </a:xfrm>
+          <a:prstGeom prst="ellipse">
+            <a:avLst/>
+          </a:prstGeom>
+          <a:solidFill>
+            <a:srgbClr val="FF6600"/>
+          </a:solidFill>
+          <a:ln/>
+        </p:spPr>
+      </p:sp>
+      <p:sp>
+        <p:nvSpPr>
+          <p:cNvPr id="46" name="Text 42"/>
+          <p:cNvSpPr txBox="1"/>
+          <p:nvPr/>
+        </p:nvSpPr>
+        <p:spPr>
+          <a:xfrm>
+            <a:off x="5446624" y="4645152"/>
+            <a:ext cx="3800704" cy="283464"/>
+          </a:xfrm>
+          <a:prstGeom prst="rect">
+            <a:avLst/>
+          </a:prstGeom>
+          <a:noFill/>
+          <a:ln/>
+        </p:spPr>
+        <p:txBody>
+          <a:bodyPr wrap="square" lIns="0" tIns="0" rIns="0" bIns="0" rtlCol="0" anchor="t"/>
+          <a:lstStyle/>
+          <a:p>
+            <a:pPr indent="0" marL="0">
+              <a:lnSpc>
+                <a:spcPts val="1600"/>
+              </a:lnSpc>
+              <a:buNone/>
+            </a:pPr>
+            <a:r>
+              <a:rPr lang="en-US" sz="1150" dirty="0">
+                <a:solidFill>
+                  <a:srgbClr val="363636"/>
+                </a:solidFill>
+                <a:latin typeface="Arial" pitchFamily="34" charset="0"/>
+                <a:ea typeface="Arial" pitchFamily="34" charset="-122"/>
+                <a:cs typeface="Arial" pitchFamily="34" charset="-120"/>
+              </a:rPr>
+              <a:t>法规月报按时分发至汽研客户并跟进反馈</a:t>
+            </a:r>
+            <a:endParaRPr lang="en-US" sz="1150" dirty="0"/>
+          </a:p>
+        </p:txBody>
+      </p:sp>
+      <p:sp>
+        <p:nvSpPr>
+          <p:cNvPr id="47" name="Shape 43"/>
+          <p:cNvSpPr/>
+          <p:nvPr/>
+        </p:nvSpPr>
+        <p:spPr>
+          <a:xfrm>
+            <a:off x="5135728" y="5111496"/>
+            <a:ext cx="4221328" cy="448056"/>
+          </a:xfrm>
+          <a:prstGeom prst="roundRect">
+            <a:avLst>
+              <a:gd name="adj" fmla="val 10204"/>
+            </a:avLst>
+          </a:prstGeom>
+          <a:solidFill>
+            <a:srgbClr val="FFFFFF"/>
+          </a:solidFill>
+          <a:ln w="9525">
+            <a:solidFill>
+              <a:srgbClr val="E8E8E8"/>
+            </a:solidFill>
+            <a:prstDash val="solid"/>
+          </a:ln>
+        </p:spPr>
+      </p:sp>
+      <p:sp>
+        <p:nvSpPr>
+          <p:cNvPr id="48" name="Shape 44"/>
+          <p:cNvSpPr/>
+          <p:nvPr/>
+        </p:nvSpPr>
+        <p:spPr>
+          <a:xfrm>
+            <a:off x="5154016" y="5157216"/>
+            <a:ext cx="32004" cy="356616"/>
+          </a:xfrm>
+          <a:prstGeom prst="rect">
+            <a:avLst/>
+          </a:prstGeom>
+          <a:solidFill>
+            <a:srgbClr val="FF6600"/>
+          </a:solidFill>
+          <a:ln/>
+        </p:spPr>
+      </p:sp>
+      <p:sp>
+        <p:nvSpPr>
+          <p:cNvPr id="49" name="Shape 45"/>
+          <p:cNvSpPr/>
+          <p:nvPr/>
+        </p:nvSpPr>
+        <p:spPr>
+          <a:xfrm>
+            <a:off x="5282032" y="5298948"/>
+            <a:ext cx="54864" cy="54864"/>
+          </a:xfrm>
+          <a:prstGeom prst="ellipse">
+            <a:avLst/>
+          </a:prstGeom>
+          <a:solidFill>
+            <a:srgbClr val="FF6600"/>
+          </a:solidFill>
+          <a:ln/>
+        </p:spPr>
+      </p:sp>
+      <p:sp>
+        <p:nvSpPr>
+          <p:cNvPr id="50" name="Text 46"/>
+          <p:cNvSpPr txBox="1"/>
+          <p:nvPr/>
+        </p:nvSpPr>
+        <p:spPr>
+          <a:xfrm>
+            <a:off x="5446624" y="5193792"/>
+            <a:ext cx="3800704" cy="283464"/>
+          </a:xfrm>
+          <a:prstGeom prst="rect">
+            <a:avLst/>
+          </a:prstGeom>
+          <a:noFill/>
+          <a:ln/>
+        </p:spPr>
+        <p:txBody>
+          <a:bodyPr wrap="square" lIns="0" tIns="0" rIns="0" bIns="0" rtlCol="0" anchor="t"/>
+          <a:lstStyle/>
+          <a:p>
+            <a:pPr indent="0" marL="0">
+              <a:lnSpc>
+                <a:spcPts val="1600"/>
+              </a:lnSpc>
+              <a:buNone/>
+            </a:pPr>
+            <a:r>
+              <a:rPr lang="en-US" sz="1150" dirty="0">
+                <a:solidFill>
+                  <a:srgbClr val="363636"/>
+                </a:solidFill>
+                <a:latin typeface="Arial" pitchFamily="34" charset="0"/>
+                <a:ea typeface="Arial" pitchFamily="34" charset="-122"/>
+                <a:cs typeface="Arial" pitchFamily="34" charset="-120"/>
+              </a:rPr>
+              <a:t>月报 Spotlight 专题内容策划与选题调整</a:t>
+            </a:r>
+            <a:endParaRPr lang="en-US" sz="1150" dirty="0"/>
+          </a:p>
+        </p:txBody>
+      </p:sp>
+      <p:sp>
+        <p:nvSpPr>
+          <p:cNvPr id="51" name="Shape 47"/>
+          <p:cNvSpPr/>
+          <p:nvPr/>
+        </p:nvSpPr>
+        <p:spPr>
+          <a:xfrm>
+            <a:off x="4952848" y="2423160"/>
+            <a:ext cx="0" cy="3886200"/>
+          </a:xfrm>
+          <a:prstGeom prst="line">
+            <a:avLst/>
+          </a:prstGeom>
+          <a:noFill/>
+          <a:ln w="6350">
+            <a:solidFill>
+              <a:srgbClr val="E0E0E0"/>
+            </a:solidFill>
+            <a:prstDash val="solid"/>
+          </a:ln>
+        </p:spPr>
+      </p:sp>
+      <p:sp>
+        <p:nvSpPr>
+          <p:cNvPr id="52" name="Shape 48"/>
+          <p:cNvSpPr/>
+          <p:nvPr/>
+        </p:nvSpPr>
+        <p:spPr>
+          <a:xfrm>
+            <a:off x="0" y="6803136"/>
+            <a:ext cx="9905695" cy="54864"/>
+          </a:xfrm>
+          <a:prstGeom prst="rect">
+            <a:avLst/>
+          </a:prstGeom>
+          <a:solidFill>
+            <a:srgbClr val="FF6600"/>
+          </a:solidFill>
+          <a:ln/>
+        </p:spPr>
+      </p:sp>
+      <p:sp>
+        <p:nvSpPr>
+          <p:cNvPr id="53" name="Text 49"/>
+          <p:cNvSpPr txBox="1"/>
+          <p:nvPr/>
+        </p:nvSpPr>
+        <p:spPr>
+          <a:xfrm>
+            <a:off x="8991295" y="6510528"/>
+            <a:ext cx="731520" cy="256032"/>
+          </a:xfrm>
+          <a:prstGeom prst="rect">
+            <a:avLst/>
+          </a:prstGeom>
+          <a:noFill/>
+          <a:ln/>
+        </p:spPr>
+        <p:txBody>
+          <a:bodyPr wrap="square" lIns="0" tIns="0" rIns="0" bIns="0" rtlCol="0" anchor="ctr"/>
+          <a:lstStyle/>
+          <a:p>
+            <a:pPr algn="r" indent="0" marL="0">
+              <a:buNone/>
+            </a:pPr>
+            <a:r>
+              <a:rPr lang="en-US" sz="900" dirty="0">
+                <a:solidFill>
+                  <a:srgbClr val="848685"/>
+                </a:solidFill>
+                <a:latin typeface="Arial" pitchFamily="34" charset="0"/>
+                <a:ea typeface="Arial" pitchFamily="34" charset="-122"/>
+                <a:cs typeface="Arial" pitchFamily="34" charset="-120"/>
+              </a:rPr>
+              <a:t>6/7</a:t>
+            </a:r>
+            <a:endParaRPr lang="en-US" sz="900" dirty="0"/>
+          </a:p>
+        </p:txBody>
+      </p:sp>
+    </p:spTree>
+  </p:cSld>
+  <p:clrMapOvr>
+    <a:masterClrMapping/>
+  </p:clrMapOvr>
+</p:sld>
+</file>
+
+<file path=ppt/slides/slide7.xml><?xml version="1.0" encoding="utf-8"?>
+<p:sld xmlns:a="http://schemas.openxmlformats.org/drawingml/2006/main" xmlns:r="http://schemas.openxmlformats.org/officeDocument/2006/relationships" xmlns:p="http://schemas.openxmlformats.org/presentationml/2006/main">
+  <p:cSld name="Slide 7">
+    <p:bg>
+      <p:bgPr>
+        <a:blipFill dpi="0" rotWithShape="1">
+          <a:blip r:embed="rId1">
+            <a:lum/>
+          </a:blip>
+          <a:srcRect/>
+          <a:stretch>
+            <a:fillRect/>
+          </a:stretch>
+        </a:blipFill>
+        <a:effectLst/>
+      </p:bgPr>
+    </p:bg>
+    <p:spTree>
+      <p:nvGrpSpPr>
+        <p:cNvPr id="1" name=""/>
+        <p:cNvGrpSpPr/>
+        <p:nvPr/>
+      </p:nvGrpSpPr>
+      <p:grpSpPr>
+        <a:xfrm>
+          <a:off x="0" y="0"/>
+          <a:ext cx="0" cy="0"/>
+          <a:chOff x="0" y="0"/>
+          <a:chExt cx="0" cy="0"/>
+        </a:xfrm>
+      </p:grpSpPr>
+      <p:sp>
+        <p:nvSpPr>
+          <p:cNvPr id="2" name="Text 0"/>
+          <p:cNvSpPr txBox="1"/>
+          <p:nvPr/>
+        </p:nvSpPr>
+        <p:spPr>
+          <a:xfrm>
+            <a:off x="548640" y="1691640"/>
+            <a:ext cx="8808415" cy="256032"/>
+          </a:xfrm>
+          <a:prstGeom prst="rect">
+            <a:avLst/>
+          </a:prstGeom>
+          <a:noFill/>
+          <a:ln/>
+        </p:spPr>
+        <p:txBody>
+          <a:bodyPr wrap="square" lIns="0" tIns="0" rIns="0" bIns="0" rtlCol="0" anchor="ctr"/>
+          <a:lstStyle/>
+          <a:p>
+            <a:pPr indent="0" marL="0">
+              <a:buNone/>
+            </a:pPr>
+            <a:r>
+              <a:rPr lang="en-US" sz="1050" spc="100" kern="0" dirty="0">
+                <a:solidFill>
+                  <a:srgbClr val="848685"/>
+                </a:solidFill>
+                <a:latin typeface="Arial" pitchFamily="34" charset="0"/>
+                <a:ea typeface="Arial" pitchFamily="34" charset="-122"/>
+                <a:cs typeface="Arial" pitchFamily="34" charset="-120"/>
+              </a:rPr>
               <a:t>第四部分 · 10月工作计划</a:t>
             </a:r>
             <a:endParaRPr lang="en-US" sz="1050" dirty="0"/>
@@ -8911,7 +9510,7 @@
                 <a:ea typeface="Arial" pitchFamily="34" charset="-122"/>
                 <a:cs typeface="Arial" pitchFamily="34" charset="-120"/>
               </a:rPr>
-              <a:t>推进汽研客户法规数据需求对接与交付</a:t>
+              <a:t>法规检索客户需求响应与数据交付</a:t>
             </a:r>
             <a:endParaRPr lang="en-US" sz="1150" dirty="0"/>
           </a:p>
@@ -9021,7 +9620,7 @@
                 <a:ea typeface="Arial" pitchFamily="34" charset="-122"/>
                 <a:cs typeface="Arial" pitchFamily="34" charset="-120"/>
               </a:rPr>
-              <a:t>配合 Q4 海外法规监测季度总结</a:t>
+              <a:t>内容营销与客户答疑支持</a:t>
             </a:r>
             <a:endParaRPr lang="en-US" sz="1150" dirty="0"/>
           </a:p>
@@ -9190,7 +9789,7 @@
                 <a:ea typeface="Arial" pitchFamily="34" charset="-122"/>
                 <a:cs typeface="Arial" pitchFamily="34" charset="-120"/>
               </a:rPr>
-              <a:t>6/6</a:t>
+              <a:t>7/7</a:t>
             </a:r>
             <a:endParaRPr lang="en-US" sz="900" dirty="0"/>
           </a:p>

</xml_diff>

<commit_message>
Rework E-mark highlights slide around retention/conversion design
Show gap-to-service mapping and expert-consultation CTA instead of
generic feature tour, per feedback that highlights should demonstrate
what keeps customers engaged with the platform.

Co-Authored-By: Claude Sonnet 5 <noreply@anthropic.com>
Claude-Session: https://claude.ai/code/session_015nf3knxVoVVLYAWgtjzRg9
</commit_message>
<xml_diff>
--- a/2026年8-9月工作汇报.pptx
+++ b/2026年8-9月工作汇报.pptx
@@ -7047,7 +7047,7 @@
                 <a:ea typeface="Georgia" pitchFamily="34" charset="-122"/>
                 <a:cs typeface="Georgia" pitchFamily="34" charset="-120"/>
               </a:rPr>
-              <a:t>E-mark 合规工具亮点</a:t>
+              <a:t>E-mark 工具:从免费自评到持续服务转化</a:t>
             </a:r>
             <a:endParaRPr lang="en-US" sz="1900" dirty="0"/>
           </a:p>
@@ -7109,7 +7109,7 @@
                 <a:ea typeface="Arial" pitchFamily="34" charset="-122"/>
                 <a:cs typeface="Arial" pitchFamily="34" charset="-120"/>
               </a:rPr>
-              <a:t>覆盖整车/系统/部件三类角色,逐条自评联动多国认证结论,专项评估模块按法规持续扩展。</a:t>
+              <a:t>中途保存的档案可随时载回继续;每条法规缺口自动映射对应服务建议,报告生成后引导预约专家解读——评估留痕、结果即线索,让客户留在「一点通」持续互动,而非用完即走。</a:t>
             </a:r>
             <a:endParaRPr lang="en-US" sz="1100" dirty="0"/>
           </a:p>
@@ -7124,11 +7124,11 @@
         <p:spPr>
           <a:xfrm>
             <a:off x="548640" y="2642616"/>
-            <a:ext cx="4645152" cy="2645664"/>
+            <a:ext cx="2953512" cy="4147859"/>
           </a:xfrm>
           <a:prstGeom prst="roundRect">
             <a:avLst>
-              <a:gd name="adj" fmla="val 2074"/>
+              <a:gd name="adj" fmla="val 1858"/>
             </a:avLst>
           </a:prstGeom>
           <a:solidFill>
@@ -7151,7 +7151,7 @@
         <p:spPr>
           <a:xfrm>
             <a:off x="548640" y="2642616"/>
-            <a:ext cx="4645152" cy="45720"/>
+            <a:ext cx="2953512" cy="45720"/>
           </a:xfrm>
           <a:prstGeom prst="rect">
             <a:avLst/>
@@ -7164,7 +7164,7 @@
       </p:sp>
       <p:pic>
         <p:nvPicPr>
-          <p:cNvPr id="8" name="Image 0" descr="/tmp/pptx_work/screenshots/c1_landing.png">    </p:cNvPr>
+          <p:cNvPr id="8" name="Image 0" descr="/tmp/pptx_work/screenshots/c4_gapservice.png">    </p:cNvPr>
           <p:cNvPicPr>
             <a:picLocks noChangeAspect="1"/>
           </p:cNvPicPr>
@@ -7179,7 +7179,7 @@
         <p:spPr>
           <a:xfrm>
             <a:off x="676656" y="2770632"/>
-            <a:ext cx="4389120" cy="1859280"/>
+            <a:ext cx="2697480" cy="3361475"/>
           </a:xfrm>
           <a:prstGeom prst="rect">
             <a:avLst/>
@@ -7194,8 +7194,8 @@
         </p:nvSpPr>
         <p:spPr>
           <a:xfrm>
-            <a:off x="676656" y="4684776"/>
-            <a:ext cx="4389120" cy="0"/>
+            <a:off x="676656" y="6186971"/>
+            <a:ext cx="2697480" cy="0"/>
           </a:xfrm>
           <a:prstGeom prst="line">
             <a:avLst/>
@@ -7217,8 +7217,8 @@
         </p:nvSpPr>
         <p:spPr>
           <a:xfrm>
-            <a:off x="676656" y="4739640"/>
-            <a:ext cx="4389120" cy="457200"/>
+            <a:off x="676656" y="6241835"/>
+            <a:ext cx="2697480" cy="457200"/>
           </a:xfrm>
           <a:prstGeom prst="rect">
             <a:avLst/>
@@ -7245,7 +7245,7 @@
                 <a:ea typeface="Arial" pitchFamily="34" charset="-122"/>
                 <a:cs typeface="Arial" pitchFamily="34" charset="-120"/>
               </a:rPr>
-              <a:t>六步智能导航:企业画像→范围界定→法规盘点→体系自评→认证旅程→行动清单,全流程闭环</a:t>
+              <a:t>行动清单「缺口→服务映射」:每条待办自动标注对应服务(如版本追踪订阅),自评结果直接转化为服务线索</a:t>
             </a:r>
             <a:endParaRPr lang="en-US" sz="1050" dirty="0"/>
           </a:p>
@@ -7259,12 +7259,12 @@
         </p:nvSpPr>
         <p:spPr>
           <a:xfrm>
-            <a:off x="5468112" y="2642616"/>
-            <a:ext cx="3319272" cy="4085258"/>
+            <a:off x="3776472" y="2642616"/>
+            <a:ext cx="4736592" cy="2923266"/>
           </a:xfrm>
           <a:prstGeom prst="roundRect">
             <a:avLst>
-              <a:gd name="adj" fmla="val 1653"/>
+              <a:gd name="adj" fmla="val 1877"/>
             </a:avLst>
           </a:prstGeom>
           <a:solidFill>
@@ -7286,8 +7286,8 @@
         </p:nvSpPr>
         <p:spPr>
           <a:xfrm>
-            <a:off x="5468112" y="2642616"/>
-            <a:ext cx="3319272" cy="45720"/>
+            <a:off x="3776472" y="2642616"/>
+            <a:ext cx="4736592" cy="45720"/>
           </a:xfrm>
           <a:prstGeom prst="rect">
             <a:avLst/>
@@ -7300,7 +7300,7 @@
       </p:sp>
       <p:pic>
         <p:nvPicPr>
-          <p:cNvPr id="13" name="Image 1" descr="/tmp/pptx_work/screenshots/c2_conclusion.png">    </p:cNvPr>
+          <p:cNvPr id="13" name="Image 1" descr="/tmp/pptx_work/screenshots/c5_expertcta.png">    </p:cNvPr>
           <p:cNvPicPr>
             <a:picLocks noChangeAspect="1"/>
           </p:cNvPicPr>
@@ -7314,8 +7314,8 @@
         </p:blipFill>
         <p:spPr>
           <a:xfrm>
-            <a:off x="5596128" y="2770632"/>
-            <a:ext cx="3063240" cy="3298874"/>
+            <a:off x="3904488" y="2770632"/>
+            <a:ext cx="4480560" cy="2136882"/>
           </a:xfrm>
           <a:prstGeom prst="rect">
             <a:avLst/>
@@ -7330,8 +7330,8 @@
         </p:nvSpPr>
         <p:spPr>
           <a:xfrm>
-            <a:off x="5596128" y="6124370"/>
-            <a:ext cx="3063240" cy="0"/>
+            <a:off x="3904488" y="4962378"/>
+            <a:ext cx="4480560" cy="0"/>
           </a:xfrm>
           <a:prstGeom prst="line">
             <a:avLst/>
@@ -7353,8 +7353,8 @@
         </p:nvSpPr>
         <p:spPr>
           <a:xfrm>
-            <a:off x="5596128" y="6179234"/>
-            <a:ext cx="3063240" cy="457200"/>
+            <a:off x="3904488" y="5017242"/>
+            <a:ext cx="4480560" cy="457200"/>
           </a:xfrm>
           <a:prstGeom prst="rect">
             <a:avLst/>
@@ -7381,7 +7381,7 @@
                 <a:ea typeface="Arial" pitchFamily="34" charset="-122"/>
                 <a:cs typeface="Arial" pitchFamily="34" charset="-120"/>
               </a:rPr>
-              <a:t>逐条自评联动「认证与通行结论」:74 个国家/地区可搜索查询互认范围</a:t>
+              <a:t>报告生成后引导「预约专家解读我的缺口」,把一次性免费评估转化为持续咨询与代办委托</a:t>
             </a:r>
             <a:endParaRPr lang="en-US" sz="1050" dirty="0"/>
           </a:p>

</xml_diff>

<commit_message>
Formalize wording on tool highlight slides (6-9)
Replace colloquial phrasing (钩子/往前走了一格/挪动/优先下单) with
more formal business-report register throughout the four highlight
slides' titles and body copy.

Co-Authored-By: Claude Sonnet 5 <noreply@anthropic.com>
Claude-Session: https://claude.ai/code/session_015nf3knxVoVVLYAWgtjzRg9
</commit_message>
<xml_diff>
--- a/2026年8-9月工作汇报.pptx
+++ b/2026年8-9月工作汇报.pptx
@@ -9663,7 +9663,7 @@
                 <a:ea typeface="Georgia" pitchFamily="34" charset="-122"/>
                 <a:cs typeface="Georgia" pitchFamily="34" charset="-120"/>
               </a:rPr>
-              <a:t>逐条订阅法规动态</a:t>
+              <a:t>法规逐条订阅机制</a:t>
             </a:r>
             <a:endParaRPr lang="en-US" sz="1900" dirty="0"/>
           </a:p>
@@ -9860,7 +9860,7 @@
                 <a:ea typeface="Arial" pitchFamily="34" charset="-122"/>
                 <a:cs typeface="Arial" pitchFamily="34" charset="-120"/>
               </a:rPr>
-              <a:t>法规盘点页每一条法规都可单独勾选「订阅该法规动态」,而不是只给一次性的合规判定。</a:t>
+              <a:t>法规盘点页支持按条订阅法规动态更新,评估结果不再是一次性判定。</a:t>
             </a:r>
             <a:endParaRPr lang="en-US" sz="1350" dirty="0"/>
           </a:p>
@@ -9895,7 +9895,7 @@
         <p:spPr>
           <a:xfrm>
             <a:off x="4937760" y="4059936"/>
-            <a:ext cx="4419295" cy="310896"/>
+            <a:ext cx="4419295" cy="530352"/>
           </a:xfrm>
           <a:prstGeom prst="rect">
             <a:avLst/>
@@ -9922,7 +9922,7 @@
                 <a:ea typeface="Arial" pitchFamily="34" charset="-122"/>
                 <a:cs typeface="Arial" pitchFamily="34" charset="-120"/>
               </a:rPr>
-              <a:t>用户按自身产品逐条建立专属关注清单,而非读完报告就走</a:t>
+              <a:t>用户可按自身产品建立个性化关注清单,评估完成后仍保留后续追踪需求</a:t>
             </a:r>
             <a:endParaRPr lang="en-US" sz="1150" dirty="0"/>
           </a:p>
@@ -9936,7 +9936,7 @@
         </p:nvSpPr>
         <p:spPr>
           <a:xfrm>
-            <a:off x="4754880" y="4581144"/>
+            <a:off x="4754880" y="4800600"/>
             <a:ext cx="64008" cy="64008"/>
           </a:xfrm>
           <a:prstGeom prst="ellipse">
@@ -9956,7 +9956,7 @@
         </p:nvSpPr>
         <p:spPr>
           <a:xfrm>
-            <a:off x="4937760" y="4480560"/>
+            <a:off x="4937760" y="4700016"/>
             <a:ext cx="4419295" cy="310896"/>
           </a:xfrm>
           <a:prstGeom prst="rect">
@@ -9984,7 +9984,7 @@
                 <a:ea typeface="Arial" pitchFamily="34" charset="-122"/>
                 <a:cs typeface="Arial" pitchFamily="34" charset="-120"/>
               </a:rPr>
-              <a:t>法规一旦更新即有理由唤回用户回到工具查看,变成持续到访的钩子</a:t>
+              <a:t>法规更新时系统主动提示,形成持续性的平台使用场景</a:t>
             </a:r>
             <a:endParaRPr lang="en-US" sz="1150" dirty="0"/>
           </a:p>
@@ -10160,7 +10160,7 @@
                 <a:ea typeface="Georgia" pitchFamily="34" charset="-122"/>
                 <a:cs typeface="Georgia" pitchFamily="34" charset="-120"/>
               </a:rPr>
-              <a:t>九站进度条,拉长使用周期</a:t>
+              <a:t>认证旅程九站进度管理</a:t>
             </a:r>
             <a:endParaRPr lang="en-US" sz="1900" dirty="0"/>
           </a:p>
@@ -10357,7 +10357,7 @@
                 <a:ea typeface="Arial" pitchFamily="34" charset="-122"/>
                 <a:cs typeface="Arial" pitchFamily="34" charset="-120"/>
               </a:rPr>
-              <a:t>认证旅程把型式批准全流程拆成 9 个站点,每站显示真实完成度与下一步材料清单(如「获证与打标」已获 9/90 张证书)。</a:t>
+              <a:t>认证旅程将型式批准全流程拆分为 9 个站点,实时显示各站完成情况与所需材料(如「获证与打标」站已获 9/90 张证书)。</a:t>
             </a:r>
             <a:endParaRPr lang="en-US" sz="1350" dirty="0"/>
           </a:p>
@@ -10419,7 +10419,7 @@
                 <a:ea typeface="Arial" pitchFamily="34" charset="-122"/>
                 <a:cs typeface="Arial" pitchFamily="34" charset="-120"/>
               </a:rPr>
-              <a:t>认证周期本身横跨数月,进度条把长周期变成看得见的阶段性成就</a:t>
+              <a:t>认证周期通常横跨数月,分阶段进度呈现使长周期目标可视化</a:t>
             </a:r>
             <a:endParaRPr lang="en-US" sz="1150" dirty="0"/>
           </a:p>
@@ -10481,7 +10481,7 @@
                 <a:ea typeface="Arial" pitchFamily="34" charset="-122"/>
                 <a:cs typeface="Arial" pitchFamily="34" charset="-120"/>
               </a:rPr>
-              <a:t>每次回访都能看到「往前走了一格」,而不是从零开始</a:t>
+              <a:t>用户每次访问均可查看阶段性进展,降低半途而废的可能性</a:t>
             </a:r>
             <a:endParaRPr lang="en-US" sz="1150" dirty="0"/>
           </a:p>
@@ -10657,7 +10657,7 @@
                 <a:ea typeface="Georgia" pitchFamily="34" charset="-122"/>
                 <a:cs typeface="Georgia" pitchFamily="34" charset="-120"/>
               </a:rPr>
-              <a:t>合规打分,给客户一个想改进的数字</a:t>
+              <a:t>合规成熟度量化评分</a:t>
             </a:r>
             <a:endParaRPr lang="en-US" sz="1900" dirty="0"/>
           </a:p>
@@ -10854,7 +10854,7 @@
                 <a:ea typeface="Arial" pitchFamily="34" charset="-122"/>
                 <a:cs typeface="Arial" pitchFamily="34" charset="-120"/>
               </a:rPr>
-              <a:t>法规完成度、体系成熟度双轴打分,自动定位所在象限(如「初始」)并给出风险研判与优先建议。</a:t>
+              <a:t>法规完成度与体系成熟度双轴打分,自动定位所在象限(如「初始」),并给出风险研判与优先建议。</a:t>
             </a:r>
             <a:endParaRPr lang="en-US" sz="1350" dirty="0"/>
           </a:p>
@@ -10916,7 +10916,7 @@
                 <a:ea typeface="Arial" pitchFamily="34" charset="-122"/>
                 <a:cs typeface="Arial" pitchFamily="34" charset="-120"/>
               </a:rPr>
-              <a:t>分数随认证进展实时变化,用户有动力回来复测、看象限有没有挪动</a:t>
+              <a:t>评分随认证推进动态更新,形成复测与持续跟踪的内在驱动</a:t>
             </a:r>
             <a:endParaRPr lang="en-US" sz="1150" dirty="0"/>
           </a:p>
@@ -10978,7 +10978,7 @@
                 <a:ea typeface="Arial" pitchFamily="34" charset="-122"/>
                 <a:cs typeface="Arial" pitchFamily="34" charset="-120"/>
               </a:rPr>
-              <a:t>0–100 统一刻度,自我进步和同行对比都有了参照系</a:t>
+              <a:t>0–100 统一量表,便于企业自我对比及同行参照</a:t>
             </a:r>
             <a:endParaRPr lang="en-US" sz="1150" dirty="0"/>
           </a:p>
@@ -11154,7 +11154,7 @@
                 <a:ea typeface="Georgia" pitchFamily="34" charset="-122"/>
                 <a:cs typeface="Georgia" pitchFamily="34" charset="-120"/>
               </a:rPr>
-              <a:t>缺口分级,每条配一项可购买的服务</a:t>
+              <a:t>缺口分级与服务映射</a:t>
             </a:r>
             <a:endParaRPr lang="en-US" sz="1900" dirty="0"/>
           </a:p>
@@ -11351,7 +11351,7 @@
                 <a:ea typeface="Arial" pitchFamily="34" charset="-122"/>
                 <a:cs typeface="Arial" pitchFamily="34" charset="-120"/>
               </a:rPr>
-              <a:t>行动清单把待办按「高/中」风险分级排序,每条缺口都配一句具体的建议行动与对应支持服务。</a:t>
+              <a:t>行动清单按「高/中」风险等级排序待办事项,每条缺口均对应具体的建议行动与支持服务。</a:t>
             </a:r>
             <a:endParaRPr lang="en-US" sz="1350" dirty="0"/>
           </a:p>
@@ -11413,7 +11413,7 @@
                 <a:ea typeface="Arial" pitchFamily="34" charset="-122"/>
                 <a:cs typeface="Arial" pitchFamily="34" charset="-120"/>
               </a:rPr>
-              <a:t>自评结果不是终点,而是服务需求的入口——评估越细,识别出的服务线索越多</a:t>
+              <a:t>评估结果直接转化为服务需求线索,评估颗粒度越细,识别的服务机会越多</a:t>
             </a:r>
             <a:endParaRPr lang="en-US" sz="1150" dirty="0"/>
           </a:p>
@@ -11475,7 +11475,7 @@
                 <a:ea typeface="Arial" pitchFamily="34" charset="-122"/>
                 <a:cs typeface="Arial" pitchFamily="34" charset="-120"/>
               </a:rPr>
-              <a:t>高风险项置顶,天然引导用户优先咨询、优先下单</a:t>
+              <a:t>高风险项优先展示,引导用户优先处理并对接相应服务</a:t>
             </a:r>
             <a:endParaRPr lang="en-US" sz="1150" dirty="0"/>
           </a:p>

</xml_diff>

<commit_message>
Merge 4 tool-highlight slides into one 2x2 cross-divided layout
Replace pages 6-9 (one screenshot each) with a single page containing
a 2x2 grid split by a cross divider, each quadrant pairing a thumbnail
screenshot with a condensed heading and one-line description. Deck
shrinks from 10 to 7 pages; October plan renumbered to page 7.

Co-Authored-By: Claude Sonnet 5 <noreply@anthropic.com>
Claude-Session: https://claude.ai/code/session_015nf3knxVoVVLYAWgtjzRg9
</commit_message>
<xml_diff>
--- a/2026年8-9月工作汇报.pptx
+++ b/2026年8-9月工作汇报.pptx
@@ -12,12 +12,9 @@
     <p:sldId id="260" r:id="rId6"/>
     <p:sldId id="261" r:id="rId7"/>
     <p:sldId id="262" r:id="rId8"/>
-    <p:sldId id="263" r:id="rId9"/>
-    <p:sldId id="264" r:id="rId10"/>
-    <p:sldId id="265" r:id="rId11"/>
   </p:sldIdLst>
   <p:notesMasterIdLst>
-    <p:notesMasterId r:id="rId12"/>
+    <p:notesMasterId r:id="rId9"/>
   </p:notesMasterIdLst>
   <p:sldSz cx="9905695" cy="6858000"/>
   <p:notesSz cx="6858000" cy="9905695"/>
@@ -553,94 +550,6 @@
 </p:notes>
 </file>
 
-<file path=ppt/notesSlides/notesSlide10.xml><?xml version="1.0" encoding="utf-8"?>
-<p:notes xmlns:a="http://schemas.openxmlformats.org/drawingml/2006/main" xmlns:r="http://schemas.openxmlformats.org/officeDocument/2006/relationships" xmlns:p="http://schemas.openxmlformats.org/presentationml/2006/main">
-  <p:cSld>
-    <p:spTree>
-      <p:nvGrpSpPr>
-        <p:cNvPr id="1" name=""/>
-        <p:cNvGrpSpPr/>
-        <p:nvPr/>
-      </p:nvGrpSpPr>
-      <p:grpSpPr>
-        <a:xfrm>
-          <a:off x="0" y="0"/>
-          <a:ext cx="0" cy="0"/>
-          <a:chOff x="0" y="0"/>
-          <a:chExt cx="0" cy="0"/>
-        </a:xfrm>
-      </p:grpSpPr>
-      <p:sp>
-        <p:nvSpPr>
-          <p:cNvPr id="2" name="Slide Image Placeholder 1"/>
-          <p:cNvSpPr>
-            <a:spLocks noGrp="1" noRot="1" noChangeAspect="1"/>
-          </p:cNvSpPr>
-          <p:nvPr>
-            <p:ph type="sldImg"/>
-          </p:nvPr>
-        </p:nvSpPr>
-        <p:spPr/>
-      </p:sp>
-      <p:sp>
-        <p:nvSpPr>
-          <p:cNvPr id="3" name="Notes Placeholder 2"/>
-          <p:cNvSpPr>
-            <a:spLocks noGrp="1"/>
-          </p:cNvSpPr>
-          <p:nvPr>
-            <p:ph type="body" idx="1"/>
-          </p:nvPr>
-        </p:nvSpPr>
-        <p:spPr/>
-        <p:txBody>
-          <a:bodyPr/>
-          <a:lstStyle/>
-          <a:p>
-            <a:r>
-              <a:rPr lang="en-US" dirty="0"/>
-              <a:t/>
-            </a:r>
-            <a:endParaRPr lang="en-US" dirty="0"/>
-          </a:p>
-        </p:txBody>
-      </p:sp>
-      <p:sp>
-        <p:nvSpPr>
-          <p:cNvPr id="4" name="Slide Number Placeholder 3"/>
-          <p:cNvSpPr>
-            <a:spLocks noGrp="1"/>
-          </p:cNvSpPr>
-          <p:nvPr>
-            <p:ph type="sldNum" sz="quarter" idx="10"/>
-          </p:nvPr>
-        </p:nvSpPr>
-        <p:spPr/>
-        <p:txBody>
-          <a:bodyPr/>
-          <a:lstStyle/>
-          <a:p>
-            <a:fld id="{F7021451-1387-4CA6-816F-3879F97B5CBC}" type="slidenum">
-              <a:rPr lang="en-US"/>
-              <a:t>10</a:t>
-            </a:fld>
-            <a:endParaRPr lang="en-US"/>
-          </a:p>
-        </p:txBody>
-      </p:sp>
-    </p:spTree>
-    <p:extLst>
-      <p:ext uri="{BB962C8B-B14F-4D97-AF65-F5344CB8AC3E}">
-        <p14:creationId xmlns:p14="http://schemas.microsoft.com/office/powerpoint/2010/main" val="1024086991"/>
-      </p:ext>
-    </p:extLst>
-  </p:cSld>
-  <p:clrMapOvr>
-    <a:masterClrMapping/>
-  </p:clrMapOvr>
-</p:notes>
-</file>
-
 <file path=ppt/notesSlides/notesSlide2.xml><?xml version="1.0" encoding="utf-8"?>
 <p:notes xmlns:a="http://schemas.openxmlformats.org/drawingml/2006/main" xmlns:r="http://schemas.openxmlformats.org/officeDocument/2006/relationships" xmlns:p="http://schemas.openxmlformats.org/presentationml/2006/main">
   <p:cSld>
@@ -1151,182 +1060,6 @@
             <a:fld id="{F7021451-1387-4CA6-816F-3879F97B5CBC}" type="slidenum">
               <a:rPr lang="en-US"/>
               <a:t>7</a:t>
-            </a:fld>
-            <a:endParaRPr lang="en-US"/>
-          </a:p>
-        </p:txBody>
-      </p:sp>
-    </p:spTree>
-    <p:extLst>
-      <p:ext uri="{BB962C8B-B14F-4D97-AF65-F5344CB8AC3E}">
-        <p14:creationId xmlns:p14="http://schemas.microsoft.com/office/powerpoint/2010/main" val="1024086991"/>
-      </p:ext>
-    </p:extLst>
-  </p:cSld>
-  <p:clrMapOvr>
-    <a:masterClrMapping/>
-  </p:clrMapOvr>
-</p:notes>
-</file>
-
-<file path=ppt/notesSlides/notesSlide8.xml><?xml version="1.0" encoding="utf-8"?>
-<p:notes xmlns:a="http://schemas.openxmlformats.org/drawingml/2006/main" xmlns:r="http://schemas.openxmlformats.org/officeDocument/2006/relationships" xmlns:p="http://schemas.openxmlformats.org/presentationml/2006/main">
-  <p:cSld>
-    <p:spTree>
-      <p:nvGrpSpPr>
-        <p:cNvPr id="1" name=""/>
-        <p:cNvGrpSpPr/>
-        <p:nvPr/>
-      </p:nvGrpSpPr>
-      <p:grpSpPr>
-        <a:xfrm>
-          <a:off x="0" y="0"/>
-          <a:ext cx="0" cy="0"/>
-          <a:chOff x="0" y="0"/>
-          <a:chExt cx="0" cy="0"/>
-        </a:xfrm>
-      </p:grpSpPr>
-      <p:sp>
-        <p:nvSpPr>
-          <p:cNvPr id="2" name="Slide Image Placeholder 1"/>
-          <p:cNvSpPr>
-            <a:spLocks noGrp="1" noRot="1" noChangeAspect="1"/>
-          </p:cNvSpPr>
-          <p:nvPr>
-            <p:ph type="sldImg"/>
-          </p:nvPr>
-        </p:nvSpPr>
-        <p:spPr/>
-      </p:sp>
-      <p:sp>
-        <p:nvSpPr>
-          <p:cNvPr id="3" name="Notes Placeholder 2"/>
-          <p:cNvSpPr>
-            <a:spLocks noGrp="1"/>
-          </p:cNvSpPr>
-          <p:nvPr>
-            <p:ph type="body" idx="1"/>
-          </p:nvPr>
-        </p:nvSpPr>
-        <p:spPr/>
-        <p:txBody>
-          <a:bodyPr/>
-          <a:lstStyle/>
-          <a:p>
-            <a:r>
-              <a:rPr lang="en-US" dirty="0"/>
-              <a:t/>
-            </a:r>
-            <a:endParaRPr lang="en-US" dirty="0"/>
-          </a:p>
-        </p:txBody>
-      </p:sp>
-      <p:sp>
-        <p:nvSpPr>
-          <p:cNvPr id="4" name="Slide Number Placeholder 3"/>
-          <p:cNvSpPr>
-            <a:spLocks noGrp="1"/>
-          </p:cNvSpPr>
-          <p:nvPr>
-            <p:ph type="sldNum" sz="quarter" idx="10"/>
-          </p:nvPr>
-        </p:nvSpPr>
-        <p:spPr/>
-        <p:txBody>
-          <a:bodyPr/>
-          <a:lstStyle/>
-          <a:p>
-            <a:fld id="{F7021451-1387-4CA6-816F-3879F97B5CBC}" type="slidenum">
-              <a:rPr lang="en-US"/>
-              <a:t>8</a:t>
-            </a:fld>
-            <a:endParaRPr lang="en-US"/>
-          </a:p>
-        </p:txBody>
-      </p:sp>
-    </p:spTree>
-    <p:extLst>
-      <p:ext uri="{BB962C8B-B14F-4D97-AF65-F5344CB8AC3E}">
-        <p14:creationId xmlns:p14="http://schemas.microsoft.com/office/powerpoint/2010/main" val="1024086991"/>
-      </p:ext>
-    </p:extLst>
-  </p:cSld>
-  <p:clrMapOvr>
-    <a:masterClrMapping/>
-  </p:clrMapOvr>
-</p:notes>
-</file>
-
-<file path=ppt/notesSlides/notesSlide9.xml><?xml version="1.0" encoding="utf-8"?>
-<p:notes xmlns:a="http://schemas.openxmlformats.org/drawingml/2006/main" xmlns:r="http://schemas.openxmlformats.org/officeDocument/2006/relationships" xmlns:p="http://schemas.openxmlformats.org/presentationml/2006/main">
-  <p:cSld>
-    <p:spTree>
-      <p:nvGrpSpPr>
-        <p:cNvPr id="1" name=""/>
-        <p:cNvGrpSpPr/>
-        <p:nvPr/>
-      </p:nvGrpSpPr>
-      <p:grpSpPr>
-        <a:xfrm>
-          <a:off x="0" y="0"/>
-          <a:ext cx="0" cy="0"/>
-          <a:chOff x="0" y="0"/>
-          <a:chExt cx="0" cy="0"/>
-        </a:xfrm>
-      </p:grpSpPr>
-      <p:sp>
-        <p:nvSpPr>
-          <p:cNvPr id="2" name="Slide Image Placeholder 1"/>
-          <p:cNvSpPr>
-            <a:spLocks noGrp="1" noRot="1" noChangeAspect="1"/>
-          </p:cNvSpPr>
-          <p:nvPr>
-            <p:ph type="sldImg"/>
-          </p:nvPr>
-        </p:nvSpPr>
-        <p:spPr/>
-      </p:sp>
-      <p:sp>
-        <p:nvSpPr>
-          <p:cNvPr id="3" name="Notes Placeholder 2"/>
-          <p:cNvSpPr>
-            <a:spLocks noGrp="1"/>
-          </p:cNvSpPr>
-          <p:nvPr>
-            <p:ph type="body" idx="1"/>
-          </p:nvPr>
-        </p:nvSpPr>
-        <p:spPr/>
-        <p:txBody>
-          <a:bodyPr/>
-          <a:lstStyle/>
-          <a:p>
-            <a:r>
-              <a:rPr lang="en-US" dirty="0"/>
-              <a:t/>
-            </a:r>
-            <a:endParaRPr lang="en-US" dirty="0"/>
-          </a:p>
-        </p:txBody>
-      </p:sp>
-      <p:sp>
-        <p:nvSpPr>
-          <p:cNvPr id="4" name="Slide Number Placeholder 3"/>
-          <p:cNvSpPr>
-            <a:spLocks noGrp="1"/>
-          </p:cNvSpPr>
-          <p:nvPr>
-            <p:ph type="sldNum" sz="quarter" idx="10"/>
-          </p:nvPr>
-        </p:nvSpPr>
-        <p:spPr/>
-        <p:txBody>
-          <a:bodyPr/>
-          <a:lstStyle/>
-          <a:p>
-            <a:fld id="{F7021451-1387-4CA6-816F-3879F97B5CBC}" type="slidenum">
-              <a:rPr lang="en-US"/>
-              <a:t>9</a:t>
             </a:fld>
             <a:endParaRPr lang="en-US"/>
           </a:p>
@@ -2578,866 +2311,7 @@
                 <a:ea typeface="Arial" pitchFamily="34" charset="-122"/>
                 <a:cs typeface="Arial" pitchFamily="34" charset="-120"/>
               </a:rPr>
-              <a:t>1/10</a:t>
-            </a:r>
-            <a:endParaRPr lang="en-US" sz="900" dirty="0"/>
-          </a:p>
-        </p:txBody>
-      </p:sp>
-    </p:spTree>
-  </p:cSld>
-  <p:clrMapOvr>
-    <a:masterClrMapping/>
-  </p:clrMapOvr>
-</p:sld>
-</file>
-
-<file path=ppt/slides/slide10.xml><?xml version="1.0" encoding="utf-8"?>
-<p:sld xmlns:a="http://schemas.openxmlformats.org/drawingml/2006/main" xmlns:r="http://schemas.openxmlformats.org/officeDocument/2006/relationships" xmlns:p="http://schemas.openxmlformats.org/presentationml/2006/main">
-  <p:cSld name="Slide 10">
-    <p:bg>
-      <p:bgPr>
-        <a:blipFill dpi="0" rotWithShape="1">
-          <a:blip r:embed="rId1">
-            <a:lum/>
-          </a:blip>
-          <a:srcRect/>
-          <a:stretch>
-            <a:fillRect/>
-          </a:stretch>
-        </a:blipFill>
-        <a:effectLst/>
-      </p:bgPr>
-    </p:bg>
-    <p:spTree>
-      <p:nvGrpSpPr>
-        <p:cNvPr id="1" name=""/>
-        <p:cNvGrpSpPr/>
-        <p:nvPr/>
-      </p:nvGrpSpPr>
-      <p:grpSpPr>
-        <a:xfrm>
-          <a:off x="0" y="0"/>
-          <a:ext cx="0" cy="0"/>
-          <a:chOff x="0" y="0"/>
-          <a:chExt cx="0" cy="0"/>
-        </a:xfrm>
-      </p:grpSpPr>
-      <p:sp>
-        <p:nvSpPr>
-          <p:cNvPr id="2" name="Text 0"/>
-          <p:cNvSpPr txBox="1"/>
-          <p:nvPr/>
-        </p:nvSpPr>
-        <p:spPr>
-          <a:xfrm>
-            <a:off x="548640" y="1691640"/>
-            <a:ext cx="8808415" cy="256032"/>
-          </a:xfrm>
-          <a:prstGeom prst="rect">
-            <a:avLst/>
-          </a:prstGeom>
-          <a:noFill/>
-          <a:ln/>
-        </p:spPr>
-        <p:txBody>
-          <a:bodyPr wrap="square" lIns="0" tIns="0" rIns="0" bIns="0" rtlCol="0" anchor="ctr"/>
-          <a:lstStyle/>
-          <a:p>
-            <a:pPr indent="0" marL="0">
-              <a:buNone/>
-            </a:pPr>
-            <a:r>
-              <a:rPr lang="en-US" sz="1050" spc="100" kern="0" dirty="0">
-                <a:solidFill>
-                  <a:srgbClr val="848685"/>
-                </a:solidFill>
-                <a:latin typeface="Arial" pitchFamily="34" charset="0"/>
-                <a:ea typeface="Arial" pitchFamily="34" charset="-122"/>
-                <a:cs typeface="Arial" pitchFamily="34" charset="-120"/>
-              </a:rPr>
-              <a:t>第四部分 · 10月工作计划</a:t>
-            </a:r>
-            <a:endParaRPr lang="en-US" sz="1050" dirty="0"/>
-          </a:p>
-        </p:txBody>
-      </p:sp>
-      <p:sp>
-        <p:nvSpPr>
-          <p:cNvPr id="3" name="Text 1"/>
-          <p:cNvSpPr txBox="1"/>
-          <p:nvPr/>
-        </p:nvSpPr>
-        <p:spPr>
-          <a:xfrm>
-            <a:off x="548640" y="1947672"/>
-            <a:ext cx="8808415" cy="347472"/>
-          </a:xfrm>
-          <a:prstGeom prst="rect">
-            <a:avLst/>
-          </a:prstGeom>
-          <a:noFill/>
-          <a:ln/>
-        </p:spPr>
-        <p:txBody>
-          <a:bodyPr wrap="square" lIns="0" tIns="0" rIns="0" bIns="0" rtlCol="0" anchor="ctr"/>
-          <a:lstStyle/>
-          <a:p>
-            <a:pPr indent="0" marL="0">
-              <a:buNone/>
-            </a:pPr>
-            <a:r>
-              <a:rPr lang="en-US" sz="1900" b="1" dirty="0">
-                <a:solidFill>
-                  <a:srgbClr val="363636"/>
-                </a:solidFill>
-                <a:latin typeface="Georgia" pitchFamily="34" charset="0"/>
-                <a:ea typeface="Georgia" pitchFamily="34" charset="-122"/>
-                <a:cs typeface="Georgia" pitchFamily="34" charset="-120"/>
-              </a:rPr>
-              <a:t>10月工作计划</a:t>
-            </a:r>
-            <a:endParaRPr lang="en-US" sz="1900" dirty="0"/>
-          </a:p>
-        </p:txBody>
-      </p:sp>
-      <p:sp>
-        <p:nvSpPr>
-          <p:cNvPr id="4" name="Shape 2"/>
-          <p:cNvSpPr/>
-          <p:nvPr/>
-        </p:nvSpPr>
-        <p:spPr>
-          <a:xfrm>
-            <a:off x="548640" y="2286000"/>
-            <a:ext cx="1097280" cy="0"/>
-          </a:xfrm>
-          <a:prstGeom prst="line">
-            <a:avLst/>
-          </a:prstGeom>
-          <a:noFill/>
-          <a:ln w="31750">
-            <a:solidFill>
-              <a:srgbClr val="FF6600"/>
-            </a:solidFill>
-            <a:prstDash val="solid"/>
-          </a:ln>
-        </p:spPr>
-      </p:sp>
-      <p:sp>
-        <p:nvSpPr>
-          <p:cNvPr id="5" name="Shape 3"/>
-          <p:cNvSpPr/>
-          <p:nvPr/>
-        </p:nvSpPr>
-        <p:spPr>
-          <a:xfrm>
-            <a:off x="548640" y="2331720"/>
-            <a:ext cx="8808415" cy="512064"/>
-          </a:xfrm>
-          <a:prstGeom prst="roundRect">
-            <a:avLst>
-              <a:gd name="adj" fmla="val 8036"/>
-            </a:avLst>
-          </a:prstGeom>
-          <a:solidFill>
-            <a:srgbClr val="FFFFFF"/>
-          </a:solidFill>
-          <a:ln w="9525">
-            <a:solidFill>
-              <a:srgbClr val="E8E8E8"/>
-            </a:solidFill>
-            <a:prstDash val="solid"/>
-          </a:ln>
-        </p:spPr>
-      </p:sp>
-      <p:sp>
-        <p:nvSpPr>
-          <p:cNvPr id="6" name="Shape 4"/>
-          <p:cNvSpPr/>
-          <p:nvPr/>
-        </p:nvSpPr>
-        <p:spPr>
-          <a:xfrm>
-            <a:off x="566928" y="2368296"/>
-            <a:ext cx="32004" cy="438912"/>
-          </a:xfrm>
-          <a:prstGeom prst="rect">
-            <a:avLst/>
-          </a:prstGeom>
-          <a:solidFill>
-            <a:srgbClr val="FF6600"/>
-          </a:solidFill>
-          <a:ln/>
-        </p:spPr>
-      </p:sp>
-      <p:pic>
-        <p:nvPicPr>
-          <p:cNvPr id="7" name="Image 0" descr="/tmp/pptx_work/icons/check.png">    </p:cNvPr>
-          <p:cNvPicPr>
-            <a:picLocks noChangeAspect="1"/>
-          </p:cNvPicPr>
-          <p:nvPr/>
-        </p:nvPicPr>
-        <p:blipFill>
-          <a:blip r:embed="rId2"/>
-          <a:stretch>
-            <a:fillRect/>
-          </a:stretch>
-        </p:blipFill>
-        <p:spPr>
-          <a:xfrm>
-            <a:off x="676656" y="2423160"/>
-            <a:ext cx="329184" cy="329184"/>
-          </a:xfrm>
-          <a:prstGeom prst="rect">
-            <a:avLst/>
-          </a:prstGeom>
-        </p:spPr>
-      </p:pic>
-      <p:sp>
-        <p:nvSpPr>
-          <p:cNvPr id="8" name="Text 5"/>
-          <p:cNvSpPr txBox="1"/>
-          <p:nvPr/>
-        </p:nvSpPr>
-        <p:spPr>
-          <a:xfrm>
-            <a:off x="1188720" y="2331720"/>
-            <a:ext cx="7985455" cy="512064"/>
-          </a:xfrm>
-          <a:prstGeom prst="rect">
-            <a:avLst/>
-          </a:prstGeom>
-          <a:noFill/>
-          <a:ln/>
-        </p:spPr>
-        <p:txBody>
-          <a:bodyPr wrap="square" lIns="0" tIns="0" rIns="0" bIns="0" rtlCol="0" anchor="ctr"/>
-          <a:lstStyle/>
-          <a:p>
-            <a:pPr indent="0" marL="0">
-              <a:buNone/>
-            </a:pPr>
-            <a:r>
-              <a:rPr lang="en-US" sz="1150" dirty="0">
-                <a:solidFill>
-                  <a:srgbClr val="363636"/>
-                </a:solidFill>
-                <a:latin typeface="Arial" pitchFamily="34" charset="0"/>
-                <a:ea typeface="Arial" pitchFamily="34" charset="-122"/>
-                <a:cs typeface="Arial" pitchFamily="34" charset="-120"/>
-              </a:rPr>
-              <a:t>编制 9 月《法规雷达》月报</a:t>
-            </a:r>
-            <a:endParaRPr lang="en-US" sz="1150" dirty="0"/>
-          </a:p>
-        </p:txBody>
-      </p:sp>
-      <p:sp>
-        <p:nvSpPr>
-          <p:cNvPr id="9" name="Shape 6"/>
-          <p:cNvSpPr/>
-          <p:nvPr/>
-        </p:nvSpPr>
-        <p:spPr>
-          <a:xfrm>
-            <a:off x="548640" y="2953512"/>
-            <a:ext cx="8808415" cy="512064"/>
-          </a:xfrm>
-          <a:prstGeom prst="roundRect">
-            <a:avLst>
-              <a:gd name="adj" fmla="val 8036"/>
-            </a:avLst>
-          </a:prstGeom>
-          <a:solidFill>
-            <a:srgbClr val="FFFFFF"/>
-          </a:solidFill>
-          <a:ln w="9525">
-            <a:solidFill>
-              <a:srgbClr val="E8E8E8"/>
-            </a:solidFill>
-            <a:prstDash val="solid"/>
-          </a:ln>
-        </p:spPr>
-      </p:sp>
-      <p:sp>
-        <p:nvSpPr>
-          <p:cNvPr id="10" name="Shape 7"/>
-          <p:cNvSpPr/>
-          <p:nvPr/>
-        </p:nvSpPr>
-        <p:spPr>
-          <a:xfrm>
-            <a:off x="566928" y="2990088"/>
-            <a:ext cx="32004" cy="438912"/>
-          </a:xfrm>
-          <a:prstGeom prst="rect">
-            <a:avLst/>
-          </a:prstGeom>
-          <a:solidFill>
-            <a:srgbClr val="FF6600"/>
-          </a:solidFill>
-          <a:ln/>
-        </p:spPr>
-      </p:sp>
-      <p:pic>
-        <p:nvPicPr>
-          <p:cNvPr id="11" name="Image 1" descr="/tmp/pptx_work/icons/check.png">    </p:cNvPr>
-          <p:cNvPicPr>
-            <a:picLocks noChangeAspect="1"/>
-          </p:cNvPicPr>
-          <p:nvPr/>
-        </p:nvPicPr>
-        <p:blipFill>
-          <a:blip r:embed="rId3"/>
-          <a:stretch>
-            <a:fillRect/>
-          </a:stretch>
-        </p:blipFill>
-        <p:spPr>
-          <a:xfrm>
-            <a:off x="676656" y="3044952"/>
-            <a:ext cx="329184" cy="329184"/>
-          </a:xfrm>
-          <a:prstGeom prst="rect">
-            <a:avLst/>
-          </a:prstGeom>
-        </p:spPr>
-      </p:pic>
-      <p:sp>
-        <p:nvSpPr>
-          <p:cNvPr id="12" name="Text 8"/>
-          <p:cNvSpPr txBox="1"/>
-          <p:nvPr/>
-        </p:nvSpPr>
-        <p:spPr>
-          <a:xfrm>
-            <a:off x="1188720" y="2953512"/>
-            <a:ext cx="7985455" cy="512064"/>
-          </a:xfrm>
-          <a:prstGeom prst="rect">
-            <a:avLst/>
-          </a:prstGeom>
-          <a:noFill/>
-          <a:ln/>
-        </p:spPr>
-        <p:txBody>
-          <a:bodyPr wrap="square" lIns="0" tIns="0" rIns="0" bIns="0" rtlCol="0" anchor="ctr"/>
-          <a:lstStyle/>
-          <a:p>
-            <a:pPr indent="0" marL="0">
-              <a:buNone/>
-            </a:pPr>
-            <a:r>
-              <a:rPr lang="en-US" sz="1150" dirty="0">
-                <a:solidFill>
-                  <a:srgbClr val="363636"/>
-                </a:solidFill>
-                <a:latin typeface="Arial" pitchFamily="34" charset="0"/>
-                <a:ea typeface="Arial" pitchFamily="34" charset="-122"/>
-                <a:cs typeface="Arial" pitchFamily="34" charset="-120"/>
-              </a:rPr>
-              <a:t>每日法规监测常态化维护</a:t>
-            </a:r>
-            <a:endParaRPr lang="en-US" sz="1150" dirty="0"/>
-          </a:p>
-        </p:txBody>
-      </p:sp>
-      <p:sp>
-        <p:nvSpPr>
-          <p:cNvPr id="13" name="Shape 9"/>
-          <p:cNvSpPr/>
-          <p:nvPr/>
-        </p:nvSpPr>
-        <p:spPr>
-          <a:xfrm>
-            <a:off x="548640" y="3575304"/>
-            <a:ext cx="8808415" cy="512064"/>
-          </a:xfrm>
-          <a:prstGeom prst="roundRect">
-            <a:avLst>
-              <a:gd name="adj" fmla="val 8036"/>
-            </a:avLst>
-          </a:prstGeom>
-          <a:solidFill>
-            <a:srgbClr val="FFFFFF"/>
-          </a:solidFill>
-          <a:ln w="9525">
-            <a:solidFill>
-              <a:srgbClr val="E8E8E8"/>
-            </a:solidFill>
-            <a:prstDash val="solid"/>
-          </a:ln>
-        </p:spPr>
-      </p:sp>
-      <p:sp>
-        <p:nvSpPr>
-          <p:cNvPr id="14" name="Shape 10"/>
-          <p:cNvSpPr/>
-          <p:nvPr/>
-        </p:nvSpPr>
-        <p:spPr>
-          <a:xfrm>
-            <a:off x="566928" y="3611880"/>
-            <a:ext cx="32004" cy="438912"/>
-          </a:xfrm>
-          <a:prstGeom prst="rect">
-            <a:avLst/>
-          </a:prstGeom>
-          <a:solidFill>
-            <a:srgbClr val="FF6600"/>
-          </a:solidFill>
-          <a:ln/>
-        </p:spPr>
-      </p:sp>
-      <p:pic>
-        <p:nvPicPr>
-          <p:cNvPr id="15" name="Image 2" descr="/tmp/pptx_work/icons/check.png">    </p:cNvPr>
-          <p:cNvPicPr>
-            <a:picLocks noChangeAspect="1"/>
-          </p:cNvPicPr>
-          <p:nvPr/>
-        </p:nvPicPr>
-        <p:blipFill>
-          <a:blip r:embed="rId4"/>
-          <a:stretch>
-            <a:fillRect/>
-          </a:stretch>
-        </p:blipFill>
-        <p:spPr>
-          <a:xfrm>
-            <a:off x="676656" y="3666744"/>
-            <a:ext cx="329184" cy="329184"/>
-          </a:xfrm>
-          <a:prstGeom prst="rect">
-            <a:avLst/>
-          </a:prstGeom>
-        </p:spPr>
-      </p:pic>
-      <p:sp>
-        <p:nvSpPr>
-          <p:cNvPr id="16" name="Text 11"/>
-          <p:cNvSpPr txBox="1"/>
-          <p:nvPr/>
-        </p:nvSpPr>
-        <p:spPr>
-          <a:xfrm>
-            <a:off x="1188720" y="3575304"/>
-            <a:ext cx="7985455" cy="512064"/>
-          </a:xfrm>
-          <a:prstGeom prst="rect">
-            <a:avLst/>
-          </a:prstGeom>
-          <a:noFill/>
-          <a:ln/>
-        </p:spPr>
-        <p:txBody>
-          <a:bodyPr wrap="square" lIns="0" tIns="0" rIns="0" bIns="0" rtlCol="0" anchor="ctr"/>
-          <a:lstStyle/>
-          <a:p>
-            <a:pPr indent="0" marL="0">
-              <a:buNone/>
-            </a:pPr>
-            <a:r>
-              <a:rPr lang="en-US" sz="1150" dirty="0">
-                <a:solidFill>
-                  <a:srgbClr val="363636"/>
-                </a:solidFill>
-                <a:latin typeface="Arial" pitchFamily="34" charset="0"/>
-                <a:ea typeface="Arial" pitchFamily="34" charset="-122"/>
-                <a:cs typeface="Arial" pitchFamily="34" charset="-120"/>
-              </a:rPr>
-              <a:t>E-mark 认证合规工具持续迭代维护</a:t>
-            </a:r>
-            <a:endParaRPr lang="en-US" sz="1150" dirty="0"/>
-          </a:p>
-        </p:txBody>
-      </p:sp>
-      <p:sp>
-        <p:nvSpPr>
-          <p:cNvPr id="17" name="Shape 12"/>
-          <p:cNvSpPr/>
-          <p:nvPr/>
-        </p:nvSpPr>
-        <p:spPr>
-          <a:xfrm>
-            <a:off x="548640" y="4197096"/>
-            <a:ext cx="8808415" cy="512064"/>
-          </a:xfrm>
-          <a:prstGeom prst="roundRect">
-            <a:avLst>
-              <a:gd name="adj" fmla="val 8036"/>
-            </a:avLst>
-          </a:prstGeom>
-          <a:solidFill>
-            <a:srgbClr val="FFFFFF"/>
-          </a:solidFill>
-          <a:ln w="9525">
-            <a:solidFill>
-              <a:srgbClr val="E8E8E8"/>
-            </a:solidFill>
-            <a:prstDash val="solid"/>
-          </a:ln>
-        </p:spPr>
-      </p:sp>
-      <p:sp>
-        <p:nvSpPr>
-          <p:cNvPr id="18" name="Shape 13"/>
-          <p:cNvSpPr/>
-          <p:nvPr/>
-        </p:nvSpPr>
-        <p:spPr>
-          <a:xfrm>
-            <a:off x="566928" y="4233672"/>
-            <a:ext cx="32004" cy="438912"/>
-          </a:xfrm>
-          <a:prstGeom prst="rect">
-            <a:avLst/>
-          </a:prstGeom>
-          <a:solidFill>
-            <a:srgbClr val="FF6600"/>
-          </a:solidFill>
-          <a:ln/>
-        </p:spPr>
-      </p:sp>
-      <p:pic>
-        <p:nvPicPr>
-          <p:cNvPr id="19" name="Image 3" descr="/tmp/pptx_work/icons/check.png">    </p:cNvPr>
-          <p:cNvPicPr>
-            <a:picLocks noChangeAspect="1"/>
-          </p:cNvPicPr>
-          <p:nvPr/>
-        </p:nvPicPr>
-        <p:blipFill>
-          <a:blip r:embed="rId5"/>
-          <a:stretch>
-            <a:fillRect/>
-          </a:stretch>
-        </p:blipFill>
-        <p:spPr>
-          <a:xfrm>
-            <a:off x="676656" y="4288536"/>
-            <a:ext cx="329184" cy="329184"/>
-          </a:xfrm>
-          <a:prstGeom prst="rect">
-            <a:avLst/>
-          </a:prstGeom>
-        </p:spPr>
-      </p:pic>
-      <p:sp>
-        <p:nvSpPr>
-          <p:cNvPr id="20" name="Text 14"/>
-          <p:cNvSpPr txBox="1"/>
-          <p:nvPr/>
-        </p:nvSpPr>
-        <p:spPr>
-          <a:xfrm>
-            <a:off x="1188720" y="4197096"/>
-            <a:ext cx="7985455" cy="512064"/>
-          </a:xfrm>
-          <a:prstGeom prst="rect">
-            <a:avLst/>
-          </a:prstGeom>
-          <a:noFill/>
-          <a:ln/>
-        </p:spPr>
-        <p:txBody>
-          <a:bodyPr wrap="square" lIns="0" tIns="0" rIns="0" bIns="0" rtlCol="0" anchor="ctr"/>
-          <a:lstStyle/>
-          <a:p>
-            <a:pPr indent="0" marL="0">
-              <a:buNone/>
-            </a:pPr>
-            <a:r>
-              <a:rPr lang="en-US" sz="1150" dirty="0">
-                <a:solidFill>
-                  <a:srgbClr val="363636"/>
-                </a:solidFill>
-                <a:latin typeface="Arial" pitchFamily="34" charset="0"/>
-                <a:ea typeface="Arial" pitchFamily="34" charset="-122"/>
-                <a:cs typeface="Arial" pitchFamily="34" charset="-120"/>
-              </a:rPr>
-              <a:t>法规检索客户需求响应与数据交付</a:t>
-            </a:r>
-            <a:endParaRPr lang="en-US" sz="1150" dirty="0"/>
-          </a:p>
-        </p:txBody>
-      </p:sp>
-      <p:sp>
-        <p:nvSpPr>
-          <p:cNvPr id="21" name="Shape 15"/>
-          <p:cNvSpPr/>
-          <p:nvPr/>
-        </p:nvSpPr>
-        <p:spPr>
-          <a:xfrm>
-            <a:off x="548640" y="4818888"/>
-            <a:ext cx="8808415" cy="512064"/>
-          </a:xfrm>
-          <a:prstGeom prst="roundRect">
-            <a:avLst>
-              <a:gd name="adj" fmla="val 8036"/>
-            </a:avLst>
-          </a:prstGeom>
-          <a:solidFill>
-            <a:srgbClr val="FFFFFF"/>
-          </a:solidFill>
-          <a:ln w="9525">
-            <a:solidFill>
-              <a:srgbClr val="E8E8E8"/>
-            </a:solidFill>
-            <a:prstDash val="solid"/>
-          </a:ln>
-        </p:spPr>
-      </p:sp>
-      <p:sp>
-        <p:nvSpPr>
-          <p:cNvPr id="22" name="Shape 16"/>
-          <p:cNvSpPr/>
-          <p:nvPr/>
-        </p:nvSpPr>
-        <p:spPr>
-          <a:xfrm>
-            <a:off x="566928" y="4855464"/>
-            <a:ext cx="32004" cy="438912"/>
-          </a:xfrm>
-          <a:prstGeom prst="rect">
-            <a:avLst/>
-          </a:prstGeom>
-          <a:solidFill>
-            <a:srgbClr val="FF6600"/>
-          </a:solidFill>
-          <a:ln/>
-        </p:spPr>
-      </p:sp>
-      <p:pic>
-        <p:nvPicPr>
-          <p:cNvPr id="23" name="Image 4" descr="/tmp/pptx_work/icons/check.png">    </p:cNvPr>
-          <p:cNvPicPr>
-            <a:picLocks noChangeAspect="1"/>
-          </p:cNvPicPr>
-          <p:nvPr/>
-        </p:nvPicPr>
-        <p:blipFill>
-          <a:blip r:embed="rId6"/>
-          <a:stretch>
-            <a:fillRect/>
-          </a:stretch>
-        </p:blipFill>
-        <p:spPr>
-          <a:xfrm>
-            <a:off x="676656" y="4910328"/>
-            <a:ext cx="329184" cy="329184"/>
-          </a:xfrm>
-          <a:prstGeom prst="rect">
-            <a:avLst/>
-          </a:prstGeom>
-        </p:spPr>
-      </p:pic>
-      <p:sp>
-        <p:nvSpPr>
-          <p:cNvPr id="24" name="Text 17"/>
-          <p:cNvSpPr txBox="1"/>
-          <p:nvPr/>
-        </p:nvSpPr>
-        <p:spPr>
-          <a:xfrm>
-            <a:off x="1188720" y="4818888"/>
-            <a:ext cx="7985455" cy="512064"/>
-          </a:xfrm>
-          <a:prstGeom prst="rect">
-            <a:avLst/>
-          </a:prstGeom>
-          <a:noFill/>
-          <a:ln/>
-        </p:spPr>
-        <p:txBody>
-          <a:bodyPr wrap="square" lIns="0" tIns="0" rIns="0" bIns="0" rtlCol="0" anchor="ctr"/>
-          <a:lstStyle/>
-          <a:p>
-            <a:pPr indent="0" marL="0">
-              <a:buNone/>
-            </a:pPr>
-            <a:r>
-              <a:rPr lang="en-US" sz="1150" dirty="0">
-                <a:solidFill>
-                  <a:srgbClr val="363636"/>
-                </a:solidFill>
-                <a:latin typeface="Arial" pitchFamily="34" charset="0"/>
-                <a:ea typeface="Arial" pitchFamily="34" charset="-122"/>
-                <a:cs typeface="Arial" pitchFamily="34" charset="-120"/>
-              </a:rPr>
-              <a:t>内容营销与客户答疑支持</a:t>
-            </a:r>
-            <a:endParaRPr lang="en-US" sz="1150" dirty="0"/>
-          </a:p>
-        </p:txBody>
-      </p:sp>
-      <p:sp>
-        <p:nvSpPr>
-          <p:cNvPr id="25" name="Shape 18"/>
-          <p:cNvSpPr/>
-          <p:nvPr/>
-        </p:nvSpPr>
-        <p:spPr>
-          <a:xfrm>
-            <a:off x="548640" y="5440680"/>
-            <a:ext cx="8808415" cy="512064"/>
-          </a:xfrm>
-          <a:prstGeom prst="roundRect">
-            <a:avLst>
-              <a:gd name="adj" fmla="val 8036"/>
-            </a:avLst>
-          </a:prstGeom>
-          <a:solidFill>
-            <a:srgbClr val="FFFFFF"/>
-          </a:solidFill>
-          <a:ln w="9525">
-            <a:solidFill>
-              <a:srgbClr val="E8E8E8"/>
-            </a:solidFill>
-            <a:prstDash val="solid"/>
-          </a:ln>
-        </p:spPr>
-      </p:sp>
-      <p:sp>
-        <p:nvSpPr>
-          <p:cNvPr id="26" name="Shape 19"/>
-          <p:cNvSpPr/>
-          <p:nvPr/>
-        </p:nvSpPr>
-        <p:spPr>
-          <a:xfrm>
-            <a:off x="566928" y="5477256"/>
-            <a:ext cx="32004" cy="438912"/>
-          </a:xfrm>
-          <a:prstGeom prst="rect">
-            <a:avLst/>
-          </a:prstGeom>
-          <a:solidFill>
-            <a:srgbClr val="FF6600"/>
-          </a:solidFill>
-          <a:ln/>
-        </p:spPr>
-      </p:sp>
-      <p:pic>
-        <p:nvPicPr>
-          <p:cNvPr id="27" name="Image 5" descr="/tmp/pptx_work/icons/check.png">    </p:cNvPr>
-          <p:cNvPicPr>
-            <a:picLocks noChangeAspect="1"/>
-          </p:cNvPicPr>
-          <p:nvPr/>
-        </p:nvPicPr>
-        <p:blipFill>
-          <a:blip r:embed="rId7"/>
-          <a:stretch>
-            <a:fillRect/>
-          </a:stretch>
-        </p:blipFill>
-        <p:spPr>
-          <a:xfrm>
-            <a:off x="676656" y="5532120"/>
-            <a:ext cx="329184" cy="329184"/>
-          </a:xfrm>
-          <a:prstGeom prst="rect">
-            <a:avLst/>
-          </a:prstGeom>
-        </p:spPr>
-      </p:pic>
-      <p:sp>
-        <p:nvSpPr>
-          <p:cNvPr id="28" name="Text 20"/>
-          <p:cNvSpPr txBox="1"/>
-          <p:nvPr/>
-        </p:nvSpPr>
-        <p:spPr>
-          <a:xfrm>
-            <a:off x="1188720" y="5440680"/>
-            <a:ext cx="7985455" cy="512064"/>
-          </a:xfrm>
-          <a:prstGeom prst="rect">
-            <a:avLst/>
-          </a:prstGeom>
-          <a:noFill/>
-          <a:ln/>
-        </p:spPr>
-        <p:txBody>
-          <a:bodyPr wrap="square" lIns="0" tIns="0" rIns="0" bIns="0" rtlCol="0" anchor="ctr"/>
-          <a:lstStyle/>
-          <a:p>
-            <a:pPr indent="0" marL="0">
-              <a:buNone/>
-            </a:pPr>
-            <a:r>
-              <a:rPr lang="en-US" sz="1150" dirty="0">
-                <a:solidFill>
-                  <a:srgbClr val="363636"/>
-                </a:solidFill>
-                <a:latin typeface="Arial" pitchFamily="34" charset="0"/>
-                <a:ea typeface="Arial" pitchFamily="34" charset="-122"/>
-                <a:cs typeface="Arial" pitchFamily="34" charset="-120"/>
-              </a:rPr>
-              <a:t>汽车制造系列推广文章持续审阅与内容支持</a:t>
-            </a:r>
-            <a:endParaRPr lang="en-US" sz="1150" dirty="0"/>
-          </a:p>
-        </p:txBody>
-      </p:sp>
-      <p:sp>
-        <p:nvSpPr>
-          <p:cNvPr id="29" name="Shape 21"/>
-          <p:cNvSpPr/>
-          <p:nvPr/>
-        </p:nvSpPr>
-        <p:spPr>
-          <a:xfrm>
-            <a:off x="0" y="6803136"/>
-            <a:ext cx="9905695" cy="54864"/>
-          </a:xfrm>
-          <a:prstGeom prst="rect">
-            <a:avLst/>
-          </a:prstGeom>
-          <a:solidFill>
-            <a:srgbClr val="FF6600"/>
-          </a:solidFill>
-          <a:ln/>
-        </p:spPr>
-      </p:sp>
-      <p:sp>
-        <p:nvSpPr>
-          <p:cNvPr id="30" name="Text 22"/>
-          <p:cNvSpPr txBox="1"/>
-          <p:nvPr/>
-        </p:nvSpPr>
-        <p:spPr>
-          <a:xfrm>
-            <a:off x="8991295" y="6510528"/>
-            <a:ext cx="731520" cy="256032"/>
-          </a:xfrm>
-          <a:prstGeom prst="rect">
-            <a:avLst/>
-          </a:prstGeom>
-          <a:noFill/>
-          <a:ln/>
-        </p:spPr>
-        <p:txBody>
-          <a:bodyPr wrap="square" lIns="0" tIns="0" rIns="0" bIns="0" rtlCol="0" anchor="ctr"/>
-          <a:lstStyle/>
-          <a:p>
-            <a:pPr algn="r" indent="0" marL="0">
-              <a:buNone/>
-            </a:pPr>
-            <a:r>
-              <a:rPr lang="en-US" sz="900" dirty="0">
-                <a:solidFill>
-                  <a:srgbClr val="848685"/>
-                </a:solidFill>
-                <a:latin typeface="Arial" pitchFamily="34" charset="0"/>
-                <a:ea typeface="Arial" pitchFamily="34" charset="-122"/>
-                <a:cs typeface="Arial" pitchFamily="34" charset="-120"/>
-              </a:rPr>
-              <a:t>10/10</a:t>
+              <a:t>1/7</a:t>
             </a:r>
             <a:endParaRPr lang="en-US" sz="900" dirty="0"/>
           </a:p>
@@ -4858,7 +3732,7 @@
                 <a:ea typeface="Arial" pitchFamily="34" charset="-122"/>
                 <a:cs typeface="Arial" pitchFamily="34" charset="-120"/>
               </a:rPr>
-              <a:t>2/10</a:t>
+              <a:t>2/7</a:t>
             </a:r>
             <a:endParaRPr lang="en-US" sz="900" dirty="0"/>
           </a:p>
@@ -6566,7 +5440,7 @@
                 <a:ea typeface="Arial" pitchFamily="34" charset="-122"/>
                 <a:cs typeface="Arial" pitchFamily="34" charset="-120"/>
               </a:rPr>
-              <a:t>3/10</a:t>
+              <a:t>3/7</a:t>
             </a:r>
             <a:endParaRPr lang="en-US" sz="900" dirty="0"/>
           </a:p>
@@ -8056,7 +6930,7 @@
                 <a:ea typeface="Arial" pitchFamily="34" charset="-122"/>
                 <a:cs typeface="Arial" pitchFamily="34" charset="-120"/>
               </a:rPr>
-              <a:t>4/10</a:t>
+              <a:t>4/7</a:t>
             </a:r>
             <a:endParaRPr lang="en-US" sz="900" dirty="0"/>
           </a:p>
@@ -9546,7 +8420,7 @@
                 <a:ea typeface="Arial" pitchFamily="34" charset="-122"/>
                 <a:cs typeface="Arial" pitchFamily="34" charset="-120"/>
               </a:rPr>
-              <a:t>5/10</a:t>
+              <a:t>5/7</a:t>
             </a:r>
             <a:endParaRPr lang="en-US" sz="900" dirty="0"/>
           </a:p>
@@ -9663,7 +8537,7 @@
                 <a:ea typeface="Georgia" pitchFamily="34" charset="-122"/>
                 <a:cs typeface="Georgia" pitchFamily="34" charset="-120"/>
               </a:rPr>
-              <a:t>法规逐条订阅机制</a:t>
+              <a:t>E-mark 工具:留存与服务转化设计</a:t>
             </a:r>
             <a:endParaRPr lang="en-US" sz="1900" dirty="0"/>
           </a:p>
@@ -9700,20 +8574,16 @@
         </p:nvSpPr>
         <p:spPr>
           <a:xfrm>
-            <a:off x="548640" y="2459736"/>
-            <a:ext cx="3822192" cy="4122500"/>
-          </a:xfrm>
-          <a:prstGeom prst="roundRect">
-            <a:avLst>
-              <a:gd name="adj" fmla="val 1435"/>
-            </a:avLst>
-          </a:prstGeom>
-          <a:solidFill>
-            <a:srgbClr val="FFFFFF"/>
-          </a:solidFill>
-          <a:ln w="9525">
+            <a:off x="4952848" y="2459736"/>
+            <a:ext cx="0" cy="4023360"/>
+          </a:xfrm>
+          <a:prstGeom prst="line">
+            <a:avLst/>
+          </a:prstGeom>
+          <a:noFill/>
+          <a:ln w="12700">
             <a:solidFill>
-              <a:srgbClr val="E8E8E8"/>
+              <a:srgbClr val="D8D8D8"/>
             </a:solidFill>
             <a:prstDash val="solid"/>
           </a:ln>
@@ -9727,16 +8597,19 @@
         </p:nvSpPr>
         <p:spPr>
           <a:xfrm>
-            <a:off x="548640" y="2459736"/>
-            <a:ext cx="3822192" cy="45720"/>
-          </a:xfrm>
-          <a:prstGeom prst="rect">
-            <a:avLst/>
-          </a:prstGeom>
-          <a:solidFill>
-            <a:srgbClr val="FF6600"/>
-          </a:solidFill>
-          <a:ln/>
+            <a:off x="548640" y="4471416"/>
+            <a:ext cx="8808415" cy="0"/>
+          </a:xfrm>
+          <a:prstGeom prst="line">
+            <a:avLst/>
+          </a:prstGeom>
+          <a:noFill/>
+          <a:ln w="12700">
+            <a:solidFill>
+              <a:srgbClr val="D8D8D8"/>
+            </a:solidFill>
+            <a:prstDash val="solid"/>
+          </a:ln>
         </p:spPr>
       </p:sp>
       <p:pic>
@@ -9755,8 +8628,8 @@
         </p:blipFill>
         <p:spPr>
           <a:xfrm>
-            <a:off x="676656" y="2587752"/>
-            <a:ext cx="3566160" cy="3866468"/>
+            <a:off x="658368" y="2569464"/>
+            <a:ext cx="1526515" cy="1655064"/>
           </a:xfrm>
           <a:prstGeom prst="rect">
             <a:avLst/>
@@ -9771,18 +8644,19 @@
         </p:nvSpPr>
         <p:spPr>
           <a:xfrm>
-            <a:off x="4736592" y="2514600"/>
-            <a:ext cx="1188720" cy="274320"/>
-          </a:xfrm>
-          <a:prstGeom prst="roundRect">
-            <a:avLst>
-              <a:gd name="adj" fmla="val 50000"/>
-            </a:avLst>
-          </a:prstGeom>
-          <a:solidFill>
-            <a:srgbClr val="FFF1E8"/>
-          </a:solidFill>
-          <a:ln/>
+            <a:off x="658368" y="2569464"/>
+            <a:ext cx="1526515" cy="1655064"/>
+          </a:xfrm>
+          <a:prstGeom prst="line">
+            <a:avLst/>
+          </a:prstGeom>
+          <a:noFill/>
+          <a:ln w="9525">
+            <a:solidFill>
+              <a:srgbClr val="E8E8E8"/>
+            </a:solidFill>
+            <a:prstDash val="solid"/>
+          </a:ln>
         </p:spPr>
       </p:sp>
       <p:sp>
@@ -9793,47 +8667,8 @@
         </p:nvSpPr>
         <p:spPr>
           <a:xfrm>
-            <a:off x="4736592" y="2514600"/>
-            <a:ext cx="1188720" cy="274320"/>
-          </a:xfrm>
-          <a:prstGeom prst="rect">
-            <a:avLst/>
-          </a:prstGeom>
-          <a:noFill/>
-          <a:ln/>
-        </p:spPr>
-        <p:txBody>
-          <a:bodyPr wrap="square" lIns="0" tIns="0" rIns="0" bIns="0" rtlCol="0" anchor="ctr"/>
-          <a:lstStyle/>
-          <a:p>
-            <a:pPr algn="ctr" indent="0" marL="0">
-              <a:buNone/>
-            </a:pPr>
-            <a:r>
-              <a:rPr lang="en-US" sz="1000" b="1" dirty="0">
-                <a:solidFill>
-                  <a:srgbClr val="FF6600"/>
-                </a:solidFill>
-                <a:latin typeface="Arial" pitchFamily="34" charset="0"/>
-                <a:ea typeface="Arial" pitchFamily="34" charset="-122"/>
-                <a:cs typeface="Arial" pitchFamily="34" charset="-120"/>
-              </a:rPr>
-              <a:t>亮点①</a:t>
-            </a:r>
-            <a:endParaRPr lang="en-US" sz="1000" dirty="0"/>
-          </a:p>
-        </p:txBody>
-      </p:sp>
-      <p:sp>
-        <p:nvSpPr>
-          <p:cNvPr id="10" name="Text 7"/>
-          <p:cNvSpPr txBox="1"/>
-          <p:nvPr/>
-        </p:nvSpPr>
-        <p:spPr>
-          <a:xfrm>
-            <a:off x="4736592" y="2953512"/>
-            <a:ext cx="4620463" cy="1051560"/>
+            <a:off x="2386051" y="2569464"/>
+            <a:ext cx="2274188" cy="402336"/>
           </a:xfrm>
           <a:prstGeom prst="rect">
             <a:avLst/>
@@ -9847,12 +8682,12 @@
           <a:p>
             <a:pPr indent="0" marL="0">
               <a:lnSpc>
-                <a:spcPts val="1900"/>
+                <a:spcPts val="1450"/>
               </a:lnSpc>
               <a:buNone/>
             </a:pPr>
             <a:r>
-              <a:rPr lang="en-US" sz="1350" b="1" dirty="0">
+              <a:rPr lang="en-US" sz="1150" b="1" dirty="0">
                 <a:solidFill>
                   <a:srgbClr val="363636"/>
                 </a:solidFill>
@@ -9860,42 +8695,45 @@
                 <a:ea typeface="Arial" pitchFamily="34" charset="-122"/>
                 <a:cs typeface="Arial" pitchFamily="34" charset="-120"/>
               </a:rPr>
-              <a:t>法规盘点页支持按条订阅法规动态更新,评估结果不再是一次性判定。</a:t>
-            </a:r>
-            <a:endParaRPr lang="en-US" sz="1350" dirty="0"/>
-          </a:p>
-        </p:txBody>
-      </p:sp>
-      <p:sp>
-        <p:nvSpPr>
-          <p:cNvPr id="11" name="Shape 8"/>
-          <p:cNvSpPr/>
-          <p:nvPr/>
-        </p:nvSpPr>
-        <p:spPr>
-          <a:xfrm>
-            <a:off x="4754880" y="4160520"/>
-            <a:ext cx="64008" cy="64008"/>
-          </a:xfrm>
-          <a:prstGeom prst="ellipse">
-            <a:avLst/>
-          </a:prstGeom>
-          <a:solidFill>
-            <a:srgbClr val="FF6600"/>
-          </a:solidFill>
-          <a:ln/>
-        </p:spPr>
-      </p:sp>
-      <p:sp>
-        <p:nvSpPr>
-          <p:cNvPr id="12" name="Text 9"/>
+              <a:t>① 法规逐条订阅机制</a:t>
+            </a:r>
+            <a:endParaRPr lang="en-US" sz="1150" dirty="0"/>
+          </a:p>
+        </p:txBody>
+      </p:sp>
+      <p:sp>
+        <p:nvSpPr>
+          <p:cNvPr id="10" name="Shape 7"/>
+          <p:cNvSpPr/>
+          <p:nvPr/>
+        </p:nvSpPr>
+        <p:spPr>
+          <a:xfrm>
+            <a:off x="2386051" y="2990088"/>
+            <a:ext cx="365760" cy="0"/>
+          </a:xfrm>
+          <a:prstGeom prst="line">
+            <a:avLst/>
+          </a:prstGeom>
+          <a:noFill/>
+          <a:ln w="19050">
+            <a:solidFill>
+              <a:srgbClr val="FF6600"/>
+            </a:solidFill>
+            <a:prstDash val="solid"/>
+          </a:ln>
+        </p:spPr>
+      </p:sp>
+      <p:sp>
+        <p:nvSpPr>
+          <p:cNvPr id="11" name="Text 8"/>
           <p:cNvSpPr txBox="1"/>
           <p:nvPr/>
         </p:nvSpPr>
         <p:spPr>
           <a:xfrm>
-            <a:off x="4937760" y="4059936"/>
-            <a:ext cx="4419295" cy="530352"/>
+            <a:off x="2386051" y="3081528"/>
+            <a:ext cx="2274188" cy="1143000"/>
           </a:xfrm>
           <a:prstGeom prst="rect">
             <a:avLst/>
@@ -9909,12 +8747,12 @@
           <a:p>
             <a:pPr indent="0" marL="0">
               <a:lnSpc>
-                <a:spcPts val="1700"/>
+                <a:spcPts val="1350"/>
               </a:lnSpc>
               <a:buNone/>
             </a:pPr>
             <a:r>
-              <a:rPr lang="en-US" sz="1150" dirty="0">
+              <a:rPr lang="en-US" sz="950" dirty="0">
                 <a:solidFill>
                   <a:srgbClr val="363636"/>
                 </a:solidFill>
@@ -9922,42 +8760,69 @@
                 <a:ea typeface="Arial" pitchFamily="34" charset="-122"/>
                 <a:cs typeface="Arial" pitchFamily="34" charset="-120"/>
               </a:rPr>
-              <a:t>用户可按自身产品建立个性化关注清单,评估完成后仍保留后续追踪需求</a:t>
-            </a:r>
-            <a:endParaRPr lang="en-US" sz="1150" dirty="0"/>
-          </a:p>
-        </p:txBody>
-      </p:sp>
-      <p:sp>
-        <p:nvSpPr>
-          <p:cNvPr id="13" name="Shape 10"/>
-          <p:cNvSpPr/>
-          <p:nvPr/>
-        </p:nvSpPr>
-        <p:spPr>
-          <a:xfrm>
-            <a:off x="4754880" y="4800600"/>
-            <a:ext cx="64008" cy="64008"/>
-          </a:xfrm>
-          <a:prstGeom prst="ellipse">
-            <a:avLst/>
-          </a:prstGeom>
-          <a:solidFill>
-            <a:srgbClr val="FF6600"/>
-          </a:solidFill>
-          <a:ln/>
-        </p:spPr>
-      </p:sp>
-      <p:sp>
-        <p:nvSpPr>
-          <p:cNvPr id="14" name="Text 11"/>
+              <a:t>法规盘点页支持按条订阅动态更新,用户建立个性化关注清单,评估完成后仍持续使用平台。</a:t>
+            </a:r>
+            <a:endParaRPr lang="en-US" sz="950" dirty="0"/>
+          </a:p>
+        </p:txBody>
+      </p:sp>
+      <p:pic>
+        <p:nvPicPr>
+          <p:cNvPr id="12" name="Image 1" descr="/tmp/pptx_work/screenshots/u2_journey.png">    </p:cNvPr>
+          <p:cNvPicPr>
+            <a:picLocks noChangeAspect="1"/>
+          </p:cNvPicPr>
+          <p:nvPr/>
+        </p:nvPicPr>
+        <p:blipFill>
+          <a:blip r:embed="rId3"/>
+          <a:stretch>
+            <a:fillRect/>
+          </a:stretch>
+        </p:blipFill>
+        <p:spPr>
+          <a:xfrm>
+            <a:off x="5245456" y="2569464"/>
+            <a:ext cx="1368023" cy="1655064"/>
+          </a:xfrm>
+          <a:prstGeom prst="rect">
+            <a:avLst/>
+          </a:prstGeom>
+        </p:spPr>
+      </p:pic>
+      <p:sp>
+        <p:nvSpPr>
+          <p:cNvPr id="13" name="Shape 9"/>
+          <p:cNvSpPr/>
+          <p:nvPr/>
+        </p:nvSpPr>
+        <p:spPr>
+          <a:xfrm>
+            <a:off x="5245456" y="2569464"/>
+            <a:ext cx="1368023" cy="1655064"/>
+          </a:xfrm>
+          <a:prstGeom prst="line">
+            <a:avLst/>
+          </a:prstGeom>
+          <a:noFill/>
+          <a:ln w="9525">
+            <a:solidFill>
+              <a:srgbClr val="E8E8E8"/>
+            </a:solidFill>
+            <a:prstDash val="solid"/>
+          </a:ln>
+        </p:spPr>
+      </p:sp>
+      <p:sp>
+        <p:nvSpPr>
+          <p:cNvPr id="14" name="Text 10"/>
           <p:cNvSpPr txBox="1"/>
           <p:nvPr/>
         </p:nvSpPr>
         <p:spPr>
           <a:xfrm>
-            <a:off x="4937760" y="4700016"/>
-            <a:ext cx="4419295" cy="310896"/>
+            <a:off x="6814647" y="2569464"/>
+            <a:ext cx="2432680" cy="402336"/>
           </a:xfrm>
           <a:prstGeom prst="rect">
             <a:avLst/>
@@ -9971,12 +8836,12 @@
           <a:p>
             <a:pPr indent="0" marL="0">
               <a:lnSpc>
-                <a:spcPts val="1700"/>
+                <a:spcPts val="1450"/>
               </a:lnSpc>
               <a:buNone/>
             </a:pPr>
             <a:r>
-              <a:rPr lang="en-US" sz="1150" dirty="0">
+              <a:rPr lang="en-US" sz="1150" b="1" dirty="0">
                 <a:solidFill>
                   <a:srgbClr val="363636"/>
                 </a:solidFill>
@@ -9984,7 +8849,7 @@
                 <a:ea typeface="Arial" pitchFamily="34" charset="-122"/>
                 <a:cs typeface="Arial" pitchFamily="34" charset="-120"/>
               </a:rPr>
-              <a:t>法规更新时系统主动提示,形成持续性的平台使用场景</a:t>
+              <a:t>② 认证旅程九站进度管理</a:t>
             </a:r>
             <a:endParaRPr lang="en-US" sz="1150" dirty="0"/>
           </a:p>
@@ -9992,7 +8857,380 @@
       </p:sp>
       <p:sp>
         <p:nvSpPr>
-          <p:cNvPr id="15" name="Shape 12"/>
+          <p:cNvPr id="15" name="Shape 11"/>
+          <p:cNvSpPr/>
+          <p:nvPr/>
+        </p:nvSpPr>
+        <p:spPr>
+          <a:xfrm>
+            <a:off x="6814647" y="2990088"/>
+            <a:ext cx="365760" cy="0"/>
+          </a:xfrm>
+          <a:prstGeom prst="line">
+            <a:avLst/>
+          </a:prstGeom>
+          <a:noFill/>
+          <a:ln w="19050">
+            <a:solidFill>
+              <a:srgbClr val="FF6600"/>
+            </a:solidFill>
+            <a:prstDash val="solid"/>
+          </a:ln>
+        </p:spPr>
+      </p:sp>
+      <p:sp>
+        <p:nvSpPr>
+          <p:cNvPr id="16" name="Text 12"/>
+          <p:cNvSpPr txBox="1"/>
+          <p:nvPr/>
+        </p:nvSpPr>
+        <p:spPr>
+          <a:xfrm>
+            <a:off x="6814647" y="3081528"/>
+            <a:ext cx="2432680" cy="1143000"/>
+          </a:xfrm>
+          <a:prstGeom prst="rect">
+            <a:avLst/>
+          </a:prstGeom>
+          <a:noFill/>
+          <a:ln/>
+        </p:spPr>
+        <p:txBody>
+          <a:bodyPr wrap="square" lIns="0" tIns="0" rIns="0" bIns="0" rtlCol="0" anchor="t"/>
+          <a:lstStyle/>
+          <a:p>
+            <a:pPr indent="0" marL="0">
+              <a:lnSpc>
+                <a:spcPts val="1350"/>
+              </a:lnSpc>
+              <a:buNone/>
+            </a:pPr>
+            <a:r>
+              <a:rPr lang="en-US" sz="950" dirty="0">
+                <a:solidFill>
+                  <a:srgbClr val="363636"/>
+                </a:solidFill>
+                <a:latin typeface="Arial" pitchFamily="34" charset="0"/>
+                <a:ea typeface="Arial" pitchFamily="34" charset="-122"/>
+                <a:cs typeface="Arial" pitchFamily="34" charset="-120"/>
+              </a:rPr>
+              <a:t>认证全流程拆分为 9 个站点,实时显示各站完成情况,阶段性进展持续吸引用户回访。</a:t>
+            </a:r>
+            <a:endParaRPr lang="en-US" sz="950" dirty="0"/>
+          </a:p>
+        </p:txBody>
+      </p:sp>
+      <p:pic>
+        <p:nvPicPr>
+          <p:cNvPr id="17" name="Image 2" descr="/tmp/pptx_work/screenshots/u3_maturity.png">    </p:cNvPr>
+          <p:cNvPicPr>
+            <a:picLocks noChangeAspect="1"/>
+          </p:cNvPicPr>
+          <p:nvPr/>
+        </p:nvPicPr>
+        <p:blipFill>
+          <a:blip r:embed="rId4"/>
+          <a:stretch>
+            <a:fillRect/>
+          </a:stretch>
+        </p:blipFill>
+        <p:spPr>
+          <a:xfrm>
+            <a:off x="658368" y="4718304"/>
+            <a:ext cx="1313236" cy="1655064"/>
+          </a:xfrm>
+          <a:prstGeom prst="rect">
+            <a:avLst/>
+          </a:prstGeom>
+        </p:spPr>
+      </p:pic>
+      <p:sp>
+        <p:nvSpPr>
+          <p:cNvPr id="18" name="Shape 13"/>
+          <p:cNvSpPr/>
+          <p:nvPr/>
+        </p:nvSpPr>
+        <p:spPr>
+          <a:xfrm>
+            <a:off x="658368" y="4718304"/>
+            <a:ext cx="1313236" cy="1655064"/>
+          </a:xfrm>
+          <a:prstGeom prst="line">
+            <a:avLst/>
+          </a:prstGeom>
+          <a:noFill/>
+          <a:ln w="9525">
+            <a:solidFill>
+              <a:srgbClr val="E8E8E8"/>
+            </a:solidFill>
+            <a:prstDash val="solid"/>
+          </a:ln>
+        </p:spPr>
+      </p:sp>
+      <p:sp>
+        <p:nvSpPr>
+          <p:cNvPr id="19" name="Text 14"/>
+          <p:cNvSpPr txBox="1"/>
+          <p:nvPr/>
+        </p:nvSpPr>
+        <p:spPr>
+          <a:xfrm>
+            <a:off x="2172772" y="4718304"/>
+            <a:ext cx="2487467" cy="402336"/>
+          </a:xfrm>
+          <a:prstGeom prst="rect">
+            <a:avLst/>
+          </a:prstGeom>
+          <a:noFill/>
+          <a:ln/>
+        </p:spPr>
+        <p:txBody>
+          <a:bodyPr wrap="square" lIns="0" tIns="0" rIns="0" bIns="0" rtlCol="0" anchor="t"/>
+          <a:lstStyle/>
+          <a:p>
+            <a:pPr indent="0" marL="0">
+              <a:lnSpc>
+                <a:spcPts val="1450"/>
+              </a:lnSpc>
+              <a:buNone/>
+            </a:pPr>
+            <a:r>
+              <a:rPr lang="en-US" sz="1150" b="1" dirty="0">
+                <a:solidFill>
+                  <a:srgbClr val="363636"/>
+                </a:solidFill>
+                <a:latin typeface="Arial" pitchFamily="34" charset="0"/>
+                <a:ea typeface="Arial" pitchFamily="34" charset="-122"/>
+                <a:cs typeface="Arial" pitchFamily="34" charset="-120"/>
+              </a:rPr>
+              <a:t>③ 合规成熟度量化评分</a:t>
+            </a:r>
+            <a:endParaRPr lang="en-US" sz="1150" dirty="0"/>
+          </a:p>
+        </p:txBody>
+      </p:sp>
+      <p:sp>
+        <p:nvSpPr>
+          <p:cNvPr id="20" name="Shape 15"/>
+          <p:cNvSpPr/>
+          <p:nvPr/>
+        </p:nvSpPr>
+        <p:spPr>
+          <a:xfrm>
+            <a:off x="2172772" y="5138928"/>
+            <a:ext cx="365760" cy="0"/>
+          </a:xfrm>
+          <a:prstGeom prst="line">
+            <a:avLst/>
+          </a:prstGeom>
+          <a:noFill/>
+          <a:ln w="19050">
+            <a:solidFill>
+              <a:srgbClr val="FF6600"/>
+            </a:solidFill>
+            <a:prstDash val="solid"/>
+          </a:ln>
+        </p:spPr>
+      </p:sp>
+      <p:sp>
+        <p:nvSpPr>
+          <p:cNvPr id="21" name="Text 16"/>
+          <p:cNvSpPr txBox="1"/>
+          <p:nvPr/>
+        </p:nvSpPr>
+        <p:spPr>
+          <a:xfrm>
+            <a:off x="2172772" y="5230368"/>
+            <a:ext cx="2487467" cy="1143000"/>
+          </a:xfrm>
+          <a:prstGeom prst="rect">
+            <a:avLst/>
+          </a:prstGeom>
+          <a:noFill/>
+          <a:ln/>
+        </p:spPr>
+        <p:txBody>
+          <a:bodyPr wrap="square" lIns="0" tIns="0" rIns="0" bIns="0" rtlCol="0" anchor="t"/>
+          <a:lstStyle/>
+          <a:p>
+            <a:pPr indent="0" marL="0">
+              <a:lnSpc>
+                <a:spcPts val="1350"/>
+              </a:lnSpc>
+              <a:buNone/>
+            </a:pPr>
+            <a:r>
+              <a:rPr lang="en-US" sz="950" dirty="0">
+                <a:solidFill>
+                  <a:srgbClr val="363636"/>
+                </a:solidFill>
+                <a:latin typeface="Arial" pitchFamily="34" charset="0"/>
+                <a:ea typeface="Arial" pitchFamily="34" charset="-122"/>
+                <a:cs typeface="Arial" pitchFamily="34" charset="-120"/>
+              </a:rPr>
+              <a:t>法规完成度与体系成熟度双轴打分,自动定位所在象限,评分变化驱动用户复测跟踪。</a:t>
+            </a:r>
+            <a:endParaRPr lang="en-US" sz="950" dirty="0"/>
+          </a:p>
+        </p:txBody>
+      </p:sp>
+      <p:pic>
+        <p:nvPicPr>
+          <p:cNvPr id="22" name="Image 3" descr="/tmp/pptx_work/screenshots/u4_gaptable.png">    </p:cNvPr>
+          <p:cNvPicPr>
+            <a:picLocks noChangeAspect="1"/>
+          </p:cNvPicPr>
+          <p:nvPr/>
+        </p:nvPicPr>
+        <p:blipFill>
+          <a:blip r:embed="rId5"/>
+          <a:stretch>
+            <a:fillRect/>
+          </a:stretch>
+        </p:blipFill>
+        <p:spPr>
+          <a:xfrm>
+            <a:off x="5245456" y="4718304"/>
+            <a:ext cx="2134302" cy="1655064"/>
+          </a:xfrm>
+          <a:prstGeom prst="rect">
+            <a:avLst/>
+          </a:prstGeom>
+        </p:spPr>
+      </p:pic>
+      <p:sp>
+        <p:nvSpPr>
+          <p:cNvPr id="23" name="Shape 17"/>
+          <p:cNvSpPr/>
+          <p:nvPr/>
+        </p:nvSpPr>
+        <p:spPr>
+          <a:xfrm>
+            <a:off x="5245456" y="4718304"/>
+            <a:ext cx="2134302" cy="1655064"/>
+          </a:xfrm>
+          <a:prstGeom prst="line">
+            <a:avLst/>
+          </a:prstGeom>
+          <a:noFill/>
+          <a:ln w="9525">
+            <a:solidFill>
+              <a:srgbClr val="E8E8E8"/>
+            </a:solidFill>
+            <a:prstDash val="solid"/>
+          </a:ln>
+        </p:spPr>
+      </p:sp>
+      <p:sp>
+        <p:nvSpPr>
+          <p:cNvPr id="24" name="Text 18"/>
+          <p:cNvSpPr txBox="1"/>
+          <p:nvPr/>
+        </p:nvSpPr>
+        <p:spPr>
+          <a:xfrm>
+            <a:off x="7580926" y="4718304"/>
+            <a:ext cx="1666401" cy="402336"/>
+          </a:xfrm>
+          <a:prstGeom prst="rect">
+            <a:avLst/>
+          </a:prstGeom>
+          <a:noFill/>
+          <a:ln/>
+        </p:spPr>
+        <p:txBody>
+          <a:bodyPr wrap="square" lIns="0" tIns="0" rIns="0" bIns="0" rtlCol="0" anchor="t"/>
+          <a:lstStyle/>
+          <a:p>
+            <a:pPr indent="0" marL="0">
+              <a:lnSpc>
+                <a:spcPts val="1450"/>
+              </a:lnSpc>
+              <a:buNone/>
+            </a:pPr>
+            <a:r>
+              <a:rPr lang="en-US" sz="1150" b="1" dirty="0">
+                <a:solidFill>
+                  <a:srgbClr val="363636"/>
+                </a:solidFill>
+                <a:latin typeface="Arial" pitchFamily="34" charset="0"/>
+                <a:ea typeface="Arial" pitchFamily="34" charset="-122"/>
+                <a:cs typeface="Arial" pitchFamily="34" charset="-120"/>
+              </a:rPr>
+              <a:t>④ 缺口分级与服务映射</a:t>
+            </a:r>
+            <a:endParaRPr lang="en-US" sz="1150" dirty="0"/>
+          </a:p>
+        </p:txBody>
+      </p:sp>
+      <p:sp>
+        <p:nvSpPr>
+          <p:cNvPr id="25" name="Shape 19"/>
+          <p:cNvSpPr/>
+          <p:nvPr/>
+        </p:nvSpPr>
+        <p:spPr>
+          <a:xfrm>
+            <a:off x="7580926" y="5138928"/>
+            <a:ext cx="365760" cy="0"/>
+          </a:xfrm>
+          <a:prstGeom prst="line">
+            <a:avLst/>
+          </a:prstGeom>
+          <a:noFill/>
+          <a:ln w="19050">
+            <a:solidFill>
+              <a:srgbClr val="FF6600"/>
+            </a:solidFill>
+            <a:prstDash val="solid"/>
+          </a:ln>
+        </p:spPr>
+      </p:sp>
+      <p:sp>
+        <p:nvSpPr>
+          <p:cNvPr id="26" name="Text 20"/>
+          <p:cNvSpPr txBox="1"/>
+          <p:nvPr/>
+        </p:nvSpPr>
+        <p:spPr>
+          <a:xfrm>
+            <a:off x="7580926" y="5230368"/>
+            <a:ext cx="1666401" cy="1143000"/>
+          </a:xfrm>
+          <a:prstGeom prst="rect">
+            <a:avLst/>
+          </a:prstGeom>
+          <a:noFill/>
+          <a:ln/>
+        </p:spPr>
+        <p:txBody>
+          <a:bodyPr wrap="square" lIns="0" tIns="0" rIns="0" bIns="0" rtlCol="0" anchor="t"/>
+          <a:lstStyle/>
+          <a:p>
+            <a:pPr indent="0" marL="0">
+              <a:lnSpc>
+                <a:spcPts val="1350"/>
+              </a:lnSpc>
+              <a:buNone/>
+            </a:pPr>
+            <a:r>
+              <a:rPr lang="en-US" sz="950" dirty="0">
+                <a:solidFill>
+                  <a:srgbClr val="363636"/>
+                </a:solidFill>
+                <a:latin typeface="Arial" pitchFamily="34" charset="0"/>
+                <a:ea typeface="Arial" pitchFamily="34" charset="-122"/>
+                <a:cs typeface="Arial" pitchFamily="34" charset="-120"/>
+              </a:rPr>
+              <a:t>行动清单按风险等级排序待办事项,每条缺口均对应具体的建议行动与支持服务。</a:t>
+            </a:r>
+            <a:endParaRPr lang="en-US" sz="950" dirty="0"/>
+          </a:p>
+        </p:txBody>
+      </p:sp>
+      <p:sp>
+        <p:nvSpPr>
+          <p:cNvPr id="27" name="Shape 21"/>
           <p:cNvSpPr/>
           <p:nvPr/>
         </p:nvSpPr>
@@ -10012,7 +9250,7 @@
       </p:sp>
       <p:sp>
         <p:nvSpPr>
-          <p:cNvPr id="16" name="Text 13"/>
+          <p:cNvPr id="28" name="Text 22"/>
           <p:cNvSpPr txBox="1"/>
           <p:nvPr/>
         </p:nvSpPr>
@@ -10043,7 +9281,7 @@
                 <a:ea typeface="Arial" pitchFamily="34" charset="-122"/>
                 <a:cs typeface="Arial" pitchFamily="34" charset="-120"/>
               </a:rPr>
-              <a:t>6/10</a:t>
+              <a:t>6/7</a:t>
             </a:r>
             <a:endParaRPr lang="en-US" sz="900" dirty="0"/>
           </a:p>
@@ -10121,7 +9359,7 @@
                 <a:ea typeface="Arial" pitchFamily="34" charset="-122"/>
                 <a:cs typeface="Arial" pitchFamily="34" charset="-120"/>
               </a:rPr>
-              <a:t>第二部分 · 非项目情况 · 工具亮点</a:t>
+              <a:t>第四部分 · 10月工作计划</a:t>
             </a:r>
             <a:endParaRPr lang="en-US" sz="1050" dirty="0"/>
           </a:p>
@@ -10160,7 +9398,7 @@
                 <a:ea typeface="Georgia" pitchFamily="34" charset="-122"/>
                 <a:cs typeface="Georgia" pitchFamily="34" charset="-120"/>
               </a:rPr>
-              <a:t>认证旅程九站进度管理</a:t>
+              <a:t>10月工作计划</a:t>
             </a:r>
             <a:endParaRPr lang="en-US" sz="1900" dirty="0"/>
           </a:p>
@@ -10197,12 +9435,12 @@
         </p:nvSpPr>
         <p:spPr>
           <a:xfrm>
-            <a:off x="548640" y="2459736"/>
-            <a:ext cx="3502152" cy="4183258"/>
+            <a:off x="548640" y="2331720"/>
+            <a:ext cx="8808415" cy="512064"/>
           </a:xfrm>
           <a:prstGeom prst="roundRect">
             <a:avLst>
-              <a:gd name="adj" fmla="val 1567"/>
+              <a:gd name="adj" fmla="val 8036"/>
             </a:avLst>
           </a:prstGeom>
           <a:solidFill>
@@ -10224,8 +9462,8 @@
         </p:nvSpPr>
         <p:spPr>
           <a:xfrm>
-            <a:off x="548640" y="2459736"/>
-            <a:ext cx="3502152" cy="45720"/>
+            <a:off x="566928" y="2368296"/>
+            <a:ext cx="32004" cy="438912"/>
           </a:xfrm>
           <a:prstGeom prst="rect">
             <a:avLst/>
@@ -10238,7 +9476,7 @@
       </p:sp>
       <p:pic>
         <p:nvPicPr>
-          <p:cNvPr id="7" name="Image 0" descr="/tmp/pptx_work/screenshots/u2_journey.png">    </p:cNvPr>
+          <p:cNvPr id="7" name="Image 0" descr="/tmp/pptx_work/icons/check.png">    </p:cNvPr>
           <p:cNvPicPr>
             <a:picLocks noChangeAspect="1"/>
           </p:cNvPicPr>
@@ -10252,8 +9490,8 @@
         </p:blipFill>
         <p:spPr>
           <a:xfrm>
-            <a:off x="676656" y="2587752"/>
-            <a:ext cx="3246120" cy="3927226"/>
+            <a:off x="676656" y="2423160"/>
+            <a:ext cx="329184" cy="329184"/>
           </a:xfrm>
           <a:prstGeom prst="rect">
             <a:avLst/>
@@ -10262,36 +9500,14 @@
       </p:pic>
       <p:sp>
         <p:nvSpPr>
-          <p:cNvPr id="8" name="Shape 5"/>
-          <p:cNvSpPr/>
-          <p:nvPr/>
-        </p:nvSpPr>
-        <p:spPr>
-          <a:xfrm>
-            <a:off x="4416552" y="2514600"/>
-            <a:ext cx="1188720" cy="274320"/>
-          </a:xfrm>
-          <a:prstGeom prst="roundRect">
-            <a:avLst>
-              <a:gd name="adj" fmla="val 50000"/>
-            </a:avLst>
-          </a:prstGeom>
-          <a:solidFill>
-            <a:srgbClr val="FFF1E8"/>
-          </a:solidFill>
-          <a:ln/>
-        </p:spPr>
-      </p:sp>
-      <p:sp>
-        <p:nvSpPr>
-          <p:cNvPr id="9" name="Text 6"/>
+          <p:cNvPr id="8" name="Text 5"/>
           <p:cNvSpPr txBox="1"/>
           <p:nvPr/>
         </p:nvSpPr>
         <p:spPr>
           <a:xfrm>
-            <a:off x="4416552" y="2514600"/>
-            <a:ext cx="1188720" cy="274320"/>
+            <a:off x="1188720" y="2331720"/>
+            <a:ext cx="7985455" cy="512064"/>
           </a:xfrm>
           <a:prstGeom prst="rect">
             <a:avLst/>
@@ -10303,111 +9519,7 @@
           <a:bodyPr wrap="square" lIns="0" tIns="0" rIns="0" bIns="0" rtlCol="0" anchor="ctr"/>
           <a:lstStyle/>
           <a:p>
-            <a:pPr algn="ctr" indent="0" marL="0">
-              <a:buNone/>
-            </a:pPr>
-            <a:r>
-              <a:rPr lang="en-US" sz="1000" b="1" dirty="0">
-                <a:solidFill>
-                  <a:srgbClr val="FF6600"/>
-                </a:solidFill>
-                <a:latin typeface="Arial" pitchFamily="34" charset="0"/>
-                <a:ea typeface="Arial" pitchFamily="34" charset="-122"/>
-                <a:cs typeface="Arial" pitchFamily="34" charset="-120"/>
-              </a:rPr>
-              <a:t>亮点②</a:t>
-            </a:r>
-            <a:endParaRPr lang="en-US" sz="1000" dirty="0"/>
-          </a:p>
-        </p:txBody>
-      </p:sp>
-      <p:sp>
-        <p:nvSpPr>
-          <p:cNvPr id="10" name="Text 7"/>
-          <p:cNvSpPr txBox="1"/>
-          <p:nvPr/>
-        </p:nvSpPr>
-        <p:spPr>
-          <a:xfrm>
-            <a:off x="4416552" y="2953512"/>
-            <a:ext cx="4940503" cy="1051560"/>
-          </a:xfrm>
-          <a:prstGeom prst="rect">
-            <a:avLst/>
-          </a:prstGeom>
-          <a:noFill/>
-          <a:ln/>
-        </p:spPr>
-        <p:txBody>
-          <a:bodyPr wrap="square" lIns="0" tIns="0" rIns="0" bIns="0" rtlCol="0" anchor="t"/>
-          <a:lstStyle/>
-          <a:p>
             <a:pPr indent="0" marL="0">
-              <a:lnSpc>
-                <a:spcPts val="1900"/>
-              </a:lnSpc>
-              <a:buNone/>
-            </a:pPr>
-            <a:r>
-              <a:rPr lang="en-US" sz="1350" b="1" dirty="0">
-                <a:solidFill>
-                  <a:srgbClr val="363636"/>
-                </a:solidFill>
-                <a:latin typeface="Arial" pitchFamily="34" charset="0"/>
-                <a:ea typeface="Arial" pitchFamily="34" charset="-122"/>
-                <a:cs typeface="Arial" pitchFamily="34" charset="-120"/>
-              </a:rPr>
-              <a:t>认证旅程将型式批准全流程拆分为 9 个站点,实时显示各站完成情况与所需材料(如「获证与打标」站已获 9/90 张证书)。</a:t>
-            </a:r>
-            <a:endParaRPr lang="en-US" sz="1350" dirty="0"/>
-          </a:p>
-        </p:txBody>
-      </p:sp>
-      <p:sp>
-        <p:nvSpPr>
-          <p:cNvPr id="11" name="Shape 8"/>
-          <p:cNvSpPr/>
-          <p:nvPr/>
-        </p:nvSpPr>
-        <p:spPr>
-          <a:xfrm>
-            <a:off x="4434840" y="4160520"/>
-            <a:ext cx="64008" cy="64008"/>
-          </a:xfrm>
-          <a:prstGeom prst="ellipse">
-            <a:avLst/>
-          </a:prstGeom>
-          <a:solidFill>
-            <a:srgbClr val="FF6600"/>
-          </a:solidFill>
-          <a:ln/>
-        </p:spPr>
-      </p:sp>
-      <p:sp>
-        <p:nvSpPr>
-          <p:cNvPr id="12" name="Text 9"/>
-          <p:cNvSpPr txBox="1"/>
-          <p:nvPr/>
-        </p:nvSpPr>
-        <p:spPr>
-          <a:xfrm>
-            <a:off x="4617720" y="4059936"/>
-            <a:ext cx="4739335" cy="310896"/>
-          </a:xfrm>
-          <a:prstGeom prst="rect">
-            <a:avLst/>
-          </a:prstGeom>
-          <a:noFill/>
-          <a:ln/>
-        </p:spPr>
-        <p:txBody>
-          <a:bodyPr wrap="square" lIns="0" tIns="0" rIns="0" bIns="0" rtlCol="0" anchor="t"/>
-          <a:lstStyle/>
-          <a:p>
-            <a:pPr indent="0" marL="0">
-              <a:lnSpc>
-                <a:spcPts val="1700"/>
-              </a:lnSpc>
               <a:buNone/>
             </a:pPr>
             <a:r>
@@ -10419,7 +9531,7 @@
                 <a:ea typeface="Arial" pitchFamily="34" charset="-122"/>
                 <a:cs typeface="Arial" pitchFamily="34" charset="-120"/>
               </a:rPr>
-              <a:t>认证周期通常横跨数月,分阶段进度呈现使长周期目标可视化</a:t>
+              <a:t>编制 9 月《法规雷达》月报</a:t>
             </a:r>
             <a:endParaRPr lang="en-US" sz="1150" dirty="0"/>
           </a:p>
@@ -10427,16 +9539,43 @@
       </p:sp>
       <p:sp>
         <p:nvSpPr>
-          <p:cNvPr id="13" name="Shape 10"/>
-          <p:cNvSpPr/>
-          <p:nvPr/>
-        </p:nvSpPr>
-        <p:spPr>
-          <a:xfrm>
-            <a:off x="4434840" y="4581144"/>
-            <a:ext cx="64008" cy="64008"/>
-          </a:xfrm>
-          <a:prstGeom prst="ellipse">
+          <p:cNvPr id="9" name="Shape 6"/>
+          <p:cNvSpPr/>
+          <p:nvPr/>
+        </p:nvSpPr>
+        <p:spPr>
+          <a:xfrm>
+            <a:off x="548640" y="2953512"/>
+            <a:ext cx="8808415" cy="512064"/>
+          </a:xfrm>
+          <a:prstGeom prst="roundRect">
+            <a:avLst>
+              <a:gd name="adj" fmla="val 8036"/>
+            </a:avLst>
+          </a:prstGeom>
+          <a:solidFill>
+            <a:srgbClr val="FFFFFF"/>
+          </a:solidFill>
+          <a:ln w="9525">
+            <a:solidFill>
+              <a:srgbClr val="E8E8E8"/>
+            </a:solidFill>
+            <a:prstDash val="solid"/>
+          </a:ln>
+        </p:spPr>
+      </p:sp>
+      <p:sp>
+        <p:nvSpPr>
+          <p:cNvPr id="10" name="Shape 7"/>
+          <p:cNvSpPr/>
+          <p:nvPr/>
+        </p:nvSpPr>
+        <p:spPr>
+          <a:xfrm>
+            <a:off x="566928" y="2990088"/>
+            <a:ext cx="32004" cy="438912"/>
+          </a:xfrm>
+          <a:prstGeom prst="rect">
             <a:avLst/>
           </a:prstGeom>
           <a:solidFill>
@@ -10445,31 +9584,52 @@
           <a:ln/>
         </p:spPr>
       </p:sp>
-      <p:sp>
-        <p:nvSpPr>
-          <p:cNvPr id="14" name="Text 11"/>
+      <p:pic>
+        <p:nvPicPr>
+          <p:cNvPr id="11" name="Image 1" descr="/tmp/pptx_work/icons/check.png">    </p:cNvPr>
+          <p:cNvPicPr>
+            <a:picLocks noChangeAspect="1"/>
+          </p:cNvPicPr>
+          <p:nvPr/>
+        </p:nvPicPr>
+        <p:blipFill>
+          <a:blip r:embed="rId3"/>
+          <a:stretch>
+            <a:fillRect/>
+          </a:stretch>
+        </p:blipFill>
+        <p:spPr>
+          <a:xfrm>
+            <a:off x="676656" y="3044952"/>
+            <a:ext cx="329184" cy="329184"/>
+          </a:xfrm>
+          <a:prstGeom prst="rect">
+            <a:avLst/>
+          </a:prstGeom>
+        </p:spPr>
+      </p:pic>
+      <p:sp>
+        <p:nvSpPr>
+          <p:cNvPr id="12" name="Text 8"/>
           <p:cNvSpPr txBox="1"/>
           <p:nvPr/>
         </p:nvSpPr>
         <p:spPr>
           <a:xfrm>
-            <a:off x="4617720" y="4480560"/>
-            <a:ext cx="4739335" cy="310896"/>
-          </a:xfrm>
-          <a:prstGeom prst="rect">
-            <a:avLst/>
-          </a:prstGeom>
-          <a:noFill/>
-          <a:ln/>
-        </p:spPr>
-        <p:txBody>
-          <a:bodyPr wrap="square" lIns="0" tIns="0" rIns="0" bIns="0" rtlCol="0" anchor="t"/>
+            <a:off x="1188720" y="2953512"/>
+            <a:ext cx="7985455" cy="512064"/>
+          </a:xfrm>
+          <a:prstGeom prst="rect">
+            <a:avLst/>
+          </a:prstGeom>
+          <a:noFill/>
+          <a:ln/>
+        </p:spPr>
+        <p:txBody>
+          <a:bodyPr wrap="square" lIns="0" tIns="0" rIns="0" bIns="0" rtlCol="0" anchor="ctr"/>
           <a:lstStyle/>
           <a:p>
             <a:pPr indent="0" marL="0">
-              <a:lnSpc>
-                <a:spcPts val="1700"/>
-              </a:lnSpc>
               <a:buNone/>
             </a:pPr>
             <a:r>
@@ -10481,7 +9641,7 @@
                 <a:ea typeface="Arial" pitchFamily="34" charset="-122"/>
                 <a:cs typeface="Arial" pitchFamily="34" charset="-120"/>
               </a:rPr>
-              <a:t>用户每次访问均可查看阶段性进展,降低半途而废的可能性</a:t>
+              <a:t>每日法规监测常态化维护</a:t>
             </a:r>
             <a:endParaRPr lang="en-US" sz="1150" dirty="0"/>
           </a:p>
@@ -10489,7 +9649,447 @@
       </p:sp>
       <p:sp>
         <p:nvSpPr>
-          <p:cNvPr id="15" name="Shape 12"/>
+          <p:cNvPr id="13" name="Shape 9"/>
+          <p:cNvSpPr/>
+          <p:nvPr/>
+        </p:nvSpPr>
+        <p:spPr>
+          <a:xfrm>
+            <a:off x="548640" y="3575304"/>
+            <a:ext cx="8808415" cy="512064"/>
+          </a:xfrm>
+          <a:prstGeom prst="roundRect">
+            <a:avLst>
+              <a:gd name="adj" fmla="val 8036"/>
+            </a:avLst>
+          </a:prstGeom>
+          <a:solidFill>
+            <a:srgbClr val="FFFFFF"/>
+          </a:solidFill>
+          <a:ln w="9525">
+            <a:solidFill>
+              <a:srgbClr val="E8E8E8"/>
+            </a:solidFill>
+            <a:prstDash val="solid"/>
+          </a:ln>
+        </p:spPr>
+      </p:sp>
+      <p:sp>
+        <p:nvSpPr>
+          <p:cNvPr id="14" name="Shape 10"/>
+          <p:cNvSpPr/>
+          <p:nvPr/>
+        </p:nvSpPr>
+        <p:spPr>
+          <a:xfrm>
+            <a:off x="566928" y="3611880"/>
+            <a:ext cx="32004" cy="438912"/>
+          </a:xfrm>
+          <a:prstGeom prst="rect">
+            <a:avLst/>
+          </a:prstGeom>
+          <a:solidFill>
+            <a:srgbClr val="FF6600"/>
+          </a:solidFill>
+          <a:ln/>
+        </p:spPr>
+      </p:sp>
+      <p:pic>
+        <p:nvPicPr>
+          <p:cNvPr id="15" name="Image 2" descr="/tmp/pptx_work/icons/check.png">    </p:cNvPr>
+          <p:cNvPicPr>
+            <a:picLocks noChangeAspect="1"/>
+          </p:cNvPicPr>
+          <p:nvPr/>
+        </p:nvPicPr>
+        <p:blipFill>
+          <a:blip r:embed="rId4"/>
+          <a:stretch>
+            <a:fillRect/>
+          </a:stretch>
+        </p:blipFill>
+        <p:spPr>
+          <a:xfrm>
+            <a:off x="676656" y="3666744"/>
+            <a:ext cx="329184" cy="329184"/>
+          </a:xfrm>
+          <a:prstGeom prst="rect">
+            <a:avLst/>
+          </a:prstGeom>
+        </p:spPr>
+      </p:pic>
+      <p:sp>
+        <p:nvSpPr>
+          <p:cNvPr id="16" name="Text 11"/>
+          <p:cNvSpPr txBox="1"/>
+          <p:nvPr/>
+        </p:nvSpPr>
+        <p:spPr>
+          <a:xfrm>
+            <a:off x="1188720" y="3575304"/>
+            <a:ext cx="7985455" cy="512064"/>
+          </a:xfrm>
+          <a:prstGeom prst="rect">
+            <a:avLst/>
+          </a:prstGeom>
+          <a:noFill/>
+          <a:ln/>
+        </p:spPr>
+        <p:txBody>
+          <a:bodyPr wrap="square" lIns="0" tIns="0" rIns="0" bIns="0" rtlCol="0" anchor="ctr"/>
+          <a:lstStyle/>
+          <a:p>
+            <a:pPr indent="0" marL="0">
+              <a:buNone/>
+            </a:pPr>
+            <a:r>
+              <a:rPr lang="en-US" sz="1150" dirty="0">
+                <a:solidFill>
+                  <a:srgbClr val="363636"/>
+                </a:solidFill>
+                <a:latin typeface="Arial" pitchFamily="34" charset="0"/>
+                <a:ea typeface="Arial" pitchFamily="34" charset="-122"/>
+                <a:cs typeface="Arial" pitchFamily="34" charset="-120"/>
+              </a:rPr>
+              <a:t>E-mark 认证合规工具持续迭代维护</a:t>
+            </a:r>
+            <a:endParaRPr lang="en-US" sz="1150" dirty="0"/>
+          </a:p>
+        </p:txBody>
+      </p:sp>
+      <p:sp>
+        <p:nvSpPr>
+          <p:cNvPr id="17" name="Shape 12"/>
+          <p:cNvSpPr/>
+          <p:nvPr/>
+        </p:nvSpPr>
+        <p:spPr>
+          <a:xfrm>
+            <a:off x="548640" y="4197096"/>
+            <a:ext cx="8808415" cy="512064"/>
+          </a:xfrm>
+          <a:prstGeom prst="roundRect">
+            <a:avLst>
+              <a:gd name="adj" fmla="val 8036"/>
+            </a:avLst>
+          </a:prstGeom>
+          <a:solidFill>
+            <a:srgbClr val="FFFFFF"/>
+          </a:solidFill>
+          <a:ln w="9525">
+            <a:solidFill>
+              <a:srgbClr val="E8E8E8"/>
+            </a:solidFill>
+            <a:prstDash val="solid"/>
+          </a:ln>
+        </p:spPr>
+      </p:sp>
+      <p:sp>
+        <p:nvSpPr>
+          <p:cNvPr id="18" name="Shape 13"/>
+          <p:cNvSpPr/>
+          <p:nvPr/>
+        </p:nvSpPr>
+        <p:spPr>
+          <a:xfrm>
+            <a:off x="566928" y="4233672"/>
+            <a:ext cx="32004" cy="438912"/>
+          </a:xfrm>
+          <a:prstGeom prst="rect">
+            <a:avLst/>
+          </a:prstGeom>
+          <a:solidFill>
+            <a:srgbClr val="FF6600"/>
+          </a:solidFill>
+          <a:ln/>
+        </p:spPr>
+      </p:sp>
+      <p:pic>
+        <p:nvPicPr>
+          <p:cNvPr id="19" name="Image 3" descr="/tmp/pptx_work/icons/check.png">    </p:cNvPr>
+          <p:cNvPicPr>
+            <a:picLocks noChangeAspect="1"/>
+          </p:cNvPicPr>
+          <p:nvPr/>
+        </p:nvPicPr>
+        <p:blipFill>
+          <a:blip r:embed="rId5"/>
+          <a:stretch>
+            <a:fillRect/>
+          </a:stretch>
+        </p:blipFill>
+        <p:spPr>
+          <a:xfrm>
+            <a:off x="676656" y="4288536"/>
+            <a:ext cx="329184" cy="329184"/>
+          </a:xfrm>
+          <a:prstGeom prst="rect">
+            <a:avLst/>
+          </a:prstGeom>
+        </p:spPr>
+      </p:pic>
+      <p:sp>
+        <p:nvSpPr>
+          <p:cNvPr id="20" name="Text 14"/>
+          <p:cNvSpPr txBox="1"/>
+          <p:nvPr/>
+        </p:nvSpPr>
+        <p:spPr>
+          <a:xfrm>
+            <a:off x="1188720" y="4197096"/>
+            <a:ext cx="7985455" cy="512064"/>
+          </a:xfrm>
+          <a:prstGeom prst="rect">
+            <a:avLst/>
+          </a:prstGeom>
+          <a:noFill/>
+          <a:ln/>
+        </p:spPr>
+        <p:txBody>
+          <a:bodyPr wrap="square" lIns="0" tIns="0" rIns="0" bIns="0" rtlCol="0" anchor="ctr"/>
+          <a:lstStyle/>
+          <a:p>
+            <a:pPr indent="0" marL="0">
+              <a:buNone/>
+            </a:pPr>
+            <a:r>
+              <a:rPr lang="en-US" sz="1150" dirty="0">
+                <a:solidFill>
+                  <a:srgbClr val="363636"/>
+                </a:solidFill>
+                <a:latin typeface="Arial" pitchFamily="34" charset="0"/>
+                <a:ea typeface="Arial" pitchFamily="34" charset="-122"/>
+                <a:cs typeface="Arial" pitchFamily="34" charset="-120"/>
+              </a:rPr>
+              <a:t>法规检索客户需求响应与数据交付</a:t>
+            </a:r>
+            <a:endParaRPr lang="en-US" sz="1150" dirty="0"/>
+          </a:p>
+        </p:txBody>
+      </p:sp>
+      <p:sp>
+        <p:nvSpPr>
+          <p:cNvPr id="21" name="Shape 15"/>
+          <p:cNvSpPr/>
+          <p:nvPr/>
+        </p:nvSpPr>
+        <p:spPr>
+          <a:xfrm>
+            <a:off x="548640" y="4818888"/>
+            <a:ext cx="8808415" cy="512064"/>
+          </a:xfrm>
+          <a:prstGeom prst="roundRect">
+            <a:avLst>
+              <a:gd name="adj" fmla="val 8036"/>
+            </a:avLst>
+          </a:prstGeom>
+          <a:solidFill>
+            <a:srgbClr val="FFFFFF"/>
+          </a:solidFill>
+          <a:ln w="9525">
+            <a:solidFill>
+              <a:srgbClr val="E8E8E8"/>
+            </a:solidFill>
+            <a:prstDash val="solid"/>
+          </a:ln>
+        </p:spPr>
+      </p:sp>
+      <p:sp>
+        <p:nvSpPr>
+          <p:cNvPr id="22" name="Shape 16"/>
+          <p:cNvSpPr/>
+          <p:nvPr/>
+        </p:nvSpPr>
+        <p:spPr>
+          <a:xfrm>
+            <a:off x="566928" y="4855464"/>
+            <a:ext cx="32004" cy="438912"/>
+          </a:xfrm>
+          <a:prstGeom prst="rect">
+            <a:avLst/>
+          </a:prstGeom>
+          <a:solidFill>
+            <a:srgbClr val="FF6600"/>
+          </a:solidFill>
+          <a:ln/>
+        </p:spPr>
+      </p:sp>
+      <p:pic>
+        <p:nvPicPr>
+          <p:cNvPr id="23" name="Image 4" descr="/tmp/pptx_work/icons/check.png">    </p:cNvPr>
+          <p:cNvPicPr>
+            <a:picLocks noChangeAspect="1"/>
+          </p:cNvPicPr>
+          <p:nvPr/>
+        </p:nvPicPr>
+        <p:blipFill>
+          <a:blip r:embed="rId6"/>
+          <a:stretch>
+            <a:fillRect/>
+          </a:stretch>
+        </p:blipFill>
+        <p:spPr>
+          <a:xfrm>
+            <a:off x="676656" y="4910328"/>
+            <a:ext cx="329184" cy="329184"/>
+          </a:xfrm>
+          <a:prstGeom prst="rect">
+            <a:avLst/>
+          </a:prstGeom>
+        </p:spPr>
+      </p:pic>
+      <p:sp>
+        <p:nvSpPr>
+          <p:cNvPr id="24" name="Text 17"/>
+          <p:cNvSpPr txBox="1"/>
+          <p:nvPr/>
+        </p:nvSpPr>
+        <p:spPr>
+          <a:xfrm>
+            <a:off x="1188720" y="4818888"/>
+            <a:ext cx="7985455" cy="512064"/>
+          </a:xfrm>
+          <a:prstGeom prst="rect">
+            <a:avLst/>
+          </a:prstGeom>
+          <a:noFill/>
+          <a:ln/>
+        </p:spPr>
+        <p:txBody>
+          <a:bodyPr wrap="square" lIns="0" tIns="0" rIns="0" bIns="0" rtlCol="0" anchor="ctr"/>
+          <a:lstStyle/>
+          <a:p>
+            <a:pPr indent="0" marL="0">
+              <a:buNone/>
+            </a:pPr>
+            <a:r>
+              <a:rPr lang="en-US" sz="1150" dirty="0">
+                <a:solidFill>
+                  <a:srgbClr val="363636"/>
+                </a:solidFill>
+                <a:latin typeface="Arial" pitchFamily="34" charset="0"/>
+                <a:ea typeface="Arial" pitchFamily="34" charset="-122"/>
+                <a:cs typeface="Arial" pitchFamily="34" charset="-120"/>
+              </a:rPr>
+              <a:t>内容营销与客户答疑支持</a:t>
+            </a:r>
+            <a:endParaRPr lang="en-US" sz="1150" dirty="0"/>
+          </a:p>
+        </p:txBody>
+      </p:sp>
+      <p:sp>
+        <p:nvSpPr>
+          <p:cNvPr id="25" name="Shape 18"/>
+          <p:cNvSpPr/>
+          <p:nvPr/>
+        </p:nvSpPr>
+        <p:spPr>
+          <a:xfrm>
+            <a:off x="548640" y="5440680"/>
+            <a:ext cx="8808415" cy="512064"/>
+          </a:xfrm>
+          <a:prstGeom prst="roundRect">
+            <a:avLst>
+              <a:gd name="adj" fmla="val 8036"/>
+            </a:avLst>
+          </a:prstGeom>
+          <a:solidFill>
+            <a:srgbClr val="FFFFFF"/>
+          </a:solidFill>
+          <a:ln w="9525">
+            <a:solidFill>
+              <a:srgbClr val="E8E8E8"/>
+            </a:solidFill>
+            <a:prstDash val="solid"/>
+          </a:ln>
+        </p:spPr>
+      </p:sp>
+      <p:sp>
+        <p:nvSpPr>
+          <p:cNvPr id="26" name="Shape 19"/>
+          <p:cNvSpPr/>
+          <p:nvPr/>
+        </p:nvSpPr>
+        <p:spPr>
+          <a:xfrm>
+            <a:off x="566928" y="5477256"/>
+            <a:ext cx="32004" cy="438912"/>
+          </a:xfrm>
+          <a:prstGeom prst="rect">
+            <a:avLst/>
+          </a:prstGeom>
+          <a:solidFill>
+            <a:srgbClr val="FF6600"/>
+          </a:solidFill>
+          <a:ln/>
+        </p:spPr>
+      </p:sp>
+      <p:pic>
+        <p:nvPicPr>
+          <p:cNvPr id="27" name="Image 5" descr="/tmp/pptx_work/icons/check.png">    </p:cNvPr>
+          <p:cNvPicPr>
+            <a:picLocks noChangeAspect="1"/>
+          </p:cNvPicPr>
+          <p:nvPr/>
+        </p:nvPicPr>
+        <p:blipFill>
+          <a:blip r:embed="rId7"/>
+          <a:stretch>
+            <a:fillRect/>
+          </a:stretch>
+        </p:blipFill>
+        <p:spPr>
+          <a:xfrm>
+            <a:off x="676656" y="5532120"/>
+            <a:ext cx="329184" cy="329184"/>
+          </a:xfrm>
+          <a:prstGeom prst="rect">
+            <a:avLst/>
+          </a:prstGeom>
+        </p:spPr>
+      </p:pic>
+      <p:sp>
+        <p:nvSpPr>
+          <p:cNvPr id="28" name="Text 20"/>
+          <p:cNvSpPr txBox="1"/>
+          <p:nvPr/>
+        </p:nvSpPr>
+        <p:spPr>
+          <a:xfrm>
+            <a:off x="1188720" y="5440680"/>
+            <a:ext cx="7985455" cy="512064"/>
+          </a:xfrm>
+          <a:prstGeom prst="rect">
+            <a:avLst/>
+          </a:prstGeom>
+          <a:noFill/>
+          <a:ln/>
+        </p:spPr>
+        <p:txBody>
+          <a:bodyPr wrap="square" lIns="0" tIns="0" rIns="0" bIns="0" rtlCol="0" anchor="ctr"/>
+          <a:lstStyle/>
+          <a:p>
+            <a:pPr indent="0" marL="0">
+              <a:buNone/>
+            </a:pPr>
+            <a:r>
+              <a:rPr lang="en-US" sz="1150" dirty="0">
+                <a:solidFill>
+                  <a:srgbClr val="363636"/>
+                </a:solidFill>
+                <a:latin typeface="Arial" pitchFamily="34" charset="0"/>
+                <a:ea typeface="Arial" pitchFamily="34" charset="-122"/>
+                <a:cs typeface="Arial" pitchFamily="34" charset="-120"/>
+              </a:rPr>
+              <a:t>汽车制造系列推广文章持续审阅与内容支持</a:t>
+            </a:r>
+            <a:endParaRPr lang="en-US" sz="1150" dirty="0"/>
+          </a:p>
+        </p:txBody>
+      </p:sp>
+      <p:sp>
+        <p:nvSpPr>
+          <p:cNvPr id="29" name="Shape 21"/>
           <p:cNvSpPr/>
           <p:nvPr/>
         </p:nvSpPr>
@@ -10509,7 +10109,7 @@
       </p:sp>
       <p:sp>
         <p:nvSpPr>
-          <p:cNvPr id="16" name="Text 13"/>
+          <p:cNvPr id="30" name="Text 22"/>
           <p:cNvSpPr txBox="1"/>
           <p:nvPr/>
         </p:nvSpPr>
@@ -10540,1001 +10140,7 @@
                 <a:ea typeface="Arial" pitchFamily="34" charset="-122"/>
                 <a:cs typeface="Arial" pitchFamily="34" charset="-120"/>
               </a:rPr>
-              <a:t>7/10</a:t>
-            </a:r>
-            <a:endParaRPr lang="en-US" sz="900" dirty="0"/>
-          </a:p>
-        </p:txBody>
-      </p:sp>
-    </p:spTree>
-  </p:cSld>
-  <p:clrMapOvr>
-    <a:masterClrMapping/>
-  </p:clrMapOvr>
-</p:sld>
-</file>
-
-<file path=ppt/slides/slide8.xml><?xml version="1.0" encoding="utf-8"?>
-<p:sld xmlns:a="http://schemas.openxmlformats.org/drawingml/2006/main" xmlns:r="http://schemas.openxmlformats.org/officeDocument/2006/relationships" xmlns:p="http://schemas.openxmlformats.org/presentationml/2006/main">
-  <p:cSld name="Slide 8">
-    <p:bg>
-      <p:bgPr>
-        <a:blipFill dpi="0" rotWithShape="1">
-          <a:blip r:embed="rId1">
-            <a:lum/>
-          </a:blip>
-          <a:srcRect/>
-          <a:stretch>
-            <a:fillRect/>
-          </a:stretch>
-        </a:blipFill>
-        <a:effectLst/>
-      </p:bgPr>
-    </p:bg>
-    <p:spTree>
-      <p:nvGrpSpPr>
-        <p:cNvPr id="1" name=""/>
-        <p:cNvGrpSpPr/>
-        <p:nvPr/>
-      </p:nvGrpSpPr>
-      <p:grpSpPr>
-        <a:xfrm>
-          <a:off x="0" y="0"/>
-          <a:ext cx="0" cy="0"/>
-          <a:chOff x="0" y="0"/>
-          <a:chExt cx="0" cy="0"/>
-        </a:xfrm>
-      </p:grpSpPr>
-      <p:sp>
-        <p:nvSpPr>
-          <p:cNvPr id="2" name="Text 0"/>
-          <p:cNvSpPr txBox="1"/>
-          <p:nvPr/>
-        </p:nvSpPr>
-        <p:spPr>
-          <a:xfrm>
-            <a:off x="548640" y="1691640"/>
-            <a:ext cx="8808415" cy="256032"/>
-          </a:xfrm>
-          <a:prstGeom prst="rect">
-            <a:avLst/>
-          </a:prstGeom>
-          <a:noFill/>
-          <a:ln/>
-        </p:spPr>
-        <p:txBody>
-          <a:bodyPr wrap="square" lIns="0" tIns="0" rIns="0" bIns="0" rtlCol="0" anchor="ctr"/>
-          <a:lstStyle/>
-          <a:p>
-            <a:pPr indent="0" marL="0">
-              <a:buNone/>
-            </a:pPr>
-            <a:r>
-              <a:rPr lang="en-US" sz="1050" spc="100" kern="0" dirty="0">
-                <a:solidFill>
-                  <a:srgbClr val="848685"/>
-                </a:solidFill>
-                <a:latin typeface="Arial" pitchFamily="34" charset="0"/>
-                <a:ea typeface="Arial" pitchFamily="34" charset="-122"/>
-                <a:cs typeface="Arial" pitchFamily="34" charset="-120"/>
-              </a:rPr>
-              <a:t>第二部分 · 非项目情况 · 工具亮点</a:t>
-            </a:r>
-            <a:endParaRPr lang="en-US" sz="1050" dirty="0"/>
-          </a:p>
-        </p:txBody>
-      </p:sp>
-      <p:sp>
-        <p:nvSpPr>
-          <p:cNvPr id="3" name="Text 1"/>
-          <p:cNvSpPr txBox="1"/>
-          <p:nvPr/>
-        </p:nvSpPr>
-        <p:spPr>
-          <a:xfrm>
-            <a:off x="548640" y="1947672"/>
-            <a:ext cx="8808415" cy="347472"/>
-          </a:xfrm>
-          <a:prstGeom prst="rect">
-            <a:avLst/>
-          </a:prstGeom>
-          <a:noFill/>
-          <a:ln/>
-        </p:spPr>
-        <p:txBody>
-          <a:bodyPr wrap="square" lIns="0" tIns="0" rIns="0" bIns="0" rtlCol="0" anchor="ctr"/>
-          <a:lstStyle/>
-          <a:p>
-            <a:pPr indent="0" marL="0">
-              <a:buNone/>
-            </a:pPr>
-            <a:r>
-              <a:rPr lang="en-US" sz="1900" b="1" dirty="0">
-                <a:solidFill>
-                  <a:srgbClr val="363636"/>
-                </a:solidFill>
-                <a:latin typeface="Georgia" pitchFamily="34" charset="0"/>
-                <a:ea typeface="Georgia" pitchFamily="34" charset="-122"/>
-                <a:cs typeface="Georgia" pitchFamily="34" charset="-120"/>
-              </a:rPr>
-              <a:t>合规成熟度量化评分</a:t>
-            </a:r>
-            <a:endParaRPr lang="en-US" sz="1900" dirty="0"/>
-          </a:p>
-        </p:txBody>
-      </p:sp>
-      <p:sp>
-        <p:nvSpPr>
-          <p:cNvPr id="4" name="Shape 2"/>
-          <p:cNvSpPr/>
-          <p:nvPr/>
-        </p:nvSpPr>
-        <p:spPr>
-          <a:xfrm>
-            <a:off x="548640" y="2286000"/>
-            <a:ext cx="1097280" cy="0"/>
-          </a:xfrm>
-          <a:prstGeom prst="line">
-            <a:avLst/>
-          </a:prstGeom>
-          <a:noFill/>
-          <a:ln w="31750">
-            <a:solidFill>
-              <a:srgbClr val="FF6600"/>
-            </a:solidFill>
-            <a:prstDash val="solid"/>
-          </a:ln>
-        </p:spPr>
-      </p:sp>
-      <p:sp>
-        <p:nvSpPr>
-          <p:cNvPr id="5" name="Shape 3"/>
-          <p:cNvSpPr/>
-          <p:nvPr/>
-        </p:nvSpPr>
-        <p:spPr>
-          <a:xfrm>
-            <a:off x="548640" y="2459736"/>
-            <a:ext cx="3364992" cy="4174236"/>
-          </a:xfrm>
-          <a:prstGeom prst="roundRect">
-            <a:avLst>
-              <a:gd name="adj" fmla="val 1630"/>
-            </a:avLst>
-          </a:prstGeom>
-          <a:solidFill>
-            <a:srgbClr val="FFFFFF"/>
-          </a:solidFill>
-          <a:ln w="9525">
-            <a:solidFill>
-              <a:srgbClr val="E8E8E8"/>
-            </a:solidFill>
-            <a:prstDash val="solid"/>
-          </a:ln>
-        </p:spPr>
-      </p:sp>
-      <p:sp>
-        <p:nvSpPr>
-          <p:cNvPr id="6" name="Shape 4"/>
-          <p:cNvSpPr/>
-          <p:nvPr/>
-        </p:nvSpPr>
-        <p:spPr>
-          <a:xfrm>
-            <a:off x="548640" y="2459736"/>
-            <a:ext cx="3364992" cy="45720"/>
-          </a:xfrm>
-          <a:prstGeom prst="rect">
-            <a:avLst/>
-          </a:prstGeom>
-          <a:solidFill>
-            <a:srgbClr val="FF6600"/>
-          </a:solidFill>
-          <a:ln/>
-        </p:spPr>
-      </p:sp>
-      <p:pic>
-        <p:nvPicPr>
-          <p:cNvPr id="7" name="Image 0" descr="/tmp/pptx_work/screenshots/u3_maturity.png">    </p:cNvPr>
-          <p:cNvPicPr>
-            <a:picLocks noChangeAspect="1"/>
-          </p:cNvPicPr>
-          <p:nvPr/>
-        </p:nvPicPr>
-        <p:blipFill>
-          <a:blip r:embed="rId2"/>
-          <a:stretch>
-            <a:fillRect/>
-          </a:stretch>
-        </p:blipFill>
-        <p:spPr>
-          <a:xfrm>
-            <a:off x="676656" y="2587752"/>
-            <a:ext cx="3108960" cy="3918204"/>
-          </a:xfrm>
-          <a:prstGeom prst="rect">
-            <a:avLst/>
-          </a:prstGeom>
-        </p:spPr>
-      </p:pic>
-      <p:sp>
-        <p:nvSpPr>
-          <p:cNvPr id="8" name="Shape 5"/>
-          <p:cNvSpPr/>
-          <p:nvPr/>
-        </p:nvSpPr>
-        <p:spPr>
-          <a:xfrm>
-            <a:off x="4279392" y="2514600"/>
-            <a:ext cx="1188720" cy="274320"/>
-          </a:xfrm>
-          <a:prstGeom prst="roundRect">
-            <a:avLst>
-              <a:gd name="adj" fmla="val 50000"/>
-            </a:avLst>
-          </a:prstGeom>
-          <a:solidFill>
-            <a:srgbClr val="FFF1E8"/>
-          </a:solidFill>
-          <a:ln/>
-        </p:spPr>
-      </p:sp>
-      <p:sp>
-        <p:nvSpPr>
-          <p:cNvPr id="9" name="Text 6"/>
-          <p:cNvSpPr txBox="1"/>
-          <p:nvPr/>
-        </p:nvSpPr>
-        <p:spPr>
-          <a:xfrm>
-            <a:off x="4279392" y="2514600"/>
-            <a:ext cx="1188720" cy="274320"/>
-          </a:xfrm>
-          <a:prstGeom prst="rect">
-            <a:avLst/>
-          </a:prstGeom>
-          <a:noFill/>
-          <a:ln/>
-        </p:spPr>
-        <p:txBody>
-          <a:bodyPr wrap="square" lIns="0" tIns="0" rIns="0" bIns="0" rtlCol="0" anchor="ctr"/>
-          <a:lstStyle/>
-          <a:p>
-            <a:pPr algn="ctr" indent="0" marL="0">
-              <a:buNone/>
-            </a:pPr>
-            <a:r>
-              <a:rPr lang="en-US" sz="1000" b="1" dirty="0">
-                <a:solidFill>
-                  <a:srgbClr val="FF6600"/>
-                </a:solidFill>
-                <a:latin typeface="Arial" pitchFamily="34" charset="0"/>
-                <a:ea typeface="Arial" pitchFamily="34" charset="-122"/>
-                <a:cs typeface="Arial" pitchFamily="34" charset="-120"/>
-              </a:rPr>
-              <a:t>亮点③</a:t>
-            </a:r>
-            <a:endParaRPr lang="en-US" sz="1000" dirty="0"/>
-          </a:p>
-        </p:txBody>
-      </p:sp>
-      <p:sp>
-        <p:nvSpPr>
-          <p:cNvPr id="10" name="Text 7"/>
-          <p:cNvSpPr txBox="1"/>
-          <p:nvPr/>
-        </p:nvSpPr>
-        <p:spPr>
-          <a:xfrm>
-            <a:off x="4279392" y="2953512"/>
-            <a:ext cx="5077663" cy="1051560"/>
-          </a:xfrm>
-          <a:prstGeom prst="rect">
-            <a:avLst/>
-          </a:prstGeom>
-          <a:noFill/>
-          <a:ln/>
-        </p:spPr>
-        <p:txBody>
-          <a:bodyPr wrap="square" lIns="0" tIns="0" rIns="0" bIns="0" rtlCol="0" anchor="t"/>
-          <a:lstStyle/>
-          <a:p>
-            <a:pPr indent="0" marL="0">
-              <a:lnSpc>
-                <a:spcPts val="1900"/>
-              </a:lnSpc>
-              <a:buNone/>
-            </a:pPr>
-            <a:r>
-              <a:rPr lang="en-US" sz="1350" b="1" dirty="0">
-                <a:solidFill>
-                  <a:srgbClr val="363636"/>
-                </a:solidFill>
-                <a:latin typeface="Arial" pitchFamily="34" charset="0"/>
-                <a:ea typeface="Arial" pitchFamily="34" charset="-122"/>
-                <a:cs typeface="Arial" pitchFamily="34" charset="-120"/>
-              </a:rPr>
-              <a:t>法规完成度与体系成熟度双轴打分,自动定位所在象限(如「初始」),并给出风险研判与优先建议。</a:t>
-            </a:r>
-            <a:endParaRPr lang="en-US" sz="1350" dirty="0"/>
-          </a:p>
-        </p:txBody>
-      </p:sp>
-      <p:sp>
-        <p:nvSpPr>
-          <p:cNvPr id="11" name="Shape 8"/>
-          <p:cNvSpPr/>
-          <p:nvPr/>
-        </p:nvSpPr>
-        <p:spPr>
-          <a:xfrm>
-            <a:off x="4297680" y="4160520"/>
-            <a:ext cx="64008" cy="64008"/>
-          </a:xfrm>
-          <a:prstGeom prst="ellipse">
-            <a:avLst/>
-          </a:prstGeom>
-          <a:solidFill>
-            <a:srgbClr val="FF6600"/>
-          </a:solidFill>
-          <a:ln/>
-        </p:spPr>
-      </p:sp>
-      <p:sp>
-        <p:nvSpPr>
-          <p:cNvPr id="12" name="Text 9"/>
-          <p:cNvSpPr txBox="1"/>
-          <p:nvPr/>
-        </p:nvSpPr>
-        <p:spPr>
-          <a:xfrm>
-            <a:off x="4480560" y="4059936"/>
-            <a:ext cx="4876495" cy="310896"/>
-          </a:xfrm>
-          <a:prstGeom prst="rect">
-            <a:avLst/>
-          </a:prstGeom>
-          <a:noFill/>
-          <a:ln/>
-        </p:spPr>
-        <p:txBody>
-          <a:bodyPr wrap="square" lIns="0" tIns="0" rIns="0" bIns="0" rtlCol="0" anchor="t"/>
-          <a:lstStyle/>
-          <a:p>
-            <a:pPr indent="0" marL="0">
-              <a:lnSpc>
-                <a:spcPts val="1700"/>
-              </a:lnSpc>
-              <a:buNone/>
-            </a:pPr>
-            <a:r>
-              <a:rPr lang="en-US" sz="1150" dirty="0">
-                <a:solidFill>
-                  <a:srgbClr val="363636"/>
-                </a:solidFill>
-                <a:latin typeface="Arial" pitchFamily="34" charset="0"/>
-                <a:ea typeface="Arial" pitchFamily="34" charset="-122"/>
-                <a:cs typeface="Arial" pitchFamily="34" charset="-120"/>
-              </a:rPr>
-              <a:t>评分随认证推进动态更新,形成复测与持续跟踪的内在驱动</a:t>
-            </a:r>
-            <a:endParaRPr lang="en-US" sz="1150" dirty="0"/>
-          </a:p>
-        </p:txBody>
-      </p:sp>
-      <p:sp>
-        <p:nvSpPr>
-          <p:cNvPr id="13" name="Shape 10"/>
-          <p:cNvSpPr/>
-          <p:nvPr/>
-        </p:nvSpPr>
-        <p:spPr>
-          <a:xfrm>
-            <a:off x="4297680" y="4581144"/>
-            <a:ext cx="64008" cy="64008"/>
-          </a:xfrm>
-          <a:prstGeom prst="ellipse">
-            <a:avLst/>
-          </a:prstGeom>
-          <a:solidFill>
-            <a:srgbClr val="FF6600"/>
-          </a:solidFill>
-          <a:ln/>
-        </p:spPr>
-      </p:sp>
-      <p:sp>
-        <p:nvSpPr>
-          <p:cNvPr id="14" name="Text 11"/>
-          <p:cNvSpPr txBox="1"/>
-          <p:nvPr/>
-        </p:nvSpPr>
-        <p:spPr>
-          <a:xfrm>
-            <a:off x="4480560" y="4480560"/>
-            <a:ext cx="4876495" cy="310896"/>
-          </a:xfrm>
-          <a:prstGeom prst="rect">
-            <a:avLst/>
-          </a:prstGeom>
-          <a:noFill/>
-          <a:ln/>
-        </p:spPr>
-        <p:txBody>
-          <a:bodyPr wrap="square" lIns="0" tIns="0" rIns="0" bIns="0" rtlCol="0" anchor="t"/>
-          <a:lstStyle/>
-          <a:p>
-            <a:pPr indent="0" marL="0">
-              <a:lnSpc>
-                <a:spcPts val="1700"/>
-              </a:lnSpc>
-              <a:buNone/>
-            </a:pPr>
-            <a:r>
-              <a:rPr lang="en-US" sz="1150" dirty="0">
-                <a:solidFill>
-                  <a:srgbClr val="363636"/>
-                </a:solidFill>
-                <a:latin typeface="Arial" pitchFamily="34" charset="0"/>
-                <a:ea typeface="Arial" pitchFamily="34" charset="-122"/>
-                <a:cs typeface="Arial" pitchFamily="34" charset="-120"/>
-              </a:rPr>
-              <a:t>0–100 统一量表,便于企业自我对比及同行参照</a:t>
-            </a:r>
-            <a:endParaRPr lang="en-US" sz="1150" dirty="0"/>
-          </a:p>
-        </p:txBody>
-      </p:sp>
-      <p:sp>
-        <p:nvSpPr>
-          <p:cNvPr id="15" name="Shape 12"/>
-          <p:cNvSpPr/>
-          <p:nvPr/>
-        </p:nvSpPr>
-        <p:spPr>
-          <a:xfrm>
-            <a:off x="0" y="6803136"/>
-            <a:ext cx="9905695" cy="54864"/>
-          </a:xfrm>
-          <a:prstGeom prst="rect">
-            <a:avLst/>
-          </a:prstGeom>
-          <a:solidFill>
-            <a:srgbClr val="FF6600"/>
-          </a:solidFill>
-          <a:ln/>
-        </p:spPr>
-      </p:sp>
-      <p:sp>
-        <p:nvSpPr>
-          <p:cNvPr id="16" name="Text 13"/>
-          <p:cNvSpPr txBox="1"/>
-          <p:nvPr/>
-        </p:nvSpPr>
-        <p:spPr>
-          <a:xfrm>
-            <a:off x="8991295" y="6510528"/>
-            <a:ext cx="731520" cy="256032"/>
-          </a:xfrm>
-          <a:prstGeom prst="rect">
-            <a:avLst/>
-          </a:prstGeom>
-          <a:noFill/>
-          <a:ln/>
-        </p:spPr>
-        <p:txBody>
-          <a:bodyPr wrap="square" lIns="0" tIns="0" rIns="0" bIns="0" rtlCol="0" anchor="ctr"/>
-          <a:lstStyle/>
-          <a:p>
-            <a:pPr algn="r" indent="0" marL="0">
-              <a:buNone/>
-            </a:pPr>
-            <a:r>
-              <a:rPr lang="en-US" sz="900" dirty="0">
-                <a:solidFill>
-                  <a:srgbClr val="848685"/>
-                </a:solidFill>
-                <a:latin typeface="Arial" pitchFamily="34" charset="0"/>
-                <a:ea typeface="Arial" pitchFamily="34" charset="-122"/>
-                <a:cs typeface="Arial" pitchFamily="34" charset="-120"/>
-              </a:rPr>
-              <a:t>8/10</a:t>
-            </a:r>
-            <a:endParaRPr lang="en-US" sz="900" dirty="0"/>
-          </a:p>
-        </p:txBody>
-      </p:sp>
-    </p:spTree>
-  </p:cSld>
-  <p:clrMapOvr>
-    <a:masterClrMapping/>
-  </p:clrMapOvr>
-</p:sld>
-</file>
-
-<file path=ppt/slides/slide9.xml><?xml version="1.0" encoding="utf-8"?>
-<p:sld xmlns:a="http://schemas.openxmlformats.org/drawingml/2006/main" xmlns:r="http://schemas.openxmlformats.org/officeDocument/2006/relationships" xmlns:p="http://schemas.openxmlformats.org/presentationml/2006/main">
-  <p:cSld name="Slide 9">
-    <p:bg>
-      <p:bgPr>
-        <a:blipFill dpi="0" rotWithShape="1">
-          <a:blip r:embed="rId1">
-            <a:lum/>
-          </a:blip>
-          <a:srcRect/>
-          <a:stretch>
-            <a:fillRect/>
-          </a:stretch>
-        </a:blipFill>
-        <a:effectLst/>
-      </p:bgPr>
-    </p:bg>
-    <p:spTree>
-      <p:nvGrpSpPr>
-        <p:cNvPr id="1" name=""/>
-        <p:cNvGrpSpPr/>
-        <p:nvPr/>
-      </p:nvGrpSpPr>
-      <p:grpSpPr>
-        <a:xfrm>
-          <a:off x="0" y="0"/>
-          <a:ext cx="0" cy="0"/>
-          <a:chOff x="0" y="0"/>
-          <a:chExt cx="0" cy="0"/>
-        </a:xfrm>
-      </p:grpSpPr>
-      <p:sp>
-        <p:nvSpPr>
-          <p:cNvPr id="2" name="Text 0"/>
-          <p:cNvSpPr txBox="1"/>
-          <p:nvPr/>
-        </p:nvSpPr>
-        <p:spPr>
-          <a:xfrm>
-            <a:off x="548640" y="1691640"/>
-            <a:ext cx="8808415" cy="256032"/>
-          </a:xfrm>
-          <a:prstGeom prst="rect">
-            <a:avLst/>
-          </a:prstGeom>
-          <a:noFill/>
-          <a:ln/>
-        </p:spPr>
-        <p:txBody>
-          <a:bodyPr wrap="square" lIns="0" tIns="0" rIns="0" bIns="0" rtlCol="0" anchor="ctr"/>
-          <a:lstStyle/>
-          <a:p>
-            <a:pPr indent="0" marL="0">
-              <a:buNone/>
-            </a:pPr>
-            <a:r>
-              <a:rPr lang="en-US" sz="1050" spc="100" kern="0" dirty="0">
-                <a:solidFill>
-                  <a:srgbClr val="848685"/>
-                </a:solidFill>
-                <a:latin typeface="Arial" pitchFamily="34" charset="0"/>
-                <a:ea typeface="Arial" pitchFamily="34" charset="-122"/>
-                <a:cs typeface="Arial" pitchFamily="34" charset="-120"/>
-              </a:rPr>
-              <a:t>第二部分 · 非项目情况 · 工具亮点</a:t>
-            </a:r>
-            <a:endParaRPr lang="en-US" sz="1050" dirty="0"/>
-          </a:p>
-        </p:txBody>
-      </p:sp>
-      <p:sp>
-        <p:nvSpPr>
-          <p:cNvPr id="3" name="Text 1"/>
-          <p:cNvSpPr txBox="1"/>
-          <p:nvPr/>
-        </p:nvSpPr>
-        <p:spPr>
-          <a:xfrm>
-            <a:off x="548640" y="1947672"/>
-            <a:ext cx="8808415" cy="347472"/>
-          </a:xfrm>
-          <a:prstGeom prst="rect">
-            <a:avLst/>
-          </a:prstGeom>
-          <a:noFill/>
-          <a:ln/>
-        </p:spPr>
-        <p:txBody>
-          <a:bodyPr wrap="square" lIns="0" tIns="0" rIns="0" bIns="0" rtlCol="0" anchor="ctr"/>
-          <a:lstStyle/>
-          <a:p>
-            <a:pPr indent="0" marL="0">
-              <a:buNone/>
-            </a:pPr>
-            <a:r>
-              <a:rPr lang="en-US" sz="1900" b="1" dirty="0">
-                <a:solidFill>
-                  <a:srgbClr val="363636"/>
-                </a:solidFill>
-                <a:latin typeface="Georgia" pitchFamily="34" charset="0"/>
-                <a:ea typeface="Georgia" pitchFamily="34" charset="-122"/>
-                <a:cs typeface="Georgia" pitchFamily="34" charset="-120"/>
-              </a:rPr>
-              <a:t>缺口分级与服务映射</a:t>
-            </a:r>
-            <a:endParaRPr lang="en-US" sz="1900" dirty="0"/>
-          </a:p>
-        </p:txBody>
-      </p:sp>
-      <p:sp>
-        <p:nvSpPr>
-          <p:cNvPr id="4" name="Shape 2"/>
-          <p:cNvSpPr/>
-          <p:nvPr/>
-        </p:nvSpPr>
-        <p:spPr>
-          <a:xfrm>
-            <a:off x="548640" y="2286000"/>
-            <a:ext cx="1097280" cy="0"/>
-          </a:xfrm>
-          <a:prstGeom prst="line">
-            <a:avLst/>
-          </a:prstGeom>
-          <a:noFill/>
-          <a:ln w="31750">
-            <a:solidFill>
-              <a:srgbClr val="FF6600"/>
-            </a:solidFill>
-            <a:prstDash val="solid"/>
-          </a:ln>
-        </p:spPr>
-      </p:sp>
-      <p:sp>
-        <p:nvSpPr>
-          <p:cNvPr id="5" name="Shape 3"/>
-          <p:cNvSpPr/>
-          <p:nvPr/>
-        </p:nvSpPr>
-        <p:spPr>
-          <a:xfrm>
-            <a:off x="548640" y="2459736"/>
-            <a:ext cx="4736592" cy="3730523"/>
-          </a:xfrm>
-          <a:prstGeom prst="roundRect">
-            <a:avLst>
-              <a:gd name="adj" fmla="val 1471"/>
-            </a:avLst>
-          </a:prstGeom>
-          <a:solidFill>
-            <a:srgbClr val="FFFFFF"/>
-          </a:solidFill>
-          <a:ln w="9525">
-            <a:solidFill>
-              <a:srgbClr val="E8E8E8"/>
-            </a:solidFill>
-            <a:prstDash val="solid"/>
-          </a:ln>
-        </p:spPr>
-      </p:sp>
-      <p:sp>
-        <p:nvSpPr>
-          <p:cNvPr id="6" name="Shape 4"/>
-          <p:cNvSpPr/>
-          <p:nvPr/>
-        </p:nvSpPr>
-        <p:spPr>
-          <a:xfrm>
-            <a:off x="548640" y="2459736"/>
-            <a:ext cx="4736592" cy="45720"/>
-          </a:xfrm>
-          <a:prstGeom prst="rect">
-            <a:avLst/>
-          </a:prstGeom>
-          <a:solidFill>
-            <a:srgbClr val="FF6600"/>
-          </a:solidFill>
-          <a:ln/>
-        </p:spPr>
-      </p:sp>
-      <p:pic>
-        <p:nvPicPr>
-          <p:cNvPr id="7" name="Image 0" descr="/tmp/pptx_work/screenshots/u4_gaptable.png">    </p:cNvPr>
-          <p:cNvPicPr>
-            <a:picLocks noChangeAspect="1"/>
-          </p:cNvPicPr>
-          <p:nvPr/>
-        </p:nvPicPr>
-        <p:blipFill>
-          <a:blip r:embed="rId2"/>
-          <a:stretch>
-            <a:fillRect/>
-          </a:stretch>
-        </p:blipFill>
-        <p:spPr>
-          <a:xfrm>
-            <a:off x="676656" y="2587752"/>
-            <a:ext cx="4480560" cy="3474491"/>
-          </a:xfrm>
-          <a:prstGeom prst="rect">
-            <a:avLst/>
-          </a:prstGeom>
-        </p:spPr>
-      </p:pic>
-      <p:sp>
-        <p:nvSpPr>
-          <p:cNvPr id="8" name="Shape 5"/>
-          <p:cNvSpPr/>
-          <p:nvPr/>
-        </p:nvSpPr>
-        <p:spPr>
-          <a:xfrm>
-            <a:off x="5650992" y="2514600"/>
-            <a:ext cx="1188720" cy="274320"/>
-          </a:xfrm>
-          <a:prstGeom prst="roundRect">
-            <a:avLst>
-              <a:gd name="adj" fmla="val 50000"/>
-            </a:avLst>
-          </a:prstGeom>
-          <a:solidFill>
-            <a:srgbClr val="FFF1E8"/>
-          </a:solidFill>
-          <a:ln/>
-        </p:spPr>
-      </p:sp>
-      <p:sp>
-        <p:nvSpPr>
-          <p:cNvPr id="9" name="Text 6"/>
-          <p:cNvSpPr txBox="1"/>
-          <p:nvPr/>
-        </p:nvSpPr>
-        <p:spPr>
-          <a:xfrm>
-            <a:off x="5650992" y="2514600"/>
-            <a:ext cx="1188720" cy="274320"/>
-          </a:xfrm>
-          <a:prstGeom prst="rect">
-            <a:avLst/>
-          </a:prstGeom>
-          <a:noFill/>
-          <a:ln/>
-        </p:spPr>
-        <p:txBody>
-          <a:bodyPr wrap="square" lIns="0" tIns="0" rIns="0" bIns="0" rtlCol="0" anchor="ctr"/>
-          <a:lstStyle/>
-          <a:p>
-            <a:pPr algn="ctr" indent="0" marL="0">
-              <a:buNone/>
-            </a:pPr>
-            <a:r>
-              <a:rPr lang="en-US" sz="1000" b="1" dirty="0">
-                <a:solidFill>
-                  <a:srgbClr val="FF6600"/>
-                </a:solidFill>
-                <a:latin typeface="Arial" pitchFamily="34" charset="0"/>
-                <a:ea typeface="Arial" pitchFamily="34" charset="-122"/>
-                <a:cs typeface="Arial" pitchFamily="34" charset="-120"/>
-              </a:rPr>
-              <a:t>亮点④</a:t>
-            </a:r>
-            <a:endParaRPr lang="en-US" sz="1000" dirty="0"/>
-          </a:p>
-        </p:txBody>
-      </p:sp>
-      <p:sp>
-        <p:nvSpPr>
-          <p:cNvPr id="10" name="Text 7"/>
-          <p:cNvSpPr txBox="1"/>
-          <p:nvPr/>
-        </p:nvSpPr>
-        <p:spPr>
-          <a:xfrm>
-            <a:off x="5650992" y="2953512"/>
-            <a:ext cx="3706063" cy="1051560"/>
-          </a:xfrm>
-          <a:prstGeom prst="rect">
-            <a:avLst/>
-          </a:prstGeom>
-          <a:noFill/>
-          <a:ln/>
-        </p:spPr>
-        <p:txBody>
-          <a:bodyPr wrap="square" lIns="0" tIns="0" rIns="0" bIns="0" rtlCol="0" anchor="t"/>
-          <a:lstStyle/>
-          <a:p>
-            <a:pPr indent="0" marL="0">
-              <a:lnSpc>
-                <a:spcPts val="1900"/>
-              </a:lnSpc>
-              <a:buNone/>
-            </a:pPr>
-            <a:r>
-              <a:rPr lang="en-US" sz="1350" b="1" dirty="0">
-                <a:solidFill>
-                  <a:srgbClr val="363636"/>
-                </a:solidFill>
-                <a:latin typeface="Arial" pitchFamily="34" charset="0"/>
-                <a:ea typeface="Arial" pitchFamily="34" charset="-122"/>
-                <a:cs typeface="Arial" pitchFamily="34" charset="-120"/>
-              </a:rPr>
-              <a:t>行动清单按「高/中」风险等级排序待办事项,每条缺口均对应具体的建议行动与支持服务。</a:t>
-            </a:r>
-            <a:endParaRPr lang="en-US" sz="1350" dirty="0"/>
-          </a:p>
-        </p:txBody>
-      </p:sp>
-      <p:sp>
-        <p:nvSpPr>
-          <p:cNvPr id="11" name="Shape 8"/>
-          <p:cNvSpPr/>
-          <p:nvPr/>
-        </p:nvSpPr>
-        <p:spPr>
-          <a:xfrm>
-            <a:off x="5669280" y="4160520"/>
-            <a:ext cx="64008" cy="64008"/>
-          </a:xfrm>
-          <a:prstGeom prst="ellipse">
-            <a:avLst/>
-          </a:prstGeom>
-          <a:solidFill>
-            <a:srgbClr val="FF6600"/>
-          </a:solidFill>
-          <a:ln/>
-        </p:spPr>
-      </p:sp>
-      <p:sp>
-        <p:nvSpPr>
-          <p:cNvPr id="12" name="Text 9"/>
-          <p:cNvSpPr txBox="1"/>
-          <p:nvPr/>
-        </p:nvSpPr>
-        <p:spPr>
-          <a:xfrm>
-            <a:off x="5852160" y="4059936"/>
-            <a:ext cx="3504895" cy="530352"/>
-          </a:xfrm>
-          <a:prstGeom prst="rect">
-            <a:avLst/>
-          </a:prstGeom>
-          <a:noFill/>
-          <a:ln/>
-        </p:spPr>
-        <p:txBody>
-          <a:bodyPr wrap="square" lIns="0" tIns="0" rIns="0" bIns="0" rtlCol="0" anchor="t"/>
-          <a:lstStyle/>
-          <a:p>
-            <a:pPr indent="0" marL="0">
-              <a:lnSpc>
-                <a:spcPts val="1700"/>
-              </a:lnSpc>
-              <a:buNone/>
-            </a:pPr>
-            <a:r>
-              <a:rPr lang="en-US" sz="1150" dirty="0">
-                <a:solidFill>
-                  <a:srgbClr val="363636"/>
-                </a:solidFill>
-                <a:latin typeface="Arial" pitchFamily="34" charset="0"/>
-                <a:ea typeface="Arial" pitchFamily="34" charset="-122"/>
-                <a:cs typeface="Arial" pitchFamily="34" charset="-120"/>
-              </a:rPr>
-              <a:t>评估结果直接转化为服务需求线索,评估颗粒度越细,识别的服务机会越多</a:t>
-            </a:r>
-            <a:endParaRPr lang="en-US" sz="1150" dirty="0"/>
-          </a:p>
-        </p:txBody>
-      </p:sp>
-      <p:sp>
-        <p:nvSpPr>
-          <p:cNvPr id="13" name="Shape 10"/>
-          <p:cNvSpPr/>
-          <p:nvPr/>
-        </p:nvSpPr>
-        <p:spPr>
-          <a:xfrm>
-            <a:off x="5669280" y="4800600"/>
-            <a:ext cx="64008" cy="64008"/>
-          </a:xfrm>
-          <a:prstGeom prst="ellipse">
-            <a:avLst/>
-          </a:prstGeom>
-          <a:solidFill>
-            <a:srgbClr val="FF6600"/>
-          </a:solidFill>
-          <a:ln/>
-        </p:spPr>
-      </p:sp>
-      <p:sp>
-        <p:nvSpPr>
-          <p:cNvPr id="14" name="Text 11"/>
-          <p:cNvSpPr txBox="1"/>
-          <p:nvPr/>
-        </p:nvSpPr>
-        <p:spPr>
-          <a:xfrm>
-            <a:off x="5852160" y="4700016"/>
-            <a:ext cx="3504895" cy="310896"/>
-          </a:xfrm>
-          <a:prstGeom prst="rect">
-            <a:avLst/>
-          </a:prstGeom>
-          <a:noFill/>
-          <a:ln/>
-        </p:spPr>
-        <p:txBody>
-          <a:bodyPr wrap="square" lIns="0" tIns="0" rIns="0" bIns="0" rtlCol="0" anchor="t"/>
-          <a:lstStyle/>
-          <a:p>
-            <a:pPr indent="0" marL="0">
-              <a:lnSpc>
-                <a:spcPts val="1700"/>
-              </a:lnSpc>
-              <a:buNone/>
-            </a:pPr>
-            <a:r>
-              <a:rPr lang="en-US" sz="1150" dirty="0">
-                <a:solidFill>
-                  <a:srgbClr val="363636"/>
-                </a:solidFill>
-                <a:latin typeface="Arial" pitchFamily="34" charset="0"/>
-                <a:ea typeface="Arial" pitchFamily="34" charset="-122"/>
-                <a:cs typeface="Arial" pitchFamily="34" charset="-120"/>
-              </a:rPr>
-              <a:t>高风险项优先展示,引导用户优先处理并对接相应服务</a:t>
-            </a:r>
-            <a:endParaRPr lang="en-US" sz="1150" dirty="0"/>
-          </a:p>
-        </p:txBody>
-      </p:sp>
-      <p:sp>
-        <p:nvSpPr>
-          <p:cNvPr id="15" name="Shape 12"/>
-          <p:cNvSpPr/>
-          <p:nvPr/>
-        </p:nvSpPr>
-        <p:spPr>
-          <a:xfrm>
-            <a:off x="0" y="6803136"/>
-            <a:ext cx="9905695" cy="54864"/>
-          </a:xfrm>
-          <a:prstGeom prst="rect">
-            <a:avLst/>
-          </a:prstGeom>
-          <a:solidFill>
-            <a:srgbClr val="FF6600"/>
-          </a:solidFill>
-          <a:ln/>
-        </p:spPr>
-      </p:sp>
-      <p:sp>
-        <p:nvSpPr>
-          <p:cNvPr id="16" name="Text 13"/>
-          <p:cNvSpPr txBox="1"/>
-          <p:nvPr/>
-        </p:nvSpPr>
-        <p:spPr>
-          <a:xfrm>
-            <a:off x="8991295" y="6510528"/>
-            <a:ext cx="731520" cy="256032"/>
-          </a:xfrm>
-          <a:prstGeom prst="rect">
-            <a:avLst/>
-          </a:prstGeom>
-          <a:noFill/>
-          <a:ln/>
-        </p:spPr>
-        <p:txBody>
-          <a:bodyPr wrap="square" lIns="0" tIns="0" rIns="0" bIns="0" rtlCol="0" anchor="ctr"/>
-          <a:lstStyle/>
-          <a:p>
-            <a:pPr algn="r" indent="0" marL="0">
-              <a:buNone/>
-            </a:pPr>
-            <a:r>
-              <a:rPr lang="en-US" sz="900" dirty="0">
-                <a:solidFill>
-                  <a:srgbClr val="848685"/>
-                </a:solidFill>
-                <a:latin typeface="Arial" pitchFamily="34" charset="0"/>
-                <a:ea typeface="Arial" pitchFamily="34" charset="-122"/>
-                <a:cs typeface="Arial" pitchFamily="34" charset="-120"/>
-              </a:rPr>
-              <a:t>9/10</a:t>
+              <a:t>7/7</a:t>
             </a:r>
             <a:endParaRPr lang="en-US" sz="900" dirty="0"/>
           </a:p>

</xml_diff>